<commit_message>
OCR benchmark deck V2: 9-slide revision, AOAI replaces the rule layer
- New slide 4: side-by-side pipelines showing Azure OpenAI taking the
  place of the hand-written extraction rules.
- Narrative shifted from cost to accuracy, effort to reach it and
  ongoing maintenance; comparison slide rebuilt around those rows.
- Bilingual, Chinese medicine and vet invoice examples kept, reframed
  as evidence for the rules-vs-AI extraction layer.
- Conclusion follows the agreed wording; next step is an unseen test.
- Archive the 8-slide revision in archive/v2_8slides/.
- check_deck_v2.py expects 9 slides.

No OCR, scoring or Azure calls; results, rules, prompt unchanged.

Co-Authored-By: Claude Opus 5.5 <noreply@anthropic.com>
</commit_message>
<xml_diff>
--- a/ppt/ocr_benchmark/current/OCR_Benchmark_V2.pptx
+++ b/ppt/ocr_benchmark/current/OCR_Benchmark_V2.pptx
@@ -19,6 +19,7 @@
     <p:sldId id="261" r:id="rId13"/>
     <p:sldId id="262" r:id="rId14"/>
     <p:sldId id="263" r:id="rId15"/>
+    <p:sldId id="264" r:id="rId16"/>
   </p:sldIdLst>
   <p:sldSz cx="12192000" cy="6858000"/>
   <p:notesSz cx="6858000" cy="9144000"/>
@@ -700,7 +701,7 @@
           <a:lstStyle/>
           <a:p>
             <a:r>
-              <a:t>Objective: compare open-source OCR plus extraction rules with Azure Document Intelligence plus Azure OpenAI for extracting six fields from medical receipts, on accuracy, speed, cost drivers and maintenance. Source: python/receipt_ocr_benchmark/results/v2/scores_improved (summary.csv, detail.csv) and extraction JSON.</a:t>
+              <a:t>Objective: compare open-source OCR plus extraction rules with Azure Document Intelligence plus Azure OpenAI for extracting six fields from medical receipts: accuracy, the manual effort needed to reach it, and the ongoing maintenance effort. Source: python/receipt_ocr_benchmark/results/v2/scores_improved (summary.csv, detail.csv) and extraction JSON.</a:t>
             </a:r>
           </a:p>
         </p:txBody>
@@ -770,7 +771,7 @@
           <a:lstStyle/>
           <a:p>
             <a:r>
-              <a:t>Receipts: English, bilingual and Traditional Chinese layouts. Fields: doctor, registration number, patient, receipt number, service date, total. 51 fields were present on the receipts and scored. Step 1 (text recognition, OCR) turns the photo into text; step 2 (field extraction) picks the six values from that text. Source: python/receipt_ocr_benchmark/results/v2/scores_improved (summary.csv, detail.csv) and extraction JSON.</a:t>
+              <a:t>Receipts: English, bilingual and Traditional Chinese layouts. Fields: doctor, registration number, patient, receipt number, service date, total. 51 fields were present on the receipts and scored. Step 1 (text recognition, OCR) turns the photo into text; step 2 (field extraction) picks the six values from that text, either with hand-written rules or with Azure OpenAI. Source: python/receipt_ocr_benchmark/results/v2/scores_improved (summary.csv, detail.csv) and extraction JSON.</a:t>
             </a:r>
           </a:p>
         </p:txBody>
@@ -910,7 +911,7 @@
           <a:lstStyle/>
           <a:p>
             <a:r>
-              <a:t>Receipt 8 (medical centre). Both OCR engines read the patient name and the doctor's name (checked in the raw OCR). The original rules matched 'Patient' and took the Chinese half of the label, 病人, as the name. The improved rules recognise bilingual labels. AOAI read the fields correctly with its unchanged prompt. Values: rules on PaddleOCR Light text; detail.csv, checked against the extraction JSON. Source: python/receipt_ocr_benchmark/results/v2/scores_improved (summary.csv, detail.csv) and extraction JSON.</a:t>
+              <a:t>Rule-based pipeline: OCR text, then hand-written extraction rules. To reach 88.2% the rules were rewritten after reviewing the errors on these 9 receipts (label phrases 69 to 225). AI pipeline: the same kind of OCR text is passed to Azure OpenAI (gpt-5-mini) with one fixed prompt, which was not changed for these receipts, and it reached 88.2%. So on this benchmark the model did the job the rules were tuned to do. It still made mistakes, and it has not been tested on a large set of unseen receipts. Source: python/receipt_ocr_benchmark/results/v2/scores_improved (summary.csv, detail.csv) and extraction JSON.</a:t>
             </a:r>
           </a:p>
         </p:txBody>
@@ -980,7 +981,7 @@
           <a:lstStyle/>
           <a:p>
             <a:r>
-              <a:t>Receipt 4 (Chinese medicine): the OCR read every value, but the original rules only knew English labels (0 of 6 fields). After adding Chinese labels: 6 of 6. The label vocabulary grew from 69 to 225 phrases (counted in extraction_general.py and extraction_improved.py). On the vet invoice (receipt 9) the original rules found receipt number 369303; after the changes they return 380048. Whether AOAI needs less maintenance on new layouts has not been tested yet. Source: python/receipt_ocr_benchmark/results/v2/scores_improved (summary.csv, detail.csv) and extraction JSON.</a:t>
+              <a:t>Receipt 8 (medical centre). Both OCR engines read the patient name and the doctor's name (checked in the raw OCR). The original rules matched 'Patient' and took the Chinese half of the label, 病人, as the name. The improved rules needed bilingual labels added by hand. AOAI read the fields correctly with its unchanged prompt (6 of 6 fields on this receipt). Values: rules on PaddleOCR Light text; detail.csv, checked against the extraction JSON. Source: python/receipt_ocr_benchmark/results/v2/scores_improved (summary.csv, detail.csv) and extraction JSON.</a:t>
             </a:r>
           </a:p>
         </p:txBody>
@@ -1050,7 +1051,7 @@
           <a:lstStyle/>
           <a:p>
             <a:r>
-              <a:t>Receipt 9 (vet invoice). The improved rules now take the payment table's 'Receipt #' (380048) instead of the invoice number. Both OCR engines read 'FPatient:' (a stray mark merged into the label), so no rule matched the patient label; AOAI still found the name. AOAI chose the sub total (1361.50) instead of the total (1361.00). Values: detail.csv, checked against the extraction JSON. Source: python/receipt_ocr_benchmark/results/v2/scores_improved (summary.csv, detail.csv) and extraction JSON.</a:t>
+              <a:t>Receipt 4 (Chinese medicine): the OCR read every value, but the original rules only knew English labels (0 of 6 fields). After adding Chinese labels: 6 of 6. DI + AOAI: 6 of 6 with no prompt change. The label vocabulary grew from 69 to 225 phrases (counted in extraction_general.py and extraction_improved.py). On the vet invoice (receipt 9) the original rules found receipt number 369303; after the changes they return 380048. Whether AOAI needs less maintenance on new layouts has not been tested yet. Source: python/receipt_ocr_benchmark/results/v2/scores_improved (summary.csv, detail.csv) and extraction JSON.</a:t>
             </a:r>
           </a:p>
         </p:txBody>
@@ -1120,7 +1121,7 @@
           <a:lstStyle/>
           <a:p>
             <a:r>
-              <a:t>Accuracy and time from summary.csv. AOAI tokens are averages over the 9 receipts. Prices for compute, Document Intelligence pages and gpt-5-mini tokens are not yet confirmed. Source: python/receipt_ocr_benchmark/results/v2/scores_improved (summary.csv, detail.csv) and extraction JSON.</a:t>
+              <a:t>Receipt 9 (vet invoice). The improved rules now take the payment table's 'Receipt #' (380048) instead of the invoice number. Both OCR engines read 'FPatient:' (a stray mark merged into the label), so no rule matched the patient label; AOAI still found the name. AOAI chose the sub total (1361.50) instead of the total (1361.00). Across all 9 receipts AOAI got 6 of 51 fields wrong. Values: detail.csv, checked against the extraction JSON. Source: python/receipt_ocr_benchmark/results/v2/scores_improved (summary.csv, detail.csv) and extraction JSON.</a:t>
             </a:r>
           </a:p>
         </p:txBody>
@@ -1190,7 +1191,77 @@
           <a:lstStyle/>
           <a:p>
             <a:r>
-              <a:t>Main finding: PaddleOCR Light reached 88.2% and Azure DI 86.3% only after the rules were rewritten for these receipts; Azure DI + AOAI reached 88.2% with no change. The benchmark is small (9 receipts) and the improved rules were tuned on it, so this is not a production decision. Source: python/receipt_ocr_benchmark/results/v2/scores_improved (summary.csv, detail.csv) and extraction JSON.</a:t>
+              <a:t>Accuracy and time from summary.csv. The improved rules were tuned on these 9 receipts; the AOAI prompt was not changed. Lower maintenance for AOAI is the key implication of this benchmark, not a result proven in production. Running cost: DI page plus about 602 input / 263 output gpt-5-mini tokens per receipt; prices are not yet confirmed. Source: python/receipt_ocr_benchmark/results/v2/scores_improved (summary.csv, detail.csv) and extraction JSON.</a:t>
+            </a:r>
+          </a:p>
+        </p:txBody>
+      </p:sp>
+      <p:sp>
+        <p:nvSpPr>
+          <p:cNvPr id="4" name="Slide Number Placeholder 3"/>
+          <p:cNvSpPr>
+            <a:spLocks noGrp="1"/>
+          </p:cNvSpPr>
+          <p:nvPr>
+            <p:ph type="sldNum" idx="5" sz="quarter"/>
+          </p:nvPr>
+        </p:nvSpPr>
+        <p:spPr/>
+      </p:sp>
+    </p:spTree>
+  </p:cSld>
+  <p:clrMapOvr>
+    <a:masterClrMapping/>
+  </p:clrMapOvr>
+</p:notes>
+</file>
+
+<file path=ppt/notesSlides/notesSlide9.xml><?xml version="1.0" encoding="utf-8"?>
+<p:notes xmlns:a="http://schemas.openxmlformats.org/drawingml/2006/main" xmlns:p="http://schemas.openxmlformats.org/presentationml/2006/main" xmlns:r="http://schemas.openxmlformats.org/officeDocument/2006/relationships">
+  <p:cSld>
+    <p:spTree>
+      <p:nvGrpSpPr>
+        <p:cNvPr id="1" name=""/>
+        <p:cNvGrpSpPr/>
+        <p:nvPr/>
+      </p:nvGrpSpPr>
+      <p:grpSpPr>
+        <a:xfrm>
+          <a:off x="0" y="0"/>
+          <a:ext cx="0" cy="0"/>
+          <a:chOff x="0" y="0"/>
+          <a:chExt cx="0" cy="0"/>
+        </a:xfrm>
+      </p:grpSpPr>
+      <p:sp>
+        <p:nvSpPr>
+          <p:cNvPr id="2" name="Slide Image Placeholder 1"/>
+          <p:cNvSpPr>
+            <a:spLocks noGrp="1"/>
+          </p:cNvSpPr>
+          <p:nvPr>
+            <p:ph type="sldImg" idx="2"/>
+          </p:nvPr>
+        </p:nvSpPr>
+        <p:spPr/>
+      </p:sp>
+      <p:sp>
+        <p:nvSpPr>
+          <p:cNvPr id="3" name="Notes Placeholder 2"/>
+          <p:cNvSpPr>
+            <a:spLocks noGrp="1"/>
+          </p:cNvSpPr>
+          <p:nvPr>
+            <p:ph type="body" idx="3" sz="quarter"/>
+          </p:nvPr>
+        </p:nvSpPr>
+        <p:spPr/>
+        <p:txBody>
+          <a:bodyPr/>
+          <a:lstStyle/>
+          <a:p>
+            <a:r>
+              <a:t>Main finding: PaddleOCR Light reached 88.2% (and Azure DI 86.3%) only after the rules were rewritten for these receipts; Azure DI + AOAI reached 88.2% with no change to its prompt. The benchmark is small (9 receipts) and the improved rules were tuned on it, so this is not a production decision. Source: python/receipt_ocr_benchmark/results/v2/scores_improved (summary.csv, detail.csv) and extraction JSON.</a:t>
             </a:r>
           </a:p>
         </p:txBody>
@@ -5854,7 +5925,7 @@
                 <a:latin typeface="Arial"/>
                 <a:ea typeface="Microsoft JhengHei"/>
               </a:rPr>
-              <a:t>Can open-source OCR with rules match Azure AI at extracting receipt fields?</a:t>
+              <a:t>Can Azure OpenAI replace hand-written extraction rules?</a:t>
             </a:r>
           </a:p>
           <a:p>
@@ -6897,7 +6968,7 @@
                 <a:latin typeface="Arial"/>
                 <a:ea typeface="Microsoft JhengHei"/>
               </a:rPr>
-              <a:t>Results: Field Accuracy and Speed</a:t>
+              <a:t>Results: Same Accuracy, Different Effort</a:t>
             </a:r>
           </a:p>
         </p:txBody>
@@ -6984,7 +7055,7 @@
                 <a:latin typeface="Arial"/>
                 <a:ea typeface="Microsoft JhengHei"/>
               </a:rPr>
-              <a:t>Improving the rules raised PaddleOCR Light from 37.3% to 88.2%. AOAI reached 88.2% without changes.</a:t>
+              <a:t>Rules reached 88.2% only after manual tuning. DI + AOAI reached 88.2% with its prompt unchanged.</a:t>
             </a:r>
           </a:p>
         </p:txBody>
@@ -7758,7 +7829,7 @@
                           <a:latin typeface="Arial"/>
                           <a:ea typeface="Microsoft JhengHei"/>
                         </a:rPr>
-                        <a:t>Not applicable (prompt unchanged)</a:t>
+                        <a:t>No rules (prompt unchanged)</a:t>
                       </a:r>
                     </a:p>
                   </a:txBody>
@@ -7910,7 +7981,7 @@
                 <a:latin typeface="Arial"/>
                 <a:ea typeface="Microsoft JhengHei"/>
               </a:rPr>
-              <a:t>Why Accuracy Improved: The Rules, Not the OCR</a:t>
+              <a:t>AOAI Replaces the Manual Rule Layer</a:t>
             </a:r>
           </a:p>
         </p:txBody>
@@ -7997,7 +8068,909 @@
                 <a:latin typeface="Arial"/>
                 <a:ea typeface="Microsoft JhengHei"/>
               </a:rPr>
-              <a:t>The OCR read the text correctly. The original rules picked the wrong text.</a:t>
+              <a:t>Both pipelines read the text the same way. Only the step that finds the fields changes.</a:t>
+            </a:r>
+          </a:p>
+        </p:txBody>
+      </p:sp>
+      <p:sp>
+        <p:nvSpPr>
+          <p:cNvPr id="12" name="TextBox 11"/>
+          <p:cNvSpPr txBox="1"/>
+          <p:nvPr/>
+        </p:nvSpPr>
+        <p:spPr>
+          <a:xfrm>
+            <a:off x="356616" y="1828800"/>
+            <a:ext cx="2514600" cy="1097280"/>
+          </a:xfrm>
+          <a:prstGeom prst="rect">
+            <a:avLst/>
+          </a:prstGeom>
+          <a:noFill/>
+        </p:spPr>
+        <p:txBody>
+          <a:bodyPr wrap="square" lIns="0" rIns="0" tIns="0" bIns="0" anchor="ctr"/>
+          <a:lstStyle/>
+          <a:p>
+            <a:pPr marL="0" indent="0" algn="l">
+              <a:spcAft>
+                <a:spcPts val="200"/>
+              </a:spcAft>
+              <a:buNone/>
+            </a:pPr>
+            <a:r>
+              <a:rPr sz="1800" b="1" i="0">
+                <a:solidFill>
+                  <a:srgbClr val="333D47"/>
+                </a:solidFill>
+                <a:latin typeface="Arial"/>
+                <a:ea typeface="Microsoft JhengHei"/>
+              </a:rPr>
+              <a:t>Rule-based</a:t>
+            </a:r>
+          </a:p>
+          <a:p>
+            <a:pPr marL="0" indent="0" algn="l">
+              <a:spcAft>
+                <a:spcPts val="600"/>
+              </a:spcAft>
+              <a:buNone/>
+            </a:pPr>
+            <a:r>
+              <a:rPr sz="1300" b="0" i="0">
+                <a:solidFill>
+                  <a:srgbClr val="5F6770"/>
+                </a:solidFill>
+                <a:latin typeface="Arial"/>
+                <a:ea typeface="Microsoft JhengHei"/>
+              </a:rPr>
+              <a:t>PaddleOCR Light + improved rules</a:t>
+            </a:r>
+          </a:p>
+          <a:p>
+            <a:pPr marL="0" indent="0" algn="l">
+              <a:spcAft>
+                <a:spcPts val="0"/>
+              </a:spcAft>
+              <a:buNone/>
+            </a:pPr>
+            <a:r>
+              <a:rPr sz="1500" b="1" i="0">
+                <a:solidFill>
+                  <a:srgbClr val="D31145"/>
+                </a:solidFill>
+                <a:latin typeface="Arial"/>
+                <a:ea typeface="Microsoft JhengHei"/>
+              </a:rPr>
+              <a:t>88.2% after tuning</a:t>
+            </a:r>
+          </a:p>
+        </p:txBody>
+      </p:sp>
+      <p:sp>
+        <p:nvSpPr>
+          <p:cNvPr id="13" name="Rectangle 12"/>
+          <p:cNvSpPr/>
+          <p:nvPr/>
+        </p:nvSpPr>
+        <p:spPr>
+          <a:xfrm>
+            <a:off x="3017520" y="1828800"/>
+            <a:ext cx="2560320" cy="1097280"/>
+          </a:xfrm>
+          <a:prstGeom prst="rect">
+            <a:avLst/>
+          </a:prstGeom>
+          <a:solidFill>
+            <a:srgbClr val="F2F2F2"/>
+          </a:solidFill>
+          <a:ln>
+            <a:noFill/>
+          </a:ln>
+        </p:spPr>
+        <p:txBody>
+          <a:bodyPr rtlCol="0" anchor="ctr" wrap="square" lIns="146304" rIns="146304" tIns="109728" bIns="109728"/>
+          <a:lstStyle/>
+          <a:p>
+            <a:pPr algn="l" marL="0" indent="0">
+              <a:spcAft>
+                <a:spcPts val="400"/>
+              </a:spcAft>
+              <a:buNone/>
+            </a:pPr>
+            <a:r>
+              <a:rPr sz="1600" b="1" i="0">
+                <a:solidFill>
+                  <a:srgbClr val="333D47"/>
+                </a:solidFill>
+                <a:latin typeface="Arial"/>
+                <a:ea typeface="Microsoft JhengHei"/>
+              </a:rPr>
+              <a:t>Read text (OCR)</a:t>
+            </a:r>
+          </a:p>
+          <a:p>
+            <a:pPr marL="0" indent="0" algn="l">
+              <a:spcAft>
+                <a:spcPts val="0"/>
+              </a:spcAft>
+              <a:buNone/>
+            </a:pPr>
+            <a:r>
+              <a:rPr sz="1250" b="0" i="0">
+                <a:solidFill>
+                  <a:srgbClr val="5F6770"/>
+                </a:solidFill>
+                <a:latin typeface="Arial"/>
+                <a:ea typeface="Microsoft JhengHei"/>
+              </a:rPr>
+              <a:t>PaddleOCR Light</a:t>
+            </a:r>
+          </a:p>
+        </p:txBody>
+      </p:sp>
+      <p:sp>
+        <p:nvSpPr>
+          <p:cNvPr id="14" name="Rectangle 13"/>
+          <p:cNvSpPr/>
+          <p:nvPr/>
+        </p:nvSpPr>
+        <p:spPr>
+          <a:xfrm>
+            <a:off x="6126479" y="1828800"/>
+            <a:ext cx="2560320" cy="1097280"/>
+          </a:xfrm>
+          <a:prstGeom prst="rect">
+            <a:avLst/>
+          </a:prstGeom>
+          <a:solidFill>
+            <a:srgbClr val="FFFFFF"/>
+          </a:solidFill>
+          <a:ln w="25400">
+            <a:solidFill>
+              <a:srgbClr val="D31145"/>
+            </a:solidFill>
+          </a:ln>
+        </p:spPr>
+        <p:txBody>
+          <a:bodyPr rtlCol="0" anchor="ctr" wrap="square" lIns="146304" rIns="146304" tIns="109728" bIns="109728"/>
+          <a:lstStyle/>
+          <a:p>
+            <a:pPr algn="l" marL="0" indent="0">
+              <a:spcAft>
+                <a:spcPts val="400"/>
+              </a:spcAft>
+              <a:buNone/>
+            </a:pPr>
+            <a:r>
+              <a:rPr sz="1600" b="1" i="0">
+                <a:solidFill>
+                  <a:srgbClr val="D31145"/>
+                </a:solidFill>
+                <a:latin typeface="Arial"/>
+                <a:ea typeface="Microsoft JhengHei"/>
+              </a:rPr>
+              <a:t>Extraction rules</a:t>
+            </a:r>
+          </a:p>
+          <a:p>
+            <a:pPr marL="0" indent="0" algn="l">
+              <a:spcAft>
+                <a:spcPts val="0"/>
+              </a:spcAft>
+              <a:buNone/>
+            </a:pPr>
+            <a:r>
+              <a:rPr sz="1250" b="0" i="0">
+                <a:solidFill>
+                  <a:srgbClr val="333D47"/>
+                </a:solidFill>
+                <a:latin typeface="Arial"/>
+                <a:ea typeface="Microsoft JhengHei"/>
+              </a:rPr>
+              <a:t>written and updated by hand (69 → 225 label phrases)</a:t>
+            </a:r>
+          </a:p>
+        </p:txBody>
+      </p:sp>
+      <p:sp>
+        <p:nvSpPr>
+          <p:cNvPr id="15" name="Right Arrow 14"/>
+          <p:cNvSpPr/>
+          <p:nvPr/>
+        </p:nvSpPr>
+        <p:spPr>
+          <a:xfrm>
+            <a:off x="5705855" y="2240280"/>
+            <a:ext cx="292607" cy="274320"/>
+          </a:xfrm>
+          <a:prstGeom prst="rightArrow">
+            <a:avLst/>
+          </a:prstGeom>
+          <a:solidFill>
+            <a:srgbClr val="5F6770"/>
+          </a:solidFill>
+          <a:ln>
+            <a:noFill/>
+          </a:ln>
+        </p:spPr>
+        <p:txBody>
+          <a:bodyPr rtlCol="0" anchor="ctr"/>
+          <a:lstStyle/>
+          <a:p>
+            <a:pPr algn="ctr"/>
+          </a:p>
+        </p:txBody>
+      </p:sp>
+      <p:sp>
+        <p:nvSpPr>
+          <p:cNvPr id="16" name="Rectangle 15"/>
+          <p:cNvSpPr/>
+          <p:nvPr/>
+        </p:nvSpPr>
+        <p:spPr>
+          <a:xfrm>
+            <a:off x="9235440" y="1828800"/>
+            <a:ext cx="2560320" cy="1097280"/>
+          </a:xfrm>
+          <a:prstGeom prst="rect">
+            <a:avLst/>
+          </a:prstGeom>
+          <a:solidFill>
+            <a:srgbClr val="F2F2F2"/>
+          </a:solidFill>
+          <a:ln>
+            <a:noFill/>
+          </a:ln>
+        </p:spPr>
+        <p:txBody>
+          <a:bodyPr rtlCol="0" anchor="ctr" wrap="square" lIns="146304" rIns="146304" tIns="109728" bIns="109728"/>
+          <a:lstStyle/>
+          <a:p>
+            <a:pPr algn="l" marL="0" indent="0">
+              <a:spcAft>
+                <a:spcPts val="400"/>
+              </a:spcAft>
+              <a:buNone/>
+            </a:pPr>
+            <a:r>
+              <a:rPr sz="1600" b="1" i="0">
+                <a:solidFill>
+                  <a:srgbClr val="333D47"/>
+                </a:solidFill>
+                <a:latin typeface="Arial"/>
+                <a:ea typeface="Microsoft JhengHei"/>
+              </a:rPr>
+              <a:t>6 fields</a:t>
+            </a:r>
+          </a:p>
+          <a:p>
+            <a:pPr marL="0" indent="0" algn="l">
+              <a:spcAft>
+                <a:spcPts val="0"/>
+              </a:spcAft>
+              <a:buNone/>
+            </a:pPr>
+            <a:r>
+              <a:rPr sz="1250" b="0" i="0">
+                <a:solidFill>
+                  <a:srgbClr val="5F6770"/>
+                </a:solidFill>
+                <a:latin typeface="Arial"/>
+                <a:ea typeface="Microsoft JhengHei"/>
+              </a:rPr>
+              <a:t>doctor, patient, total, …</a:t>
+            </a:r>
+          </a:p>
+        </p:txBody>
+      </p:sp>
+      <p:sp>
+        <p:nvSpPr>
+          <p:cNvPr id="17" name="Right Arrow 16"/>
+          <p:cNvSpPr/>
+          <p:nvPr/>
+        </p:nvSpPr>
+        <p:spPr>
+          <a:xfrm>
+            <a:off x="8814816" y="2240280"/>
+            <a:ext cx="292607" cy="274320"/>
+          </a:xfrm>
+          <a:prstGeom prst="rightArrow">
+            <a:avLst/>
+          </a:prstGeom>
+          <a:solidFill>
+            <a:srgbClr val="5F6770"/>
+          </a:solidFill>
+          <a:ln>
+            <a:noFill/>
+          </a:ln>
+        </p:spPr>
+        <p:txBody>
+          <a:bodyPr rtlCol="0" anchor="ctr"/>
+          <a:lstStyle/>
+          <a:p>
+            <a:pPr algn="ctr"/>
+          </a:p>
+        </p:txBody>
+      </p:sp>
+      <p:sp>
+        <p:nvSpPr>
+          <p:cNvPr id="18" name="TextBox 17"/>
+          <p:cNvSpPr txBox="1"/>
+          <p:nvPr/>
+        </p:nvSpPr>
+        <p:spPr>
+          <a:xfrm>
+            <a:off x="356616" y="3611880"/>
+            <a:ext cx="2514600" cy="1097280"/>
+          </a:xfrm>
+          <a:prstGeom prst="rect">
+            <a:avLst/>
+          </a:prstGeom>
+          <a:noFill/>
+        </p:spPr>
+        <p:txBody>
+          <a:bodyPr wrap="square" lIns="0" rIns="0" tIns="0" bIns="0" anchor="ctr"/>
+          <a:lstStyle/>
+          <a:p>
+            <a:pPr marL="0" indent="0" algn="l">
+              <a:spcAft>
+                <a:spcPts val="200"/>
+              </a:spcAft>
+              <a:buNone/>
+            </a:pPr>
+            <a:r>
+              <a:rPr sz="1800" b="1" i="0">
+                <a:solidFill>
+                  <a:srgbClr val="333D47"/>
+                </a:solidFill>
+                <a:latin typeface="Arial"/>
+                <a:ea typeface="Microsoft JhengHei"/>
+              </a:rPr>
+              <a:t>AI extraction</a:t>
+            </a:r>
+          </a:p>
+          <a:p>
+            <a:pPr marL="0" indent="0" algn="l">
+              <a:spcAft>
+                <a:spcPts val="600"/>
+              </a:spcAft>
+              <a:buNone/>
+            </a:pPr>
+            <a:r>
+              <a:rPr sz="1300" b="0" i="0">
+                <a:solidFill>
+                  <a:srgbClr val="5F6770"/>
+                </a:solidFill>
+                <a:latin typeface="Arial"/>
+                <a:ea typeface="Microsoft JhengHei"/>
+              </a:rPr>
+              <a:t>Azure DI + AOAI</a:t>
+            </a:r>
+          </a:p>
+          <a:p>
+            <a:pPr marL="0" indent="0" algn="l">
+              <a:spcAft>
+                <a:spcPts val="0"/>
+              </a:spcAft>
+              <a:buNone/>
+            </a:pPr>
+            <a:r>
+              <a:rPr sz="1500" b="1" i="0">
+                <a:solidFill>
+                  <a:srgbClr val="D31145"/>
+                </a:solidFill>
+                <a:latin typeface="Arial"/>
+                <a:ea typeface="Microsoft JhengHei"/>
+              </a:rPr>
+              <a:t>88.2%, prompt unchanged</a:t>
+            </a:r>
+          </a:p>
+        </p:txBody>
+      </p:sp>
+      <p:sp>
+        <p:nvSpPr>
+          <p:cNvPr id="19" name="Rectangle 18"/>
+          <p:cNvSpPr/>
+          <p:nvPr/>
+        </p:nvSpPr>
+        <p:spPr>
+          <a:xfrm>
+            <a:off x="3017520" y="3611880"/>
+            <a:ext cx="2560320" cy="1097280"/>
+          </a:xfrm>
+          <a:prstGeom prst="rect">
+            <a:avLst/>
+          </a:prstGeom>
+          <a:solidFill>
+            <a:srgbClr val="F2F2F2"/>
+          </a:solidFill>
+          <a:ln>
+            <a:noFill/>
+          </a:ln>
+        </p:spPr>
+        <p:txBody>
+          <a:bodyPr rtlCol="0" anchor="ctr" wrap="square" lIns="146304" rIns="146304" tIns="109728" bIns="109728"/>
+          <a:lstStyle/>
+          <a:p>
+            <a:pPr algn="l" marL="0" indent="0">
+              <a:spcAft>
+                <a:spcPts val="400"/>
+              </a:spcAft>
+              <a:buNone/>
+            </a:pPr>
+            <a:r>
+              <a:rPr sz="1600" b="1" i="0">
+                <a:solidFill>
+                  <a:srgbClr val="333D47"/>
+                </a:solidFill>
+                <a:latin typeface="Arial"/>
+                <a:ea typeface="Microsoft JhengHei"/>
+              </a:rPr>
+              <a:t>Read text (OCR)</a:t>
+            </a:r>
+          </a:p>
+          <a:p>
+            <a:pPr marL="0" indent="0" algn="l">
+              <a:spcAft>
+                <a:spcPts val="0"/>
+              </a:spcAft>
+              <a:buNone/>
+            </a:pPr>
+            <a:r>
+              <a:rPr sz="1250" b="0" i="0">
+                <a:solidFill>
+                  <a:srgbClr val="5F6770"/>
+                </a:solidFill>
+                <a:latin typeface="Arial"/>
+                <a:ea typeface="Microsoft JhengHei"/>
+              </a:rPr>
+              <a:t>Azure DI</a:t>
+            </a:r>
+          </a:p>
+        </p:txBody>
+      </p:sp>
+      <p:sp>
+        <p:nvSpPr>
+          <p:cNvPr id="20" name="Rectangle 19"/>
+          <p:cNvSpPr/>
+          <p:nvPr/>
+        </p:nvSpPr>
+        <p:spPr>
+          <a:xfrm>
+            <a:off x="6126479" y="3611880"/>
+            <a:ext cx="2560320" cy="1097280"/>
+          </a:xfrm>
+          <a:prstGeom prst="rect">
+            <a:avLst/>
+          </a:prstGeom>
+          <a:solidFill>
+            <a:srgbClr val="FFFFFF"/>
+          </a:solidFill>
+          <a:ln w="25400">
+            <a:solidFill>
+              <a:srgbClr val="D31145"/>
+            </a:solidFill>
+          </a:ln>
+        </p:spPr>
+        <p:txBody>
+          <a:bodyPr rtlCol="0" anchor="ctr" wrap="square" lIns="146304" rIns="146304" tIns="109728" bIns="109728"/>
+          <a:lstStyle/>
+          <a:p>
+            <a:pPr algn="l" marL="0" indent="0">
+              <a:spcAft>
+                <a:spcPts val="400"/>
+              </a:spcAft>
+              <a:buNone/>
+            </a:pPr>
+            <a:r>
+              <a:rPr sz="1600" b="1" i="0">
+                <a:solidFill>
+                  <a:srgbClr val="D31145"/>
+                </a:solidFill>
+                <a:latin typeface="Arial"/>
+                <a:ea typeface="Microsoft JhengHei"/>
+              </a:rPr>
+              <a:t>Azure OpenAI</a:t>
+            </a:r>
+          </a:p>
+          <a:p>
+            <a:pPr marL="0" indent="0" algn="l">
+              <a:spcAft>
+                <a:spcPts val="0"/>
+              </a:spcAft>
+              <a:buNone/>
+            </a:pPr>
+            <a:r>
+              <a:rPr sz="1250" b="0" i="0">
+                <a:solidFill>
+                  <a:srgbClr val="333D47"/>
+                </a:solidFill>
+                <a:latin typeface="Arial"/>
+                <a:ea typeface="Microsoft JhengHei"/>
+              </a:rPr>
+              <a:t>one fixed prompt, not changed for these receipts</a:t>
+            </a:r>
+          </a:p>
+        </p:txBody>
+      </p:sp>
+      <p:sp>
+        <p:nvSpPr>
+          <p:cNvPr id="21" name="Right Arrow 20"/>
+          <p:cNvSpPr/>
+          <p:nvPr/>
+        </p:nvSpPr>
+        <p:spPr>
+          <a:xfrm>
+            <a:off x="5705855" y="4023359"/>
+            <a:ext cx="292607" cy="274320"/>
+          </a:xfrm>
+          <a:prstGeom prst="rightArrow">
+            <a:avLst/>
+          </a:prstGeom>
+          <a:solidFill>
+            <a:srgbClr val="5F6770"/>
+          </a:solidFill>
+          <a:ln>
+            <a:noFill/>
+          </a:ln>
+        </p:spPr>
+        <p:txBody>
+          <a:bodyPr rtlCol="0" anchor="ctr"/>
+          <a:lstStyle/>
+          <a:p>
+            <a:pPr algn="ctr"/>
+          </a:p>
+        </p:txBody>
+      </p:sp>
+      <p:sp>
+        <p:nvSpPr>
+          <p:cNvPr id="22" name="Rectangle 21"/>
+          <p:cNvSpPr/>
+          <p:nvPr/>
+        </p:nvSpPr>
+        <p:spPr>
+          <a:xfrm>
+            <a:off x="9235440" y="3611880"/>
+            <a:ext cx="2560320" cy="1097280"/>
+          </a:xfrm>
+          <a:prstGeom prst="rect">
+            <a:avLst/>
+          </a:prstGeom>
+          <a:solidFill>
+            <a:srgbClr val="F2F2F2"/>
+          </a:solidFill>
+          <a:ln>
+            <a:noFill/>
+          </a:ln>
+        </p:spPr>
+        <p:txBody>
+          <a:bodyPr rtlCol="0" anchor="ctr" wrap="square" lIns="146304" rIns="146304" tIns="109728" bIns="109728"/>
+          <a:lstStyle/>
+          <a:p>
+            <a:pPr algn="l" marL="0" indent="0">
+              <a:spcAft>
+                <a:spcPts val="400"/>
+              </a:spcAft>
+              <a:buNone/>
+            </a:pPr>
+            <a:r>
+              <a:rPr sz="1600" b="1" i="0">
+                <a:solidFill>
+                  <a:srgbClr val="333D47"/>
+                </a:solidFill>
+                <a:latin typeface="Arial"/>
+                <a:ea typeface="Microsoft JhengHei"/>
+              </a:rPr>
+              <a:t>6 fields</a:t>
+            </a:r>
+          </a:p>
+          <a:p>
+            <a:pPr marL="0" indent="0" algn="l">
+              <a:spcAft>
+                <a:spcPts val="0"/>
+              </a:spcAft>
+              <a:buNone/>
+            </a:pPr>
+            <a:r>
+              <a:rPr sz="1250" b="0" i="0">
+                <a:solidFill>
+                  <a:srgbClr val="5F6770"/>
+                </a:solidFill>
+                <a:latin typeface="Arial"/>
+                <a:ea typeface="Microsoft JhengHei"/>
+              </a:rPr>
+              <a:t>doctor, patient, total, …</a:t>
+            </a:r>
+          </a:p>
+        </p:txBody>
+      </p:sp>
+      <p:sp>
+        <p:nvSpPr>
+          <p:cNvPr id="23" name="Right Arrow 22"/>
+          <p:cNvSpPr/>
+          <p:nvPr/>
+        </p:nvSpPr>
+        <p:spPr>
+          <a:xfrm>
+            <a:off x="8814816" y="4023359"/>
+            <a:ext cx="292607" cy="274320"/>
+          </a:xfrm>
+          <a:prstGeom prst="rightArrow">
+            <a:avLst/>
+          </a:prstGeom>
+          <a:solidFill>
+            <a:srgbClr val="5F6770"/>
+          </a:solidFill>
+          <a:ln>
+            <a:noFill/>
+          </a:ln>
+        </p:spPr>
+        <p:txBody>
+          <a:bodyPr rtlCol="0" anchor="ctr"/>
+          <a:lstStyle/>
+          <a:p>
+            <a:pPr algn="ctr"/>
+          </a:p>
+        </p:txBody>
+      </p:sp>
+      <p:sp>
+        <p:nvSpPr>
+          <p:cNvPr id="24" name="Down Arrow 23"/>
+          <p:cNvSpPr/>
+          <p:nvPr/>
+        </p:nvSpPr>
+        <p:spPr>
+          <a:xfrm>
+            <a:off x="7223759" y="3017520"/>
+            <a:ext cx="365760" cy="502920"/>
+          </a:xfrm>
+          <a:prstGeom prst="downArrow">
+            <a:avLst/>
+          </a:prstGeom>
+          <a:solidFill>
+            <a:srgbClr val="D31145"/>
+          </a:solidFill>
+          <a:ln>
+            <a:noFill/>
+          </a:ln>
+        </p:spPr>
+        <p:txBody>
+          <a:bodyPr rtlCol="0" anchor="ctr"/>
+          <a:lstStyle/>
+          <a:p>
+            <a:pPr algn="ctr"/>
+          </a:p>
+        </p:txBody>
+      </p:sp>
+      <p:sp>
+        <p:nvSpPr>
+          <p:cNvPr id="25" name="TextBox 24"/>
+          <p:cNvSpPr txBox="1"/>
+          <p:nvPr/>
+        </p:nvSpPr>
+        <p:spPr>
+          <a:xfrm>
+            <a:off x="7726679" y="3081528"/>
+            <a:ext cx="2377440" cy="365760"/>
+          </a:xfrm>
+          <a:prstGeom prst="rect">
+            <a:avLst/>
+          </a:prstGeom>
+          <a:noFill/>
+        </p:spPr>
+        <p:txBody>
+          <a:bodyPr wrap="square" lIns="0" rIns="0" tIns="0" bIns="0" anchor="t"/>
+          <a:lstStyle/>
+          <a:p>
+            <a:pPr marL="0" indent="0" algn="l">
+              <a:spcAft>
+                <a:spcPts val="0"/>
+              </a:spcAft>
+              <a:buNone/>
+            </a:pPr>
+            <a:r>
+              <a:rPr sz="1400" b="0" i="1">
+                <a:solidFill>
+                  <a:srgbClr val="D31145"/>
+                </a:solidFill>
+                <a:latin typeface="Arial"/>
+                <a:ea typeface="Microsoft JhengHei"/>
+              </a:rPr>
+              <a:t>replaced by</a:t>
+            </a:r>
+          </a:p>
+        </p:txBody>
+      </p:sp>
+      <p:sp>
+        <p:nvSpPr>
+          <p:cNvPr id="26" name="Rectangle 25"/>
+          <p:cNvSpPr/>
+          <p:nvPr/>
+        </p:nvSpPr>
+        <p:spPr>
+          <a:xfrm>
+            <a:off x="356616" y="4983480"/>
+            <a:ext cx="11475720" cy="685800"/>
+          </a:xfrm>
+          <a:prstGeom prst="rect">
+            <a:avLst/>
+          </a:prstGeom>
+          <a:solidFill>
+            <a:srgbClr val="F2F2F2"/>
+          </a:solidFill>
+          <a:ln>
+            <a:noFill/>
+          </a:ln>
+        </p:spPr>
+        <p:txBody>
+          <a:bodyPr rtlCol="0" anchor="ctr" wrap="square" lIns="228600" rIns="228600" tIns="109728" bIns="109728"/>
+          <a:lstStyle/>
+          <a:p>
+            <a:pPr algn="l" marL="0" indent="0">
+              <a:spcAft>
+                <a:spcPts val="0"/>
+              </a:spcAft>
+              <a:buNone/>
+            </a:pPr>
+            <a:r>
+              <a:rPr sz="1600" b="1" i="0">
+                <a:solidFill>
+                  <a:srgbClr val="333D47"/>
+                </a:solidFill>
+                <a:latin typeface="Arial"/>
+                <a:ea typeface="Microsoft JhengHei"/>
+              </a:rPr>
+              <a:t>AOAI replaces the manual rule layer. </a:t>
+            </a:r>
+            <a:r>
+              <a:rPr sz="1500" b="0" i="0">
+                <a:solidFill>
+                  <a:srgbClr val="333D47"/>
+                </a:solidFill>
+                <a:latin typeface="Arial"/>
+                <a:ea typeface="Microsoft JhengHei"/>
+              </a:rPr>
+              <a:t>It still makes mistakes (6 of 51 fields wrong) and has not yet been tested on a large set of unseen receipts.</a:t>
+            </a:r>
+          </a:p>
+        </p:txBody>
+      </p:sp>
+    </p:spTree>
+  </p:cSld>
+  <p:clrMapOvr>
+    <a:masterClrMapping/>
+  </p:clrMapOvr>
+</p:sld>
+</file>
+
+<file path=ppt/slides/slide5.xml><?xml version="1.0" encoding="utf-8"?>
+<p:sld xmlns:a="http://schemas.openxmlformats.org/drawingml/2006/main" xmlns:p="http://schemas.openxmlformats.org/presentationml/2006/main" xmlns:r="http://schemas.openxmlformats.org/officeDocument/2006/relationships">
+  <p:cSld>
+    <p:spTree>
+      <p:nvGrpSpPr>
+        <p:cNvPr id="1" name=""/>
+        <p:cNvGrpSpPr/>
+        <p:nvPr/>
+      </p:nvGrpSpPr>
+      <p:grpSpPr/>
+      <p:sp>
+        <p:nvSpPr>
+          <p:cNvPr id="4" name="Text Placeholder 3"/>
+          <p:cNvSpPr>
+            <a:spLocks noGrp="1"/>
+          </p:cNvSpPr>
+          <p:nvPr>
+            <p:ph type="body" idx="10" sz="quarter"/>
+          </p:nvPr>
+        </p:nvSpPr>
+        <p:spPr>
+          <a:xfrm>
+            <a:off x="356616" y="502920"/>
+            <a:ext cx="11155680" cy="566928"/>
+          </a:xfrm>
+        </p:spPr>
+        <p:txBody>
+          <a:bodyPr lIns="0"/>
+          <a:lstStyle/>
+          <a:p>
+            <a:r>
+              <a:rPr sz="2800" b="1">
+                <a:solidFill>
+                  <a:srgbClr val="333D47"/>
+                </a:solidFill>
+                <a:latin typeface="Arial"/>
+                <a:ea typeface="Microsoft JhengHei"/>
+              </a:rPr>
+              <a:t>Example 1: The OCR Was Right, the Rules Were Wrong</a:t>
+            </a:r>
+          </a:p>
+        </p:txBody>
+      </p:sp>
+      <p:sp>
+        <p:nvSpPr>
+          <p:cNvPr id="10" name="Slide Number Placeholder 5">
+            <a:extLst>
+              <a:ext uri="{FF2B5EF4-FFF2-40B4-BE49-F238E27FC236}">
+                <a16:creationId xmlns:a16="http://schemas.microsoft.com/office/drawing/2014/main" id="{3E493E1F-F28C-FD47-B996-3EBF17D328AE}"/>
+              </a:ext>
+            </a:extLst>
+          </p:cNvPr>
+          <p:cNvSpPr>
+            <a:spLocks noGrp="1"/>
+          </p:cNvSpPr>
+          <p:nvPr>
+            <p:ph type="sldNum" sz="quarter" idx="4"/>
+          </p:nvPr>
+        </p:nvSpPr>
+        <p:spPr>
+          <a:xfrm>
+            <a:off x="359999" y="6264872"/>
+            <a:ext cx="360000" cy="360000"/>
+          </a:xfrm>
+          <a:prstGeom prst="rect">
+            <a:avLst/>
+          </a:prstGeom>
+        </p:spPr>
+        <p:txBody>
+          <a:bodyPr vert="horz" lIns="91440" tIns="45720" rIns="91440" bIns="45720" rtlCol="0" anchor="ctr"/>
+          <a:lstStyle>
+            <a:lvl1pPr algn="l">
+              <a:defRPr sz="800" b="0" i="0">
+                <a:solidFill>
+                  <a:schemeClr val="tx1"/>
+                </a:solidFill>
+                <a:latin typeface="Arial" panose="020B0604020202020204" pitchFamily="34" charset="0"/>
+                <a:cs typeface="Arial" panose="020B0604020202020204" pitchFamily="34" charset="0"/>
+              </a:defRPr>
+            </a:lvl1pPr>
+          </a:lstStyle>
+          <a:p>
+            <a:fld id="{18A41853-EF22-D446-BDBC-A7CF3FE93503}" type="slidenum">
+              <a:rPr lang="en-US" smtClean="0"/>
+              <a:pPr/>
+              <a:t>‹#›</a:t>
+            </a:fld>
+            <a:endParaRPr lang="en-US" dirty="0"/>
+          </a:p>
+        </p:txBody>
+      </p:sp>
+      <p:sp>
+        <p:nvSpPr>
+          <p:cNvPr id="11" name="TextBox 10"/>
+          <p:cNvSpPr txBox="1"/>
+          <p:nvPr/>
+        </p:nvSpPr>
+        <p:spPr>
+          <a:xfrm>
+            <a:off x="356616" y="1115568"/>
+            <a:ext cx="11475720" cy="457200"/>
+          </a:xfrm>
+          <a:prstGeom prst="rect">
+            <a:avLst/>
+          </a:prstGeom>
+          <a:noFill/>
+        </p:spPr>
+        <p:txBody>
+          <a:bodyPr wrap="square" lIns="0" rIns="0" tIns="0" bIns="0" anchor="t"/>
+          <a:lstStyle/>
+          <a:p>
+            <a:pPr marL="0" indent="0" algn="l">
+              <a:spcAft>
+                <a:spcPts val="0"/>
+              </a:spcAft>
+              <a:buNone/>
+            </a:pPr>
+            <a:r>
+              <a:rPr sz="1700" b="0" i="0">
+                <a:solidFill>
+                  <a:srgbClr val="D31145"/>
+                </a:solidFill>
+                <a:latin typeface="Arial"/>
+                <a:ea typeface="Microsoft JhengHei"/>
+              </a:rPr>
+              <a:t>Both OCR engines read the names. The original rules took the label 病人 as the patient's name.</a:t>
             </a:r>
           </a:p>
         </p:txBody>
@@ -8700,7 +9673,7 @@
           <a:p>
             <a:pPr marL="182880" indent="-182880" algn="l">
               <a:spcAft>
-                <a:spcPts val="800"/>
+                <a:spcPts val="600"/>
               </a:spcAft>
               <a:buFont typeface="Arial"/>
               <a:buChar char="•"/>
@@ -8714,6 +9687,25 @@
                 <a:ea typeface="Microsoft JhengHei"/>
               </a:rPr>
               <a:t>Original rules: took the Chinese label 病人 ("patient") as the patient's name.</a:t>
+            </a:r>
+          </a:p>
+          <a:p>
+            <a:pPr marL="182880" indent="-182880" algn="l">
+              <a:spcAft>
+                <a:spcPts val="600"/>
+              </a:spcAft>
+              <a:buFont typeface="Arial"/>
+              <a:buChar char="•"/>
+            </a:pPr>
+            <a:r>
+              <a:rPr sz="1400" b="0" i="0">
+                <a:solidFill>
+                  <a:srgbClr val="333D47"/>
+                </a:solidFill>
+                <a:latin typeface="Arial"/>
+                <a:ea typeface="Microsoft JhengHei"/>
+              </a:rPr>
+              <a:t>Improved rules: fixed by adding bilingual labels by hand.</a:t>
             </a:r>
           </a:p>
           <a:p>
@@ -8732,7 +9724,7 @@
                 <a:latin typeface="Arial"/>
                 <a:ea typeface="Microsoft JhengHei"/>
               </a:rPr>
-              <a:t>Improved rules: added bilingual labels, so the label and the value are kept apart.</a:t>
+              <a:t>AOAI: correct with the same prompt; no change needed.</a:t>
             </a:r>
           </a:p>
         </p:txBody>
@@ -8784,7 +9776,7 @@
 </p:sld>
 </file>
 
-<file path=ppt/slides/slide5.xml><?xml version="1.0" encoding="utf-8"?>
+<file path=ppt/slides/slide6.xml><?xml version="1.0" encoding="utf-8"?>
 <p:sld xmlns:a="http://schemas.openxmlformats.org/drawingml/2006/main" xmlns:p="http://schemas.openxmlformats.org/presentationml/2006/main" xmlns:r="http://schemas.openxmlformats.org/officeDocument/2006/relationships">
   <p:cSld>
     <p:spTree>
@@ -8822,7 +9814,7 @@
                 <a:latin typeface="Arial"/>
                 <a:ea typeface="Microsoft JhengHei"/>
               </a:rPr>
-              <a:t>The Trade-off: Rules Need Manual Maintenance</a:t>
+              <a:t>Example 2: Reaching 88.2% With Rules Took Manual Work</a:t>
             </a:r>
           </a:p>
         </p:txBody>
@@ -8909,7 +9901,7 @@
                 <a:latin typeface="Arial"/>
                 <a:ea typeface="Microsoft JhengHei"/>
               </a:rPr>
-              <a:t>High accuracy came from rewriting the rules by hand, and one fix broke another receipt.</a:t>
+              <a:t>Each new language or label wording had to be added by hand, and one change broke another receipt.</a:t>
             </a:r>
           </a:p>
         </p:txBody>
@@ -8952,7 +9944,7 @@
         <p:spPr>
           <a:xfrm>
             <a:off x="356616" y="4389120"/>
-            <a:ext cx="4206240" cy="457200"/>
+            <a:ext cx="4206240" cy="685800"/>
           </a:xfrm>
           <a:prstGeom prst="rect">
             <a:avLst/>
@@ -8977,7 +9969,7 @@
                 <a:latin typeface="Arial"/>
                 <a:ea typeface="Microsoft JhengHei"/>
               </a:rPr>
-              <a:t>Chinese medicine receipt: original rules 0/6 fields, improved rules 6/6.</a:t>
+              <a:t>Chinese medicine receipt: original rules 0/6 fields, improved rules 6/6, DI + AOAI 6/6 (prompt unchanged).</a:t>
             </a:r>
           </a:p>
         </p:txBody>
@@ -9163,7 +10155,7 @@
                 <a:latin typeface="Arial"/>
                 <a:ea typeface="Microsoft JhengHei"/>
               </a:rPr>
-              <a:t>may need more rule changes and retesting of every receipt</a:t>
+              <a:t>will likely need more rule changes and a retest of every receipt</a:t>
             </a:r>
           </a:p>
         </p:txBody>
@@ -9202,7 +10194,7 @@
                 <a:latin typeface="Arial"/>
                 <a:ea typeface="Microsoft JhengHei"/>
               </a:rPr>
-              <a:t>AOAI used the same prompt for every receipt. Whether that means less maintenance on new layouts still needs to be tested.</a:t>
+              <a:t>DI + AOAI needed none of these changes for these receipts. Whether that holds for new layouts still needs to be tested.</a:t>
             </a:r>
           </a:p>
         </p:txBody>
@@ -9215,7 +10207,7 @@
 </p:sld>
 </file>
 
-<file path=ppt/slides/slide6.xml><?xml version="1.0" encoding="utf-8"?>
+<file path=ppt/slides/slide7.xml><?xml version="1.0" encoding="utf-8"?>
 <p:sld xmlns:a="http://schemas.openxmlformats.org/drawingml/2006/main" xmlns:p="http://schemas.openxmlformats.org/presentationml/2006/main" xmlns:r="http://schemas.openxmlformats.org/officeDocument/2006/relationships">
   <p:cSld>
     <p:spTree>
@@ -9253,7 +10245,7 @@
                 <a:latin typeface="Arial"/>
                 <a:ea typeface="Microsoft JhengHei"/>
               </a:rPr>
-              <a:t>Where Errors Remain: Both Approaches Make Mistakes</a:t>
+              <a:t>Example 3: AOAI Still Makes Mistakes</a:t>
             </a:r>
           </a:p>
         </p:txBody>
@@ -10354,7 +11346,7 @@
 </p:sld>
 </file>
 
-<file path=ppt/slides/slide7.xml><?xml version="1.0" encoding="utf-8"?>
+<file path=ppt/slides/slide8.xml><?xml version="1.0" encoding="utf-8"?>
 <p:sld xmlns:a="http://schemas.openxmlformats.org/drawingml/2006/main" xmlns:p="http://schemas.openxmlformats.org/presentationml/2006/main" xmlns:r="http://schemas.openxmlformats.org/officeDocument/2006/relationships">
   <p:cSld>
     <p:spTree>
@@ -10392,7 +11384,7 @@
                 <a:latin typeface="Arial"/>
                 <a:ea typeface="Microsoft JhengHei"/>
               </a:rPr>
-              <a:t>Practical Comparison of the Two Candidates</a:t>
+              <a:t>What It Takes to Reach 88.2%</a:t>
             </a:r>
           </a:p>
         </p:txBody>
@@ -10479,7 +11471,7 @@
                 <a:latin typeface="Arial"/>
                 <a:ea typeface="Microsoft JhengHei"/>
               </a:rPr>
-              <a:t>Similar accuracy on these receipts; they differ in cost, speed and how new layouts are handled.</a:t>
+              <a:t>Same accuracy. The difference is the manual work to get there, and to keep it there.</a:t>
             </a:r>
           </a:p>
         </p:txBody>
@@ -10503,9 +11495,9 @@
                 <a:tableStyleId>{2D5ABB26-0587-4C30-8999-92F81FD0307C}</a:tableStyleId>
               </a:tblPr>
               <a:tblGrid>
-                <a:gridCol w="2834640"/>
-                <a:gridCol w="4297680"/>
+                <a:gridCol w="2743200"/>
                 <a:gridCol w="4343400"/>
+                <a:gridCol w="4389120"/>
               </a:tblGrid>
               <a:tr h="548640">
                 <a:tc>
@@ -10632,7 +11624,7 @@
                           <a:latin typeface="Arial"/>
                           <a:ea typeface="Microsoft JhengHei"/>
                         </a:rPr>
-                        <a:t>Accuracy (these 9 receipts)</a:t>
+                        <a:t>Accuracy (9 receipts)</a:t>
                       </a:r>
                     </a:p>
                   </a:txBody>
@@ -10661,14 +11653,14 @@
                     <a:p>
                       <a:pPr algn="l"/>
                       <a:r>
-                        <a:rPr sz="1400" b="0" i="0">
+                        <a:rPr sz="1400" b="1" i="0">
                           <a:solidFill>
-                            <a:srgbClr val="333D47"/>
+                            <a:srgbClr val="D31145"/>
                           </a:solidFill>
                           <a:latin typeface="Arial"/>
                           <a:ea typeface="Microsoft JhengHei"/>
                         </a:rPr>
-                        <a:t>88.2% (45/51), tuned</a:t>
+                        <a:t>88.2% (45/51)</a:t>
                       </a:r>
                     </a:p>
                   </a:txBody>
@@ -10697,14 +11689,14 @@
                     <a:p>
                       <a:pPr algn="l"/>
                       <a:r>
-                        <a:rPr sz="1400" b="0" i="0">
+                        <a:rPr sz="1400" b="1" i="0">
                           <a:solidFill>
-                            <a:srgbClr val="333D47"/>
+                            <a:srgbClr val="D31145"/>
                           </a:solidFill>
                           <a:latin typeface="Arial"/>
                           <a:ea typeface="Microsoft JhengHei"/>
                         </a:rPr>
-                        <a:t>88.2% (45/51), prompt unchanged</a:t>
+                        <a:t>88.2% (45/51)</a:t>
                       </a:r>
                     </a:p>
                   </a:txBody>
@@ -10735,14 +11727,14 @@
                     <a:p>
                       <a:pPr algn="l"/>
                       <a:r>
-                        <a:rPr sz="1400" b="1" i="0">
+                        <a:rPr sz="1350" b="1" i="0">
                           <a:solidFill>
                             <a:srgbClr val="333D47"/>
                           </a:solidFill>
                           <a:latin typeface="Arial"/>
                           <a:ea typeface="Microsoft JhengHei"/>
                         </a:rPr>
-                        <a:t>Time per receipt</a:t>
+                        <a:t>Effort to get there</a:t>
                       </a:r>
                     </a:p>
                   </a:txBody>
@@ -10771,14 +11763,14 @@
                     <a:p>
                       <a:pPr algn="l"/>
                       <a:r>
-                        <a:rPr sz="1400" b="0" i="0">
+                        <a:rPr sz="1350" b="0" i="0">
                           <a:solidFill>
                             <a:srgbClr val="333D47"/>
                           </a:solidFill>
                           <a:latin typeface="Arial"/>
                           <a:ea typeface="Microsoft JhengHei"/>
                         </a:rPr>
-                        <a:t>13.9 s</a:t>
+                        <a:t>Rules rewritten by hand after reviewing errors on these receipts</a:t>
                       </a:r>
                     </a:p>
                   </a:txBody>
@@ -10807,14 +11799,14 @@
                     <a:p>
                       <a:pPr algn="l"/>
                       <a:r>
-                        <a:rPr sz="1400" b="0" i="0">
+                        <a:rPr sz="1350" b="0" i="0">
                           <a:solidFill>
                             <a:srgbClr val="333D47"/>
                           </a:solidFill>
                           <a:latin typeface="Arial"/>
                           <a:ea typeface="Microsoft JhengHei"/>
                         </a:rPr>
-                        <a:t>6.2 s</a:t>
+                        <a:t>None: prompt unchanged</a:t>
                       </a:r>
                     </a:p>
                   </a:txBody>
@@ -10845,14 +11837,14 @@
                     <a:p>
                       <a:pPr algn="l"/>
                       <a:r>
-                        <a:rPr sz="1400" b="1" i="0">
+                        <a:rPr sz="1350" b="1" i="0">
                           <a:solidFill>
                             <a:srgbClr val="333D47"/>
                           </a:solidFill>
                           <a:latin typeface="Arial"/>
                           <a:ea typeface="Microsoft JhengHei"/>
                         </a:rPr>
-                        <a:t>Where it runs</a:t>
+                        <a:t>Extraction logic</a:t>
                       </a:r>
                     </a:p>
                   </a:txBody>
@@ -10881,14 +11873,14 @@
                     <a:p>
                       <a:pPr algn="l"/>
                       <a:r>
-                        <a:rPr sz="1400" b="0" i="0">
+                        <a:rPr sz="1350" b="0" i="0">
                           <a:solidFill>
                             <a:srgbClr val="333D47"/>
                           </a:solidFill>
                           <a:latin typeface="Arial"/>
                           <a:ea typeface="Microsoft JhengHei"/>
                         </a:rPr>
-                        <a:t>Our own compute, offline</a:t>
+                        <a:t>69 → 225 label phrases to maintain</a:t>
                       </a:r>
                     </a:p>
                   </a:txBody>
@@ -10917,14 +11909,14 @@
                     <a:p>
                       <a:pPr algn="l"/>
                       <a:r>
-                        <a:rPr sz="1400" b="0" i="0">
+                        <a:rPr sz="1350" b="0" i="0">
                           <a:solidFill>
                             <a:srgbClr val="333D47"/>
                           </a:solidFill>
                           <a:latin typeface="Arial"/>
                           <a:ea typeface="Microsoft JhengHei"/>
                         </a:rPr>
-                        <a:t>Azure cloud services</a:t>
+                        <a:t>One fixed prompt</a:t>
                       </a:r>
                     </a:p>
                   </a:txBody>
@@ -10955,14 +11947,14 @@
                     <a:p>
                       <a:pPr algn="l"/>
                       <a:r>
-                        <a:rPr sz="1400" b="1" i="0">
+                        <a:rPr sz="1350" b="1" i="0">
                           <a:solidFill>
                             <a:srgbClr val="333D47"/>
                           </a:solidFill>
                           <a:latin typeface="Arial"/>
                           <a:ea typeface="Microsoft JhengHei"/>
                         </a:rPr>
-                        <a:t>Cost per receipt</a:t>
+                        <a:t>New receipt layouts</a:t>
                       </a:r>
                     </a:p>
                   </a:txBody>
@@ -10991,14 +11983,14 @@
                     <a:p>
                       <a:pPr algn="l"/>
                       <a:r>
-                        <a:rPr sz="1400" b="0" i="0">
+                        <a:rPr sz="1350" b="0" i="0">
                           <a:solidFill>
                             <a:srgbClr val="333D47"/>
                           </a:solidFill>
                           <a:latin typeface="Arial"/>
                           <a:ea typeface="Microsoft JhengHei"/>
                         </a:rPr>
-                        <a:t>CPU time only, no API fee</a:t>
+                        <a:t>Likely more rule updates and a regression test of every receipt</a:t>
                       </a:r>
                     </a:p>
                   </a:txBody>
@@ -11027,14 +12019,14 @@
                     <a:p>
                       <a:pPr algn="l"/>
                       <a:r>
-                        <a:rPr sz="1400" b="0" i="0">
+                        <a:rPr sz="1350" b="0" i="0">
                           <a:solidFill>
                             <a:srgbClr val="333D47"/>
                           </a:solidFill>
                           <a:latin typeface="Arial"/>
                           <a:ea typeface="Microsoft JhengHei"/>
                         </a:rPr>
-                        <a:t>DI page + about 602 input / 263 output tokens (prices to confirm)</a:t>
+                        <a:t>Possibly no change; not yet tested</a:t>
                       </a:r>
                     </a:p>
                   </a:txBody>
@@ -11065,14 +12057,14 @@
                     <a:p>
                       <a:pPr algn="l"/>
                       <a:r>
-                        <a:rPr sz="1400" b="1" i="0">
+                        <a:rPr sz="1350" b="1" i="0">
                           <a:solidFill>
                             <a:srgbClr val="333D47"/>
                           </a:solidFill>
                           <a:latin typeface="Arial"/>
                           <a:ea typeface="Microsoft JhengHei"/>
                         </a:rPr>
-                        <a:t>New receipt layouts</a:t>
+                        <a:t>Errors seen</a:t>
                       </a:r>
                     </a:p>
                   </a:txBody>
@@ -11101,14 +12093,14 @@
                     <a:p>
                       <a:pPr algn="l"/>
                       <a:r>
-                        <a:rPr sz="1400" b="0" i="0">
+                        <a:rPr sz="1350" b="0" i="0">
                           <a:solidFill>
                             <a:srgbClr val="333D47"/>
                           </a:solidFill>
                           <a:latin typeface="Arial"/>
                           <a:ea typeface="Microsoft JhengHei"/>
                         </a:rPr>
-                        <a:t>Edit rules and retest</a:t>
+                        <a:t>6 wrong fields, incl. one regression caused by tuning</a:t>
                       </a:r>
                     </a:p>
                   </a:txBody>
@@ -11137,14 +12129,14 @@
                     <a:p>
                       <a:pPr algn="l"/>
                       <a:r>
-                        <a:rPr sz="1400" b="0" i="0">
+                        <a:rPr sz="1350" b="0" i="0">
                           <a:solidFill>
                             <a:srgbClr val="333D47"/>
                           </a:solidFill>
                           <a:latin typeface="Arial"/>
                           <a:ea typeface="Microsoft JhengHei"/>
                         </a:rPr>
-                        <a:t>Same prompt; still to be tested</a:t>
+                        <a:t>6 wrong fields, e.g. the vet invoice total</a:t>
                       </a:r>
                     </a:p>
                   </a:txBody>
@@ -11175,14 +12167,14 @@
                     <a:p>
                       <a:pPr algn="l"/>
                       <a:r>
-                        <a:rPr sz="1400" b="1" i="0">
+                        <a:rPr sz="1350" b="1" i="0">
                           <a:solidFill>
                             <a:srgbClr val="333D47"/>
                           </a:solidFill>
                           <a:latin typeface="Arial"/>
                           <a:ea typeface="Microsoft JhengHei"/>
                         </a:rPr>
-                        <a:t>Main risk</a:t>
+                        <a:t>Time and running cost</a:t>
                       </a:r>
                     </a:p>
                   </a:txBody>
@@ -11211,14 +12203,14 @@
                     <a:p>
                       <a:pPr algn="l"/>
                       <a:r>
-                        <a:rPr sz="1400" b="0" i="0">
+                        <a:rPr sz="1350" b="0" i="0">
                           <a:solidFill>
                             <a:srgbClr val="333D47"/>
                           </a:solidFill>
                           <a:latin typeface="Arial"/>
                           <a:ea typeface="Microsoft JhengHei"/>
                         </a:rPr>
-                        <a:t>Maintenance and regressions</a:t>
+                        <a:t>13.9 s, own compute, no API fee</a:t>
                       </a:r>
                     </a:p>
                   </a:txBody>
@@ -11247,14 +12239,14 @@
                     <a:p>
                       <a:pPr algn="l"/>
                       <a:r>
-                        <a:rPr sz="1400" b="0" i="0">
+                        <a:rPr sz="1350" b="0" i="0">
                           <a:solidFill>
                             <a:srgbClr val="333D47"/>
                           </a:solidFill>
                           <a:latin typeface="Arial"/>
                           <a:ea typeface="Microsoft JhengHei"/>
                         </a:rPr>
-                        <a:t>API cost and model variability</a:t>
+                        <a:t>6.2 s, Azure fees per receipt (to confirm)</a:t>
                       </a:r>
                     </a:p>
                   </a:txBody>
@@ -11289,7 +12281,7 @@
         </p:nvSpPr>
         <p:spPr>
           <a:xfrm>
-            <a:off x="356616" y="5577840"/>
+            <a:off x="356616" y="5440680"/>
             <a:ext cx="10972800" cy="320040"/>
           </a:xfrm>
           <a:prstGeom prst="rect">
@@ -11315,7 +12307,7 @@
                 <a:latin typeface="Arial"/>
                 <a:ea typeface="Microsoft JhengHei"/>
               </a:rPr>
-              <a:t>Both approaches read the receipt text well; the differences are in finding the fields.</a:t>
+              <a:t>The main question is not API price but who maintains the extraction logic. Lower maintenance for AOAI is implied by this benchmark, not yet proven.</a:t>
             </a:r>
           </a:p>
         </p:txBody>
@@ -11328,7 +12320,7 @@
 </p:sld>
 </file>
 
-<file path=ppt/slides/slide8.xml><?xml version="1.0" encoding="utf-8"?>
+<file path=ppt/slides/slide9.xml><?xml version="1.0" encoding="utf-8"?>
 <p:sld xmlns:a="http://schemas.openxmlformats.org/drawingml/2006/main" xmlns:p="http://schemas.openxmlformats.org/presentationml/2006/main" xmlns:r="http://schemas.openxmlformats.org/officeDocument/2006/relationships">
   <p:cSld>
     <p:spTree>
@@ -11453,7 +12445,7 @@
                 <a:latin typeface="Arial"/>
                 <a:ea typeface="Microsoft JhengHei"/>
               </a:rPr>
-              <a:t>Rules can reach high accuracy, but only with ongoing manual work. That is the decision to make.</a:t>
+              <a:t>The real trade-off: maintain extraction rules ourselves, or let AI replace that layer.</a:t>
             </a:r>
           </a:p>
         </p:txBody>
@@ -11467,7 +12459,7 @@
         <p:spPr>
           <a:xfrm>
             <a:off x="356616" y="1783080"/>
-            <a:ext cx="11475720" cy="1417320"/>
+            <a:ext cx="11475720" cy="1508760"/>
           </a:xfrm>
           <a:prstGeom prst="rect">
             <a:avLst/>
@@ -11483,39 +12475,60 @@
           <a:bodyPr rtlCol="0" anchor="t" wrap="square" lIns="274320" rIns="274320" tIns="109728" bIns="109728"/>
           <a:lstStyle/>
           <a:p>
-            <a:pPr algn="l" marL="0" indent="0">
+            <a:pPr algn="l" marL="182880" indent="-182880">
               <a:spcAft>
                 <a:spcPts val="600"/>
               </a:spcAft>
-              <a:buNone/>
+              <a:buFont typeface="Arial"/>
+              <a:buChar char="•"/>
             </a:pPr>
             <a:r>
-              <a:rPr sz="1900" b="1" i="0">
+              <a:rPr sz="1600" b="0" i="0">
                 <a:solidFill>
                   <a:srgbClr val="333D47"/>
                 </a:solidFill>
                 <a:latin typeface="Arial"/>
                 <a:ea typeface="Microsoft JhengHei"/>
               </a:rPr>
-              <a:t>The question is not only which method is most accurate.</a:t>
+              <a:t>PaddleOCR Light + improved rules and Azure DI + AOAI both reached 88.2% on this benchmark.</a:t>
             </a:r>
           </a:p>
           <a:p>
-            <a:pPr marL="0" indent="0" algn="l">
+            <a:pPr marL="182880" indent="-182880" algn="l">
+              <a:spcAft>
+                <a:spcPts val="600"/>
+              </a:spcAft>
+              <a:buFont typeface="Arial"/>
+              <a:buChar char="•"/>
+            </a:pPr>
+            <a:r>
+              <a:rPr sz="1600" b="0" i="0">
+                <a:solidFill>
+                  <a:srgbClr val="333D47"/>
+                </a:solidFill>
+                <a:latin typeface="Arial"/>
+                <a:ea typeface="Microsoft JhengHei"/>
+              </a:rPr>
+              <a:t>PaddleOCR Light needed manual rule tuning to get there. Azure DI + AOAI reached the same accuracy without changing its prompt.</a:t>
+            </a:r>
+          </a:p>
+          <a:p>
+            <a:pPr marL="182880" indent="-182880" algn="l">
               <a:spcAft>
                 <a:spcPts val="0"/>
               </a:spcAft>
-              <a:buNone/>
+              <a:buFont typeface="Arial"/>
+              <a:buChar char="•"/>
             </a:pPr>
             <a:r>
-              <a:rPr sz="1600" b="0" i="0">
+              <a:rPr sz="1600" b="1" i="0">
                 <a:solidFill>
                   <a:srgbClr val="333D47"/>
                 </a:solidFill>
                 <a:latin typeface="Arial"/>
                 <a:ea typeface="Microsoft JhengHei"/>
               </a:rPr>
-              <a:t>It is whether we want to keep updating extraction rules each time an unfamiliar receipt layout appears, or pay per request for a model that may handle new layouts without changes.</a:t>
+              <a:t>So the choice is whether to keep writing and maintaining extraction rules, or to use AI for that layer.</a:t>
             </a:r>
           </a:p>
         </p:txBody>
@@ -11528,7 +12541,7 @@
         </p:nvSpPr>
         <p:spPr>
           <a:xfrm>
-            <a:off x="356616" y="3429000"/>
+            <a:off x="356616" y="3520440"/>
             <a:ext cx="3642360" cy="1280160"/>
           </a:xfrm>
           <a:prstGeom prst="rect">
@@ -11590,7 +12603,7 @@
         </p:nvSpPr>
         <p:spPr>
           <a:xfrm>
-            <a:off x="4273296" y="3429000"/>
+            <a:off x="4273296" y="3520440"/>
             <a:ext cx="3642360" cy="1280160"/>
           </a:xfrm>
           <a:prstGeom prst="rect">
@@ -11621,7 +12634,7 @@
                 <a:latin typeface="Arial"/>
                 <a:ea typeface="Microsoft JhengHei"/>
               </a:rPr>
-              <a:t>2. Test on new receipts</a:t>
+              <a:t>2. Test on unseen receipts</a:t>
             </a:r>
           </a:p>
           <a:p>
@@ -11639,7 +12652,7 @@
                 <a:latin typeface="Arial"/>
                 <a:ea typeface="Microsoft JhengHei"/>
               </a:rPr>
-              <a:t>30+ real, anonymised receipts not seen before. Count the rule changes needed.</a:t>
+              <a:t>30+ real, anonymised receipts. Measure accuracy and count the rule changes needed.</a:t>
             </a:r>
           </a:p>
         </p:txBody>
@@ -11652,7 +12665,7 @@
         </p:nvSpPr>
         <p:spPr>
           <a:xfrm>
-            <a:off x="8189976" y="3429000"/>
+            <a:off x="8189976" y="3520440"/>
             <a:ext cx="3642360" cy="1280160"/>
           </a:xfrm>
           <a:prstGeom prst="rect">
@@ -11683,7 +12696,7 @@
                 <a:latin typeface="Arial"/>
                 <a:ea typeface="Microsoft JhengHei"/>
               </a:rPr>
-              <a:t>3. Confirm prices</a:t>
+              <a:t>3. Then compare cost</a:t>
             </a:r>
           </a:p>
           <a:p>
@@ -11714,7 +12727,7 @@
         </p:nvSpPr>
         <p:spPr>
           <a:xfrm>
-            <a:off x="356616" y="4983480"/>
+            <a:off x="356616" y="5029200"/>
             <a:ext cx="10972800" cy="320040"/>
           </a:xfrm>
           <a:prstGeom prst="rect">
@@ -11740,7 +12753,7 @@
                 <a:latin typeface="Arial"/>
                 <a:ea typeface="Microsoft JhengHei"/>
               </a:rPr>
-              <a:t>Limitation: 9 receipts, mostly printed mock receipts; the improved rules were tuned on them. Candidates for further testing: PaddleOCR Light + improved rules, and Azure DI + AOAI.</a:t>
+              <a:t>Limitation: 9 receipts, mostly printed mock receipts; the improved rules were tuned on them. AOAI still makes mistakes and has not been tested on a large unseen set.</a:t>
             </a:r>
           </a:p>
         </p:txBody>

</xml_diff>

<commit_message>
OCR benchmark deck V2: add pros and cons slide (10 slides)
- New slide 9, before the conclusion: Pure OCR + Rules vs. Azure DI +
  AOAI, pros and cons in two columns. Points taken from the benchmark
  are marked "Measured"; the rest are expected advantages or risks.
- Takeaway: the decision is not only accuracy or API cost, but how much
  development and ongoing maintenance effort we want to own.
- Archive the 9-slide revision in archive/v2_9slides/.
- check_deck_v2.py expects 10 slides.

No OCR, scoring or Azure calls; figures and conclusions unchanged.

Co-Authored-By: Claude Opus 5.5 <noreply@anthropic.com>
</commit_message>
<xml_diff>
--- a/ppt/ocr_benchmark/current/OCR_Benchmark_V2.pptx
+++ b/ppt/ocr_benchmark/current/OCR_Benchmark_V2.pptx
@@ -20,6 +20,7 @@
     <p:sldId id="262" r:id="rId14"/>
     <p:sldId id="263" r:id="rId15"/>
     <p:sldId id="264" r:id="rId16"/>
+    <p:sldId id="265" r:id="rId17"/>
   </p:sldIdLst>
   <p:sldSz cx="12192000" cy="6858000"/>
   <p:notesSz cx="6858000" cy="9144000"/>
@@ -726,6 +727,76 @@
 </p:notes>
 </file>
 
+<file path=ppt/notesSlides/notesSlide10.xml><?xml version="1.0" encoding="utf-8"?>
+<p:notes xmlns:a="http://schemas.openxmlformats.org/drawingml/2006/main" xmlns:p="http://schemas.openxmlformats.org/presentationml/2006/main" xmlns:r="http://schemas.openxmlformats.org/officeDocument/2006/relationships">
+  <p:cSld>
+    <p:spTree>
+      <p:nvGrpSpPr>
+        <p:cNvPr id="1" name=""/>
+        <p:cNvGrpSpPr/>
+        <p:nvPr/>
+      </p:nvGrpSpPr>
+      <p:grpSpPr>
+        <a:xfrm>
+          <a:off x="0" y="0"/>
+          <a:ext cx="0" cy="0"/>
+          <a:chOff x="0" y="0"/>
+          <a:chExt cx="0" cy="0"/>
+        </a:xfrm>
+      </p:grpSpPr>
+      <p:sp>
+        <p:nvSpPr>
+          <p:cNvPr id="2" name="Slide Image Placeholder 1"/>
+          <p:cNvSpPr>
+            <a:spLocks noGrp="1"/>
+          </p:cNvSpPr>
+          <p:nvPr>
+            <p:ph type="sldImg" idx="2"/>
+          </p:nvPr>
+        </p:nvSpPr>
+        <p:spPr/>
+      </p:sp>
+      <p:sp>
+        <p:nvSpPr>
+          <p:cNvPr id="3" name="Notes Placeholder 2"/>
+          <p:cNvSpPr>
+            <a:spLocks noGrp="1"/>
+          </p:cNvSpPr>
+          <p:nvPr>
+            <p:ph type="body" idx="3" sz="quarter"/>
+          </p:nvPr>
+        </p:nvSpPr>
+        <p:spPr/>
+        <p:txBody>
+          <a:bodyPr/>
+          <a:lstStyle/>
+          <a:p>
+            <a:r>
+              <a:t>Main finding: PaddleOCR Light reached 88.2% (and Azure DI 86.3%) only after the rules were rewritten for these receipts; Azure DI + AOAI reached 88.2% with no change to its prompt. The benchmark is small (9 receipts) and the improved rules were tuned on it, so this is not a production decision. Source: python/receipt_ocr_benchmark/results/v2/scores_improved (summary.csv, detail.csv) and extraction JSON.</a:t>
+            </a:r>
+          </a:p>
+        </p:txBody>
+      </p:sp>
+      <p:sp>
+        <p:nvSpPr>
+          <p:cNvPr id="4" name="Slide Number Placeholder 3"/>
+          <p:cNvSpPr>
+            <a:spLocks noGrp="1"/>
+          </p:cNvSpPr>
+          <p:nvPr>
+            <p:ph type="sldNum" idx="5" sz="quarter"/>
+          </p:nvPr>
+        </p:nvSpPr>
+        <p:spPr/>
+      </p:sp>
+    </p:spTree>
+  </p:cSld>
+  <p:clrMapOvr>
+    <a:masterClrMapping/>
+  </p:clrMapOvr>
+</p:notes>
+</file>
+
 <file path=ppt/notesSlides/notesSlide2.xml><?xml version="1.0" encoding="utf-8"?>
 <p:notes xmlns:a="http://schemas.openxmlformats.org/drawingml/2006/main" xmlns:p="http://schemas.openxmlformats.org/presentationml/2006/main" xmlns:r="http://schemas.openxmlformats.org/officeDocument/2006/relationships">
   <p:cSld>
@@ -1261,7 +1332,7 @@
           <a:lstStyle/>
           <a:p>
             <a:r>
-              <a:t>Main finding: PaddleOCR Light reached 88.2% (and Azure DI 86.3%) only after the rules were rewritten for these receipts; Azure DI + AOAI reached 88.2% with no change to its prompt. The benchmark is small (9 receipts) and the improved rules were tuned on it, so this is not a production decision. Source: python/receipt_ocr_benchmark/results/v2/scores_improved (summary.csv, detail.csv) and extraction JSON.</a:t>
+              <a:t>Measured (summary.csv, detail.csv): PaddleOCR Light + rules 37.3% with the original rules and 88.2% after tuning on these 9 receipts; label phrases 69 to 225; vet invoice receipt number 369303 correct before tuning, 380048 after. Azure DI + AOAI 88.2% with the prompt unchanged; bilingual receipt 6/6 and Chinese medicine receipt 6/6; 6.2 s vs 13.9 s per receipt; vet invoice total 1361.5 although the Azure DI text contains the correct 1361.00. Expected, not measured: control, predictability, API fees, run-to-run variation and behaviour on unseen receipts. Prices are not yet confirmed. Source: python/receipt_ocr_benchmark/results/v2/scores_improved (summary.csv, detail.csv) and extraction JSON.</a:t>
             </a:r>
           </a:p>
         </p:txBody>
@@ -5972,6 +6043,452 @@
 </p:sld>
 </file>
 
+<file path=ppt/slides/slide10.xml><?xml version="1.0" encoding="utf-8"?>
+<p:sld xmlns:a="http://schemas.openxmlformats.org/drawingml/2006/main" xmlns:p="http://schemas.openxmlformats.org/presentationml/2006/main" xmlns:r="http://schemas.openxmlformats.org/officeDocument/2006/relationships">
+  <p:cSld>
+    <p:spTree>
+      <p:nvGrpSpPr>
+        <p:cNvPr id="1" name=""/>
+        <p:cNvGrpSpPr/>
+        <p:nvPr/>
+      </p:nvGrpSpPr>
+      <p:grpSpPr/>
+      <p:sp>
+        <p:nvSpPr>
+          <p:cNvPr id="4" name="Text Placeholder 3"/>
+          <p:cNvSpPr>
+            <a:spLocks noGrp="1"/>
+          </p:cNvSpPr>
+          <p:nvPr>
+            <p:ph type="body" idx="10" sz="quarter"/>
+          </p:nvPr>
+        </p:nvSpPr>
+        <p:spPr>
+          <a:xfrm>
+            <a:off x="356616" y="502920"/>
+            <a:ext cx="11155680" cy="566928"/>
+          </a:xfrm>
+        </p:spPr>
+        <p:txBody>
+          <a:bodyPr lIns="0"/>
+          <a:lstStyle/>
+          <a:p>
+            <a:r>
+              <a:rPr sz="2800" b="1">
+                <a:solidFill>
+                  <a:srgbClr val="333D47"/>
+                </a:solidFill>
+                <a:latin typeface="Arial"/>
+                <a:ea typeface="Microsoft JhengHei"/>
+              </a:rPr>
+              <a:t>Conclusion and Next Steps</a:t>
+            </a:r>
+          </a:p>
+        </p:txBody>
+      </p:sp>
+      <p:sp>
+        <p:nvSpPr>
+          <p:cNvPr id="10" name="Slide Number Placeholder 5">
+            <a:extLst>
+              <a:ext uri="{FF2B5EF4-FFF2-40B4-BE49-F238E27FC236}">
+                <a16:creationId xmlns:a16="http://schemas.microsoft.com/office/drawing/2014/main" id="{3E493E1F-F28C-FD47-B996-3EBF17D328AE}"/>
+              </a:ext>
+            </a:extLst>
+          </p:cNvPr>
+          <p:cNvSpPr>
+            <a:spLocks noGrp="1"/>
+          </p:cNvSpPr>
+          <p:nvPr>
+            <p:ph type="sldNum" sz="quarter" idx="4"/>
+          </p:nvPr>
+        </p:nvSpPr>
+        <p:spPr>
+          <a:xfrm>
+            <a:off x="359999" y="6264872"/>
+            <a:ext cx="360000" cy="360000"/>
+          </a:xfrm>
+          <a:prstGeom prst="rect">
+            <a:avLst/>
+          </a:prstGeom>
+        </p:spPr>
+        <p:txBody>
+          <a:bodyPr vert="horz" lIns="91440" tIns="45720" rIns="91440" bIns="45720" rtlCol="0" anchor="ctr"/>
+          <a:lstStyle>
+            <a:lvl1pPr algn="l">
+              <a:defRPr sz="800" b="0" i="0">
+                <a:solidFill>
+                  <a:schemeClr val="tx1"/>
+                </a:solidFill>
+                <a:latin typeface="Arial" panose="020B0604020202020204" pitchFamily="34" charset="0"/>
+                <a:cs typeface="Arial" panose="020B0604020202020204" pitchFamily="34" charset="0"/>
+              </a:defRPr>
+            </a:lvl1pPr>
+          </a:lstStyle>
+          <a:p>
+            <a:fld id="{18A41853-EF22-D446-BDBC-A7CF3FE93503}" type="slidenum">
+              <a:rPr lang="en-US" smtClean="0"/>
+              <a:pPr/>
+              <a:t>‹#›</a:t>
+            </a:fld>
+            <a:endParaRPr lang="en-US" dirty="0"/>
+          </a:p>
+        </p:txBody>
+      </p:sp>
+      <p:sp>
+        <p:nvSpPr>
+          <p:cNvPr id="11" name="TextBox 10"/>
+          <p:cNvSpPr txBox="1"/>
+          <p:nvPr/>
+        </p:nvSpPr>
+        <p:spPr>
+          <a:xfrm>
+            <a:off x="356616" y="1115568"/>
+            <a:ext cx="11475720" cy="457200"/>
+          </a:xfrm>
+          <a:prstGeom prst="rect">
+            <a:avLst/>
+          </a:prstGeom>
+          <a:noFill/>
+        </p:spPr>
+        <p:txBody>
+          <a:bodyPr wrap="square" lIns="0" rIns="0" tIns="0" bIns="0" anchor="t"/>
+          <a:lstStyle/>
+          <a:p>
+            <a:pPr marL="0" indent="0" algn="l">
+              <a:spcAft>
+                <a:spcPts val="0"/>
+              </a:spcAft>
+              <a:buNone/>
+            </a:pPr>
+            <a:r>
+              <a:rPr sz="1700" b="0" i="0">
+                <a:solidFill>
+                  <a:srgbClr val="D31145"/>
+                </a:solidFill>
+                <a:latin typeface="Arial"/>
+                <a:ea typeface="Microsoft JhengHei"/>
+              </a:rPr>
+              <a:t>The real trade-off: maintain extraction rules ourselves, or let AI replace that layer.</a:t>
+            </a:r>
+          </a:p>
+        </p:txBody>
+      </p:sp>
+      <p:sp>
+        <p:nvSpPr>
+          <p:cNvPr id="12" name="Rectangle 11"/>
+          <p:cNvSpPr/>
+          <p:nvPr/>
+        </p:nvSpPr>
+        <p:spPr>
+          <a:xfrm>
+            <a:off x="356616" y="1783080"/>
+            <a:ext cx="11475720" cy="1508760"/>
+          </a:xfrm>
+          <a:prstGeom prst="rect">
+            <a:avLst/>
+          </a:prstGeom>
+          <a:solidFill>
+            <a:srgbClr val="F2F2F2"/>
+          </a:solidFill>
+          <a:ln>
+            <a:noFill/>
+          </a:ln>
+        </p:spPr>
+        <p:txBody>
+          <a:bodyPr rtlCol="0" anchor="t" wrap="square" lIns="274320" rIns="274320" tIns="109728" bIns="109728"/>
+          <a:lstStyle/>
+          <a:p>
+            <a:pPr algn="l" marL="182880" indent="-182880">
+              <a:spcAft>
+                <a:spcPts val="600"/>
+              </a:spcAft>
+              <a:buFont typeface="Arial"/>
+              <a:buChar char="•"/>
+            </a:pPr>
+            <a:r>
+              <a:rPr sz="1600" b="0" i="0">
+                <a:solidFill>
+                  <a:srgbClr val="333D47"/>
+                </a:solidFill>
+                <a:latin typeface="Arial"/>
+                <a:ea typeface="Microsoft JhengHei"/>
+              </a:rPr>
+              <a:t>PaddleOCR Light + improved rules and Azure DI + AOAI both reached 88.2% on this benchmark.</a:t>
+            </a:r>
+          </a:p>
+          <a:p>
+            <a:pPr marL="182880" indent="-182880" algn="l">
+              <a:spcAft>
+                <a:spcPts val="600"/>
+              </a:spcAft>
+              <a:buFont typeface="Arial"/>
+              <a:buChar char="•"/>
+            </a:pPr>
+            <a:r>
+              <a:rPr sz="1600" b="0" i="0">
+                <a:solidFill>
+                  <a:srgbClr val="333D47"/>
+                </a:solidFill>
+                <a:latin typeface="Arial"/>
+                <a:ea typeface="Microsoft JhengHei"/>
+              </a:rPr>
+              <a:t>PaddleOCR Light needed manual rule tuning to get there. Azure DI + AOAI reached the same accuracy without changing its prompt.</a:t>
+            </a:r>
+          </a:p>
+          <a:p>
+            <a:pPr marL="182880" indent="-182880" algn="l">
+              <a:spcAft>
+                <a:spcPts val="0"/>
+              </a:spcAft>
+              <a:buFont typeface="Arial"/>
+              <a:buChar char="•"/>
+            </a:pPr>
+            <a:r>
+              <a:rPr sz="1600" b="1" i="0">
+                <a:solidFill>
+                  <a:srgbClr val="333D47"/>
+                </a:solidFill>
+                <a:latin typeface="Arial"/>
+                <a:ea typeface="Microsoft JhengHei"/>
+              </a:rPr>
+              <a:t>So the choice is whether to keep writing and maintaining extraction rules, or to use AI for that layer.</a:t>
+            </a:r>
+          </a:p>
+        </p:txBody>
+      </p:sp>
+      <p:sp>
+        <p:nvSpPr>
+          <p:cNvPr id="13" name="Rectangle 12"/>
+          <p:cNvSpPr/>
+          <p:nvPr/>
+        </p:nvSpPr>
+        <p:spPr>
+          <a:xfrm>
+            <a:off x="356616" y="3520440"/>
+            <a:ext cx="3642360" cy="1280160"/>
+          </a:xfrm>
+          <a:prstGeom prst="rect">
+            <a:avLst/>
+          </a:prstGeom>
+          <a:solidFill>
+            <a:srgbClr val="F2F2F2"/>
+          </a:solidFill>
+          <a:ln>
+            <a:noFill/>
+          </a:ln>
+        </p:spPr>
+        <p:txBody>
+          <a:bodyPr rtlCol="0" anchor="t" wrap="square" lIns="201168" rIns="201168" tIns="109728" bIns="109728"/>
+          <a:lstStyle/>
+          <a:p>
+            <a:pPr algn="l" marL="0" indent="0">
+              <a:spcAft>
+                <a:spcPts val="600"/>
+              </a:spcAft>
+              <a:buNone/>
+            </a:pPr>
+            <a:r>
+              <a:rPr sz="1600" b="1" i="0">
+                <a:solidFill>
+                  <a:srgbClr val="D31145"/>
+                </a:solidFill>
+                <a:latin typeface="Arial"/>
+                <a:ea typeface="Microsoft JhengHei"/>
+              </a:rPr>
+              <a:t>1. Freeze both</a:t>
+            </a:r>
+          </a:p>
+          <a:p>
+            <a:pPr marL="0" indent="0" algn="l">
+              <a:spcAft>
+                <a:spcPts val="0"/>
+              </a:spcAft>
+              <a:buNone/>
+            </a:pPr>
+            <a:r>
+              <a:rPr sz="1400" b="0" i="0">
+                <a:solidFill>
+                  <a:srgbClr val="333D47"/>
+                </a:solidFill>
+                <a:latin typeface="Arial"/>
+                <a:ea typeface="Microsoft JhengHei"/>
+              </a:rPr>
+              <a:t>Lock the improved rules and the AOAI prompt.</a:t>
+            </a:r>
+          </a:p>
+        </p:txBody>
+      </p:sp>
+      <p:sp>
+        <p:nvSpPr>
+          <p:cNvPr id="14" name="Rectangle 13"/>
+          <p:cNvSpPr/>
+          <p:nvPr/>
+        </p:nvSpPr>
+        <p:spPr>
+          <a:xfrm>
+            <a:off x="4273296" y="3520440"/>
+            <a:ext cx="3642360" cy="1280160"/>
+          </a:xfrm>
+          <a:prstGeom prst="rect">
+            <a:avLst/>
+          </a:prstGeom>
+          <a:solidFill>
+            <a:srgbClr val="F2F2F2"/>
+          </a:solidFill>
+          <a:ln>
+            <a:noFill/>
+          </a:ln>
+        </p:spPr>
+        <p:txBody>
+          <a:bodyPr rtlCol="0" anchor="t" wrap="square" lIns="201168" rIns="201168" tIns="109728" bIns="109728"/>
+          <a:lstStyle/>
+          <a:p>
+            <a:pPr algn="l" marL="0" indent="0">
+              <a:spcAft>
+                <a:spcPts val="600"/>
+              </a:spcAft>
+              <a:buNone/>
+            </a:pPr>
+            <a:r>
+              <a:rPr sz="1600" b="1" i="0">
+                <a:solidFill>
+                  <a:srgbClr val="D31145"/>
+                </a:solidFill>
+                <a:latin typeface="Arial"/>
+                <a:ea typeface="Microsoft JhengHei"/>
+              </a:rPr>
+              <a:t>2. Test on unseen receipts</a:t>
+            </a:r>
+          </a:p>
+          <a:p>
+            <a:pPr marL="0" indent="0" algn="l">
+              <a:spcAft>
+                <a:spcPts val="0"/>
+              </a:spcAft>
+              <a:buNone/>
+            </a:pPr>
+            <a:r>
+              <a:rPr sz="1400" b="0" i="0">
+                <a:solidFill>
+                  <a:srgbClr val="333D47"/>
+                </a:solidFill>
+                <a:latin typeface="Arial"/>
+                <a:ea typeface="Microsoft JhengHei"/>
+              </a:rPr>
+              <a:t>30+ real, anonymised receipts. Measure accuracy and count the rule changes needed.</a:t>
+            </a:r>
+          </a:p>
+        </p:txBody>
+      </p:sp>
+      <p:sp>
+        <p:nvSpPr>
+          <p:cNvPr id="15" name="Rectangle 14"/>
+          <p:cNvSpPr/>
+          <p:nvPr/>
+        </p:nvSpPr>
+        <p:spPr>
+          <a:xfrm>
+            <a:off x="8189976" y="3520440"/>
+            <a:ext cx="3642360" cy="1280160"/>
+          </a:xfrm>
+          <a:prstGeom prst="rect">
+            <a:avLst/>
+          </a:prstGeom>
+          <a:solidFill>
+            <a:srgbClr val="F2F2F2"/>
+          </a:solidFill>
+          <a:ln>
+            <a:noFill/>
+          </a:ln>
+        </p:spPr>
+        <p:txBody>
+          <a:bodyPr rtlCol="0" anchor="t" wrap="square" lIns="201168" rIns="201168" tIns="109728" bIns="109728"/>
+          <a:lstStyle/>
+          <a:p>
+            <a:pPr algn="l" marL="0" indent="0">
+              <a:spcAft>
+                <a:spcPts val="600"/>
+              </a:spcAft>
+              <a:buNone/>
+            </a:pPr>
+            <a:r>
+              <a:rPr sz="1600" b="1" i="0">
+                <a:solidFill>
+                  <a:srgbClr val="D31145"/>
+                </a:solidFill>
+                <a:latin typeface="Arial"/>
+                <a:ea typeface="Microsoft JhengHei"/>
+              </a:rPr>
+              <a:t>3. Then compare cost</a:t>
+            </a:r>
+          </a:p>
+          <a:p>
+            <a:pPr marL="0" indent="0" algn="l">
+              <a:spcAft>
+                <a:spcPts val="0"/>
+              </a:spcAft>
+              <a:buNone/>
+            </a:pPr>
+            <a:r>
+              <a:rPr sz="1400" b="0" i="0">
+                <a:solidFill>
+                  <a:srgbClr val="333D47"/>
+                </a:solidFill>
+                <a:latin typeface="Arial"/>
+                <a:ea typeface="Microsoft JhengHei"/>
+              </a:rPr>
+              <a:t>Compute, Document Intelligence pages and gpt-5-mini tokens.</a:t>
+            </a:r>
+          </a:p>
+        </p:txBody>
+      </p:sp>
+      <p:sp>
+        <p:nvSpPr>
+          <p:cNvPr id="16" name="TextBox 15"/>
+          <p:cNvSpPr txBox="1"/>
+          <p:nvPr/>
+        </p:nvSpPr>
+        <p:spPr>
+          <a:xfrm>
+            <a:off x="356616" y="5029200"/>
+            <a:ext cx="10972800" cy="320040"/>
+          </a:xfrm>
+          <a:prstGeom prst="rect">
+            <a:avLst/>
+          </a:prstGeom>
+          <a:noFill/>
+        </p:spPr>
+        <p:txBody>
+          <a:bodyPr wrap="square" lIns="0" rIns="0" tIns="0" bIns="0" anchor="t"/>
+          <a:lstStyle/>
+          <a:p>
+            <a:pPr marL="0" indent="0" algn="l">
+              <a:spcAft>
+                <a:spcPts val="0"/>
+              </a:spcAft>
+              <a:buNone/>
+            </a:pPr>
+            <a:r>
+              <a:rPr sz="1100" b="0" i="1">
+                <a:solidFill>
+                  <a:srgbClr val="5F6770"/>
+                </a:solidFill>
+                <a:latin typeface="Arial"/>
+                <a:ea typeface="Microsoft JhengHei"/>
+              </a:rPr>
+              <a:t>Limitation: 9 receipts, mostly printed mock receipts; the improved rules were tuned on them. AOAI still makes mistakes and has not been tested on a large unseen set.</a:t>
+            </a:r>
+          </a:p>
+        </p:txBody>
+      </p:sp>
+    </p:spTree>
+  </p:cSld>
+  <p:clrMapOvr>
+    <a:masterClrMapping/>
+  </p:clrMapOvr>
+</p:sld>
+</file>
+
 <file path=ppt/slides/slide2.xml><?xml version="1.0" encoding="utf-8"?>
 <p:sld xmlns:a="http://schemas.openxmlformats.org/drawingml/2006/main" xmlns:p="http://schemas.openxmlformats.org/presentationml/2006/main" xmlns:r="http://schemas.openxmlformats.org/officeDocument/2006/relationships">
   <p:cSld>
@@ -12358,7 +12875,7 @@
                 <a:latin typeface="Arial"/>
                 <a:ea typeface="Microsoft JhengHei"/>
               </a:rPr>
-              <a:t>Conclusion and Next Steps</a:t>
+              <a:t>Pure OCR + Rules vs. Azure DI + AOAI: Pros and Cons</a:t>
             </a:r>
           </a:p>
         </p:txBody>
@@ -12445,7 +12962,7 @@
                 <a:latin typeface="Arial"/>
                 <a:ea typeface="Microsoft JhengHei"/>
               </a:rPr>
-              <a:t>The real trade-off: maintain extraction rules ourselves, or let AI replace that layer.</a:t>
+              <a:t>Both reached 88.2%. Points marked "Measured" come from this benchmark; the rest are expected, not yet tested.</a:t>
             </a:r>
           </a:p>
         </p:txBody>
@@ -12459,7 +12976,645 @@
         <p:spPr>
           <a:xfrm>
             <a:off x="356616" y="1783080"/>
-            <a:ext cx="11475720" cy="1508760"/>
+            <a:ext cx="5600700" cy="411480"/>
+          </a:xfrm>
+          <a:prstGeom prst="rect">
+            <a:avLst/>
+          </a:prstGeom>
+          <a:solidFill>
+            <a:srgbClr val="333D47"/>
+          </a:solidFill>
+          <a:ln>
+            <a:noFill/>
+          </a:ln>
+        </p:spPr>
+        <p:txBody>
+          <a:bodyPr rtlCol="0" anchor="ctr" wrap="square" lIns="164592" rIns="164592" tIns="109728" bIns="109728"/>
+          <a:lstStyle/>
+          <a:p>
+            <a:pPr algn="l" marL="0" indent="0">
+              <a:spcAft>
+                <a:spcPts val="0"/>
+              </a:spcAft>
+              <a:buNone/>
+            </a:pPr>
+            <a:r>
+              <a:rPr sz="1600" b="1" i="0">
+                <a:solidFill>
+                  <a:srgbClr val="FFFFFF"/>
+                </a:solidFill>
+                <a:latin typeface="Arial"/>
+                <a:ea typeface="Microsoft JhengHei"/>
+              </a:rPr>
+              <a:t>Pure OCR + Rules (PaddleOCR Light)</a:t>
+            </a:r>
+          </a:p>
+        </p:txBody>
+      </p:sp>
+      <p:sp>
+        <p:nvSpPr>
+          <p:cNvPr id="13" name="Rectangle 12"/>
+          <p:cNvSpPr/>
+          <p:nvPr/>
+        </p:nvSpPr>
+        <p:spPr>
+          <a:xfrm>
+            <a:off x="356616" y="2286000"/>
+            <a:ext cx="5600700" cy="1527048"/>
+          </a:xfrm>
+          <a:prstGeom prst="rect">
+            <a:avLst/>
+          </a:prstGeom>
+          <a:solidFill>
+            <a:srgbClr val="E6F2EA"/>
+          </a:solidFill>
+          <a:ln>
+            <a:noFill/>
+          </a:ln>
+        </p:spPr>
+        <p:txBody>
+          <a:bodyPr rtlCol="0" anchor="t" wrap="square" lIns="164592" rIns="164592" tIns="109728" bIns="109728"/>
+          <a:lstStyle/>
+          <a:p>
+            <a:pPr algn="l" marL="0" indent="0">
+              <a:spcAft>
+                <a:spcPts val="400"/>
+              </a:spcAft>
+              <a:buNone/>
+            </a:pPr>
+            <a:r>
+              <a:rPr sz="1500" b="1" i="0">
+                <a:solidFill>
+                  <a:srgbClr val="1E7B4A"/>
+                </a:solidFill>
+                <a:latin typeface="Arial"/>
+                <a:ea typeface="Microsoft JhengHei"/>
+              </a:rPr>
+              <a:t>Pros</a:t>
+            </a:r>
+          </a:p>
+          <a:p>
+            <a:pPr marL="182880" indent="-182880" algn="l">
+              <a:spcAft>
+                <a:spcPts val="300"/>
+              </a:spcAft>
+              <a:buFont typeface="Arial"/>
+              <a:buChar char="•"/>
+            </a:pPr>
+            <a:r>
+              <a:rPr sz="1300" b="0" i="0">
+                <a:solidFill>
+                  <a:srgbClr val="333D47"/>
+                </a:solidFill>
+                <a:latin typeface="Arial"/>
+                <a:ea typeface="Microsoft JhengHei"/>
+              </a:rPr>
+              <a:t>Full control over the extraction logic.</a:t>
+            </a:r>
+          </a:p>
+          <a:p>
+            <a:pPr marL="182880" indent="-182880" algn="l">
+              <a:spcAft>
+                <a:spcPts val="300"/>
+              </a:spcAft>
+              <a:buFont typeface="Arial"/>
+              <a:buChar char="•"/>
+            </a:pPr>
+            <a:r>
+              <a:rPr sz="1300" b="0" i="0">
+                <a:solidFill>
+                  <a:srgbClr val="333D47"/>
+                </a:solidFill>
+                <a:latin typeface="Arial"/>
+                <a:ea typeface="Microsoft JhengHei"/>
+              </a:rPr>
+              <a:t>No API fees: open-source OCR on our own compute.</a:t>
+            </a:r>
+          </a:p>
+          <a:p>
+            <a:pPr marL="182880" indent="-182880" algn="l">
+              <a:spcAft>
+                <a:spcPts val="300"/>
+              </a:spcAft>
+              <a:buFont typeface="Arial"/>
+              <a:buChar char="•"/>
+            </a:pPr>
+            <a:r>
+              <a:rPr sz="1300" b="0" i="0">
+                <a:solidFill>
+                  <a:srgbClr val="333D47"/>
+                </a:solidFill>
+                <a:latin typeface="Arial"/>
+                <a:ea typeface="Microsoft JhengHei"/>
+              </a:rPr>
+              <a:t>Predictable on receipt formats the rules already know.</a:t>
+            </a:r>
+          </a:p>
+          <a:p>
+            <a:pPr marL="182880" indent="-182880" algn="l">
+              <a:spcAft>
+                <a:spcPts val="0"/>
+              </a:spcAft>
+              <a:buFont typeface="Arial"/>
+              <a:buChar char="•"/>
+            </a:pPr>
+            <a:r>
+              <a:rPr sz="1300" b="1" i="0">
+                <a:solidFill>
+                  <a:srgbClr val="333D47"/>
+                </a:solidFill>
+                <a:latin typeface="Arial"/>
+                <a:ea typeface="Microsoft JhengHei"/>
+              </a:rPr>
+              <a:t>Measured: </a:t>
+            </a:r>
+            <a:r>
+              <a:rPr sz="1300" b="0" i="0">
+                <a:solidFill>
+                  <a:srgbClr val="333D47"/>
+                </a:solidFill>
+                <a:latin typeface="Arial"/>
+                <a:ea typeface="Microsoft JhengHei"/>
+              </a:rPr>
+              <a:t>88.2% after careful tuning (from 37.3%).</a:t>
+            </a:r>
+          </a:p>
+        </p:txBody>
+      </p:sp>
+      <p:sp>
+        <p:nvSpPr>
+          <p:cNvPr id="14" name="Rectangle 13"/>
+          <p:cNvSpPr/>
+          <p:nvPr/>
+        </p:nvSpPr>
+        <p:spPr>
+          <a:xfrm>
+            <a:off x="356616" y="3886200"/>
+            <a:ext cx="5600700" cy="1527048"/>
+          </a:xfrm>
+          <a:prstGeom prst="rect">
+            <a:avLst/>
+          </a:prstGeom>
+          <a:solidFill>
+            <a:srgbClr val="FBE7EC"/>
+          </a:solidFill>
+          <a:ln>
+            <a:noFill/>
+          </a:ln>
+        </p:spPr>
+        <p:txBody>
+          <a:bodyPr rtlCol="0" anchor="t" wrap="square" lIns="164592" rIns="164592" tIns="109728" bIns="109728"/>
+          <a:lstStyle/>
+          <a:p>
+            <a:pPr algn="l" marL="0" indent="0">
+              <a:spcAft>
+                <a:spcPts val="400"/>
+              </a:spcAft>
+              <a:buNone/>
+            </a:pPr>
+            <a:r>
+              <a:rPr sz="1500" b="1" i="0">
+                <a:solidFill>
+                  <a:srgbClr val="D31145"/>
+                </a:solidFill>
+                <a:latin typeface="Arial"/>
+                <a:ea typeface="Microsoft JhengHei"/>
+              </a:rPr>
+              <a:t>Cons</a:t>
+            </a:r>
+          </a:p>
+          <a:p>
+            <a:pPr marL="182880" indent="-182880" algn="l">
+              <a:spcAft>
+                <a:spcPts val="300"/>
+              </a:spcAft>
+              <a:buFont typeface="Arial"/>
+              <a:buChar char="•"/>
+            </a:pPr>
+            <a:r>
+              <a:rPr sz="1300" b="1" i="0">
+                <a:solidFill>
+                  <a:srgbClr val="333D47"/>
+                </a:solidFill>
+                <a:latin typeface="Arial"/>
+                <a:ea typeface="Microsoft JhengHei"/>
+              </a:rPr>
+              <a:t>Measured: </a:t>
+            </a:r>
+            <a:r>
+              <a:rPr sz="1300" b="0" i="0">
+                <a:solidFill>
+                  <a:srgbClr val="333D47"/>
+                </a:solidFill>
+                <a:latin typeface="Arial"/>
+                <a:ea typeface="Microsoft JhengHei"/>
+              </a:rPr>
+              <a:t>rules expanded by hand (69 → 225 label phrases).</a:t>
+            </a:r>
+          </a:p>
+          <a:p>
+            <a:pPr marL="182880" indent="-182880" algn="l">
+              <a:spcAft>
+                <a:spcPts val="300"/>
+              </a:spcAft>
+              <a:buFont typeface="Arial"/>
+              <a:buChar char="•"/>
+            </a:pPr>
+            <a:r>
+              <a:rPr sz="1300" b="0" i="0">
+                <a:solidFill>
+                  <a:srgbClr val="333D47"/>
+                </a:solidFill>
+                <a:latin typeface="Arial"/>
+                <a:ea typeface="Microsoft JhengHei"/>
+              </a:rPr>
+              <a:t>New languages, labels and layouts need more rule changes.</a:t>
+            </a:r>
+          </a:p>
+          <a:p>
+            <a:pPr marL="182880" indent="-182880" algn="l">
+              <a:spcAft>
+                <a:spcPts val="300"/>
+              </a:spcAft>
+              <a:buFont typeface="Arial"/>
+              <a:buChar char="•"/>
+            </a:pPr>
+            <a:r>
+              <a:rPr sz="1300" b="1" i="0">
+                <a:solidFill>
+                  <a:srgbClr val="333D47"/>
+                </a:solidFill>
+                <a:latin typeface="Arial"/>
+                <a:ea typeface="Microsoft JhengHei"/>
+              </a:rPr>
+              <a:t>Measured: </a:t>
+            </a:r>
+            <a:r>
+              <a:rPr sz="1300" b="0" i="0">
+                <a:solidFill>
+                  <a:srgbClr val="333D47"/>
+                </a:solidFill>
+                <a:latin typeface="Arial"/>
+                <a:ea typeface="Microsoft JhengHei"/>
+              </a:rPr>
+              <a:t>a rule update broke a receipt that was already correct.</a:t>
+            </a:r>
+          </a:p>
+          <a:p>
+            <a:pPr marL="182880" indent="-182880" algn="l">
+              <a:spcAft>
+                <a:spcPts val="0"/>
+              </a:spcAft>
+              <a:buFont typeface="Arial"/>
+              <a:buChar char="•"/>
+            </a:pPr>
+            <a:r>
+              <a:rPr sz="1300" b="0" i="0">
+                <a:solidFill>
+                  <a:srgbClr val="333D47"/>
+                </a:solidFill>
+                <a:latin typeface="Arial"/>
+                <a:ea typeface="Microsoft JhengHei"/>
+              </a:rPr>
+              <a:t>Accuracy on unseen receipt formats is unknown.</a:t>
+            </a:r>
+          </a:p>
+        </p:txBody>
+      </p:sp>
+      <p:sp>
+        <p:nvSpPr>
+          <p:cNvPr id="15" name="Rectangle 14"/>
+          <p:cNvSpPr/>
+          <p:nvPr/>
+        </p:nvSpPr>
+        <p:spPr>
+          <a:xfrm>
+            <a:off x="6231636" y="1783080"/>
+            <a:ext cx="5600700" cy="411480"/>
+          </a:xfrm>
+          <a:prstGeom prst="rect">
+            <a:avLst/>
+          </a:prstGeom>
+          <a:solidFill>
+            <a:srgbClr val="333D47"/>
+          </a:solidFill>
+          <a:ln>
+            <a:noFill/>
+          </a:ln>
+        </p:spPr>
+        <p:txBody>
+          <a:bodyPr rtlCol="0" anchor="ctr" wrap="square" lIns="164592" rIns="164592" tIns="109728" bIns="109728"/>
+          <a:lstStyle/>
+          <a:p>
+            <a:pPr algn="l" marL="0" indent="0">
+              <a:spcAft>
+                <a:spcPts val="0"/>
+              </a:spcAft>
+              <a:buNone/>
+            </a:pPr>
+            <a:r>
+              <a:rPr sz="1600" b="1" i="0">
+                <a:solidFill>
+                  <a:srgbClr val="FFFFFF"/>
+                </a:solidFill>
+                <a:latin typeface="Arial"/>
+                <a:ea typeface="Microsoft JhengHei"/>
+              </a:rPr>
+              <a:t>Azure DI + AOAI</a:t>
+            </a:r>
+          </a:p>
+        </p:txBody>
+      </p:sp>
+      <p:sp>
+        <p:nvSpPr>
+          <p:cNvPr id="16" name="Rectangle 15"/>
+          <p:cNvSpPr/>
+          <p:nvPr/>
+        </p:nvSpPr>
+        <p:spPr>
+          <a:xfrm>
+            <a:off x="6231636" y="2286000"/>
+            <a:ext cx="5600700" cy="1527048"/>
+          </a:xfrm>
+          <a:prstGeom prst="rect">
+            <a:avLst/>
+          </a:prstGeom>
+          <a:solidFill>
+            <a:srgbClr val="E6F2EA"/>
+          </a:solidFill>
+          <a:ln>
+            <a:noFill/>
+          </a:ln>
+        </p:spPr>
+        <p:txBody>
+          <a:bodyPr rtlCol="0" anchor="t" wrap="square" lIns="164592" rIns="164592" tIns="109728" bIns="109728"/>
+          <a:lstStyle/>
+          <a:p>
+            <a:pPr algn="l" marL="0" indent="0">
+              <a:spcAft>
+                <a:spcPts val="400"/>
+              </a:spcAft>
+              <a:buNone/>
+            </a:pPr>
+            <a:r>
+              <a:rPr sz="1500" b="1" i="0">
+                <a:solidFill>
+                  <a:srgbClr val="1E7B4A"/>
+                </a:solidFill>
+                <a:latin typeface="Arial"/>
+                <a:ea typeface="Microsoft JhengHei"/>
+              </a:rPr>
+              <a:t>Pros</a:t>
+            </a:r>
+          </a:p>
+          <a:p>
+            <a:pPr marL="182880" indent="-182880" algn="l">
+              <a:spcAft>
+                <a:spcPts val="300"/>
+              </a:spcAft>
+              <a:buFont typeface="Arial"/>
+              <a:buChar char="•"/>
+            </a:pPr>
+            <a:r>
+              <a:rPr sz="1300" b="1" i="0">
+                <a:solidFill>
+                  <a:srgbClr val="333D47"/>
+                </a:solidFill>
+                <a:latin typeface="Arial"/>
+                <a:ea typeface="Microsoft JhengHei"/>
+              </a:rPr>
+              <a:t>Measured: </a:t>
+            </a:r>
+            <a:r>
+              <a:rPr sz="1300" b="0" i="0">
+                <a:solidFill>
+                  <a:srgbClr val="333D47"/>
+                </a:solidFill>
+                <a:latin typeface="Arial"/>
+                <a:ea typeface="Microsoft JhengHei"/>
+              </a:rPr>
+              <a:t>88.2% with the prompt unchanged.</a:t>
+            </a:r>
+          </a:p>
+          <a:p>
+            <a:pPr marL="182880" indent="-182880" algn="l">
+              <a:spcAft>
+                <a:spcPts val="300"/>
+              </a:spcAft>
+              <a:buFont typeface="Arial"/>
+              <a:buChar char="•"/>
+            </a:pPr>
+            <a:r>
+              <a:rPr sz="1300" b="0" i="0">
+                <a:solidFill>
+                  <a:srgbClr val="333D47"/>
+                </a:solidFill>
+                <a:latin typeface="Arial"/>
+                <a:ea typeface="Microsoft JhengHei"/>
+              </a:rPr>
+              <a:t>Reduces the need to write detailed extraction rules.</a:t>
+            </a:r>
+          </a:p>
+          <a:p>
+            <a:pPr marL="182880" indent="-182880" algn="l">
+              <a:spcAft>
+                <a:spcPts val="300"/>
+              </a:spcAft>
+              <a:buFont typeface="Arial"/>
+              <a:buChar char="•"/>
+            </a:pPr>
+            <a:r>
+              <a:rPr sz="1300" b="1" i="0">
+                <a:solidFill>
+                  <a:srgbClr val="333D47"/>
+                </a:solidFill>
+                <a:latin typeface="Arial"/>
+                <a:ea typeface="Microsoft JhengHei"/>
+              </a:rPr>
+              <a:t>Measured: </a:t>
+            </a:r>
+            <a:r>
+              <a:rPr sz="1300" b="0" i="0">
+                <a:solidFill>
+                  <a:srgbClr val="333D47"/>
+                </a:solidFill>
+                <a:latin typeface="Arial"/>
+                <a:ea typeface="Microsoft JhengHei"/>
+              </a:rPr>
+              <a:t>6/6 fields on both the bilingual and Chinese examples.</a:t>
+            </a:r>
+          </a:p>
+          <a:p>
+            <a:pPr marL="182880" indent="-182880" algn="l">
+              <a:spcAft>
+                <a:spcPts val="0"/>
+              </a:spcAft>
+              <a:buFont typeface="Arial"/>
+              <a:buChar char="•"/>
+            </a:pPr>
+            <a:r>
+              <a:rPr sz="1300" b="1" i="0">
+                <a:solidFill>
+                  <a:srgbClr val="333D47"/>
+                </a:solidFill>
+                <a:latin typeface="Arial"/>
+                <a:ea typeface="Microsoft JhengHei"/>
+              </a:rPr>
+              <a:t>Measured: </a:t>
+            </a:r>
+            <a:r>
+              <a:rPr sz="1300" b="0" i="0">
+                <a:solidFill>
+                  <a:srgbClr val="333D47"/>
+                </a:solidFill>
+                <a:latin typeface="Arial"/>
+                <a:ea typeface="Microsoft JhengHei"/>
+              </a:rPr>
+              <a:t>faster, 6.2 s vs 13.9 s per receipt.</a:t>
+            </a:r>
+          </a:p>
+        </p:txBody>
+      </p:sp>
+      <p:sp>
+        <p:nvSpPr>
+          <p:cNvPr id="17" name="Rectangle 16"/>
+          <p:cNvSpPr/>
+          <p:nvPr/>
+        </p:nvSpPr>
+        <p:spPr>
+          <a:xfrm>
+            <a:off x="6231636" y="3886200"/>
+            <a:ext cx="5600700" cy="1527048"/>
+          </a:xfrm>
+          <a:prstGeom prst="rect">
+            <a:avLst/>
+          </a:prstGeom>
+          <a:solidFill>
+            <a:srgbClr val="FBE7EC"/>
+          </a:solidFill>
+          <a:ln>
+            <a:noFill/>
+          </a:ln>
+        </p:spPr>
+        <p:txBody>
+          <a:bodyPr rtlCol="0" anchor="t" wrap="square" lIns="164592" rIns="164592" tIns="109728" bIns="109728"/>
+          <a:lstStyle/>
+          <a:p>
+            <a:pPr algn="l" marL="0" indent="0">
+              <a:spcAft>
+                <a:spcPts val="400"/>
+              </a:spcAft>
+              <a:buNone/>
+            </a:pPr>
+            <a:r>
+              <a:rPr sz="1500" b="1" i="0">
+                <a:solidFill>
+                  <a:srgbClr val="D31145"/>
+                </a:solidFill>
+                <a:latin typeface="Arial"/>
+                <a:ea typeface="Microsoft JhengHei"/>
+              </a:rPr>
+              <a:t>Cons</a:t>
+            </a:r>
+          </a:p>
+          <a:p>
+            <a:pPr marL="182880" indent="-182880" algn="l">
+              <a:spcAft>
+                <a:spcPts val="300"/>
+              </a:spcAft>
+              <a:buFont typeface="Arial"/>
+              <a:buChar char="•"/>
+            </a:pPr>
+            <a:r>
+              <a:rPr sz="1300" b="0" i="0">
+                <a:solidFill>
+                  <a:srgbClr val="333D47"/>
+                </a:solidFill>
+                <a:latin typeface="Arial"/>
+                <a:ea typeface="Microsoft JhengHei"/>
+              </a:rPr>
+              <a:t>Needs Azure services and per-request API fees.</a:t>
+            </a:r>
+          </a:p>
+          <a:p>
+            <a:pPr marL="182880" indent="-182880" algn="l">
+              <a:spcAft>
+                <a:spcPts val="300"/>
+              </a:spcAft>
+              <a:buFont typeface="Arial"/>
+              <a:buChar char="•"/>
+            </a:pPr>
+            <a:r>
+              <a:rPr sz="1300" b="1" i="0">
+                <a:solidFill>
+                  <a:srgbClr val="333D47"/>
+                </a:solidFill>
+                <a:latin typeface="Arial"/>
+                <a:ea typeface="Microsoft JhengHei"/>
+              </a:rPr>
+              <a:t>Measured: </a:t>
+            </a:r>
+            <a:r>
+              <a:rPr sz="1300" b="0" i="0">
+                <a:solidFill>
+                  <a:srgbClr val="333D47"/>
+                </a:solidFill>
+                <a:latin typeface="Arial"/>
+                <a:ea typeface="Microsoft JhengHei"/>
+              </a:rPr>
+              <a:t>wrong value even though the OCR text was correct.</a:t>
+            </a:r>
+          </a:p>
+          <a:p>
+            <a:pPr marL="182880" indent="-182880" algn="l">
+              <a:spcAft>
+                <a:spcPts val="300"/>
+              </a:spcAft>
+              <a:buFont typeface="Arial"/>
+              <a:buChar char="•"/>
+            </a:pPr>
+            <a:r>
+              <a:rPr sz="1300" b="0" i="0">
+                <a:solidFill>
+                  <a:srgbClr val="333D47"/>
+                </a:solidFill>
+                <a:latin typeface="Arial"/>
+                <a:ea typeface="Microsoft JhengHei"/>
+              </a:rPr>
+              <a:t>Results may vary, so validation and error handling are needed.</a:t>
+            </a:r>
+          </a:p>
+          <a:p>
+            <a:pPr marL="182880" indent="-182880" algn="l">
+              <a:spcAft>
+                <a:spcPts val="0"/>
+              </a:spcAft>
+              <a:buFont typeface="Arial"/>
+              <a:buChar char="•"/>
+            </a:pPr>
+            <a:r>
+              <a:rPr sz="1300" b="0" i="0">
+                <a:solidFill>
+                  <a:srgbClr val="333D47"/>
+                </a:solidFill>
+                <a:latin typeface="Arial"/>
+                <a:ea typeface="Microsoft JhengHei"/>
+              </a:rPr>
+              <a:t>Accuracy and maintenance effort on unseen receipts not yet proven.</a:t>
+            </a:r>
+          </a:p>
+        </p:txBody>
+      </p:sp>
+      <p:sp>
+        <p:nvSpPr>
+          <p:cNvPr id="18" name="Rectangle 17"/>
+          <p:cNvSpPr/>
+          <p:nvPr/>
+        </p:nvSpPr>
+        <p:spPr>
+          <a:xfrm>
+            <a:off x="356616" y="5486400"/>
+            <a:ext cx="10607040" cy="411480"/>
           </a:xfrm>
           <a:prstGeom prst="rect">
             <a:avLst/>
@@ -12472,288 +13627,34 @@
           </a:ln>
         </p:spPr>
         <p:txBody>
-          <a:bodyPr rtlCol="0" anchor="t" wrap="square" lIns="274320" rIns="274320" tIns="109728" bIns="109728"/>
+          <a:bodyPr rtlCol="0" anchor="ctr" wrap="square" lIns="164592" rIns="164592" tIns="109728" bIns="109728"/>
           <a:lstStyle/>
           <a:p>
-            <a:pPr algn="l" marL="182880" indent="-182880">
-              <a:spcAft>
-                <a:spcPts val="600"/>
-              </a:spcAft>
-              <a:buFont typeface="Arial"/>
-              <a:buChar char="•"/>
-            </a:pPr>
-            <a:r>
-              <a:rPr sz="1600" b="0" i="0">
-                <a:solidFill>
-                  <a:srgbClr val="333D47"/>
-                </a:solidFill>
-                <a:latin typeface="Arial"/>
-                <a:ea typeface="Microsoft JhengHei"/>
-              </a:rPr>
-              <a:t>PaddleOCR Light + improved rules and Azure DI + AOAI both reached 88.2% on this benchmark.</a:t>
-            </a:r>
-          </a:p>
-          <a:p>
-            <a:pPr marL="182880" indent="-182880" algn="l">
-              <a:spcAft>
-                <a:spcPts val="600"/>
-              </a:spcAft>
-              <a:buFont typeface="Arial"/>
-              <a:buChar char="•"/>
-            </a:pPr>
-            <a:r>
-              <a:rPr sz="1600" b="0" i="0">
-                <a:solidFill>
-                  <a:srgbClr val="333D47"/>
-                </a:solidFill>
-                <a:latin typeface="Arial"/>
-                <a:ea typeface="Microsoft JhengHei"/>
-              </a:rPr>
-              <a:t>PaddleOCR Light needed manual rule tuning to get there. Azure DI + AOAI reached the same accuracy without changing its prompt.</a:t>
-            </a:r>
-          </a:p>
-          <a:p>
-            <a:pPr marL="182880" indent="-182880" algn="l">
-              <a:spcAft>
-                <a:spcPts val="0"/>
-              </a:spcAft>
-              <a:buFont typeface="Arial"/>
-              <a:buChar char="•"/>
-            </a:pPr>
-            <a:r>
-              <a:rPr sz="1600" b="1" i="0">
-                <a:solidFill>
-                  <a:srgbClr val="333D47"/>
-                </a:solidFill>
-                <a:latin typeface="Arial"/>
-                <a:ea typeface="Microsoft JhengHei"/>
-              </a:rPr>
-              <a:t>So the choice is whether to keep writing and maintaining extraction rules, or to use AI for that layer.</a:t>
-            </a:r>
-          </a:p>
-        </p:txBody>
-      </p:sp>
-      <p:sp>
-        <p:nvSpPr>
-          <p:cNvPr id="13" name="Rectangle 12"/>
-          <p:cNvSpPr/>
-          <p:nvPr/>
-        </p:nvSpPr>
-        <p:spPr>
-          <a:xfrm>
-            <a:off x="356616" y="3520440"/>
-            <a:ext cx="3642360" cy="1280160"/>
-          </a:xfrm>
-          <a:prstGeom prst="rect">
-            <a:avLst/>
-          </a:prstGeom>
-          <a:solidFill>
-            <a:srgbClr val="F2F2F2"/>
-          </a:solidFill>
-          <a:ln>
-            <a:noFill/>
-          </a:ln>
-        </p:spPr>
-        <p:txBody>
-          <a:bodyPr rtlCol="0" anchor="t" wrap="square" lIns="201168" rIns="201168" tIns="109728" bIns="109728"/>
-          <a:lstStyle/>
-          <a:p>
             <a:pPr algn="l" marL="0" indent="0">
-              <a:spcAft>
-                <a:spcPts val="600"/>
-              </a:spcAft>
-              <a:buNone/>
-            </a:pPr>
-            <a:r>
-              <a:rPr sz="1600" b="1" i="0">
-                <a:solidFill>
-                  <a:srgbClr val="D31145"/>
-                </a:solidFill>
-                <a:latin typeface="Arial"/>
-                <a:ea typeface="Microsoft JhengHei"/>
-              </a:rPr>
-              <a:t>1. Freeze both</a:t>
-            </a:r>
-          </a:p>
-          <a:p>
-            <a:pPr marL="0" indent="0" algn="l">
               <a:spcAft>
                 <a:spcPts val="0"/>
               </a:spcAft>
               <a:buNone/>
             </a:pPr>
             <a:r>
-              <a:rPr sz="1400" b="0" i="0">
+              <a:rPr sz="1400" b="1" i="0">
                 <a:solidFill>
                   <a:srgbClr val="333D47"/>
                 </a:solidFill>
                 <a:latin typeface="Arial"/>
                 <a:ea typeface="Microsoft JhengHei"/>
               </a:rPr>
-              <a:t>Lock the improved rules and the AOAI prompt.</a:t>
-            </a:r>
-          </a:p>
-        </p:txBody>
-      </p:sp>
-      <p:sp>
-        <p:nvSpPr>
-          <p:cNvPr id="14" name="Rectangle 13"/>
-          <p:cNvSpPr/>
-          <p:nvPr/>
-        </p:nvSpPr>
-        <p:spPr>
-          <a:xfrm>
-            <a:off x="4273296" y="3520440"/>
-            <a:ext cx="3642360" cy="1280160"/>
-          </a:xfrm>
-          <a:prstGeom prst="rect">
-            <a:avLst/>
-          </a:prstGeom>
-          <a:solidFill>
-            <a:srgbClr val="F2F2F2"/>
-          </a:solidFill>
-          <a:ln>
-            <a:noFill/>
-          </a:ln>
-        </p:spPr>
-        <p:txBody>
-          <a:bodyPr rtlCol="0" anchor="t" wrap="square" lIns="201168" rIns="201168" tIns="109728" bIns="109728"/>
-          <a:lstStyle/>
-          <a:p>
-            <a:pPr algn="l" marL="0" indent="0">
-              <a:spcAft>
-                <a:spcPts val="600"/>
-              </a:spcAft>
-              <a:buNone/>
-            </a:pPr>
-            <a:r>
-              <a:rPr sz="1600" b="1" i="0">
-                <a:solidFill>
-                  <a:srgbClr val="D31145"/>
+              <a:t>The decision is not only accuracy or API cost: </a:t>
+            </a:r>
+            <a:r>
+              <a:rPr sz="1400" b="0" i="0">
+                <a:solidFill>
+                  <a:srgbClr val="333D47"/>
                 </a:solidFill>
                 <a:latin typeface="Arial"/>
                 <a:ea typeface="Microsoft JhengHei"/>
               </a:rPr>
-              <a:t>2. Test on unseen receipts</a:t>
-            </a:r>
-          </a:p>
-          <a:p>
-            <a:pPr marL="0" indent="0" algn="l">
-              <a:spcAft>
-                <a:spcPts val="0"/>
-              </a:spcAft>
-              <a:buNone/>
-            </a:pPr>
-            <a:r>
-              <a:rPr sz="1400" b="0" i="0">
-                <a:solidFill>
-                  <a:srgbClr val="333D47"/>
-                </a:solidFill>
-                <a:latin typeface="Arial"/>
-                <a:ea typeface="Microsoft JhengHei"/>
-              </a:rPr>
-              <a:t>30+ real, anonymised receipts. Measure accuracy and count the rule changes needed.</a:t>
-            </a:r>
-          </a:p>
-        </p:txBody>
-      </p:sp>
-      <p:sp>
-        <p:nvSpPr>
-          <p:cNvPr id="15" name="Rectangle 14"/>
-          <p:cNvSpPr/>
-          <p:nvPr/>
-        </p:nvSpPr>
-        <p:spPr>
-          <a:xfrm>
-            <a:off x="8189976" y="3520440"/>
-            <a:ext cx="3642360" cy="1280160"/>
-          </a:xfrm>
-          <a:prstGeom prst="rect">
-            <a:avLst/>
-          </a:prstGeom>
-          <a:solidFill>
-            <a:srgbClr val="F2F2F2"/>
-          </a:solidFill>
-          <a:ln>
-            <a:noFill/>
-          </a:ln>
-        </p:spPr>
-        <p:txBody>
-          <a:bodyPr rtlCol="0" anchor="t" wrap="square" lIns="201168" rIns="201168" tIns="109728" bIns="109728"/>
-          <a:lstStyle/>
-          <a:p>
-            <a:pPr algn="l" marL="0" indent="0">
-              <a:spcAft>
-                <a:spcPts val="600"/>
-              </a:spcAft>
-              <a:buNone/>
-            </a:pPr>
-            <a:r>
-              <a:rPr sz="1600" b="1" i="0">
-                <a:solidFill>
-                  <a:srgbClr val="D31145"/>
-                </a:solidFill>
-                <a:latin typeface="Arial"/>
-                <a:ea typeface="Microsoft JhengHei"/>
-              </a:rPr>
-              <a:t>3. Then compare cost</a:t>
-            </a:r>
-          </a:p>
-          <a:p>
-            <a:pPr marL="0" indent="0" algn="l">
-              <a:spcAft>
-                <a:spcPts val="0"/>
-              </a:spcAft>
-              <a:buNone/>
-            </a:pPr>
-            <a:r>
-              <a:rPr sz="1400" b="0" i="0">
-                <a:solidFill>
-                  <a:srgbClr val="333D47"/>
-                </a:solidFill>
-                <a:latin typeface="Arial"/>
-                <a:ea typeface="Microsoft JhengHei"/>
-              </a:rPr>
-              <a:t>Compute, Document Intelligence pages and gpt-5-mini tokens.</a:t>
-            </a:r>
-          </a:p>
-        </p:txBody>
-      </p:sp>
-      <p:sp>
-        <p:nvSpPr>
-          <p:cNvPr id="16" name="TextBox 15"/>
-          <p:cNvSpPr txBox="1"/>
-          <p:nvPr/>
-        </p:nvSpPr>
-        <p:spPr>
-          <a:xfrm>
-            <a:off x="356616" y="5029200"/>
-            <a:ext cx="10972800" cy="320040"/>
-          </a:xfrm>
-          <a:prstGeom prst="rect">
-            <a:avLst/>
-          </a:prstGeom>
-          <a:noFill/>
-        </p:spPr>
-        <p:txBody>
-          <a:bodyPr wrap="square" lIns="0" rIns="0" tIns="0" bIns="0" anchor="t"/>
-          <a:lstStyle/>
-          <a:p>
-            <a:pPr marL="0" indent="0" algn="l">
-              <a:spcAft>
-                <a:spcPts val="0"/>
-              </a:spcAft>
-              <a:buNone/>
-            </a:pPr>
-            <a:r>
-              <a:rPr sz="1100" b="0" i="1">
-                <a:solidFill>
-                  <a:srgbClr val="5F6770"/>
-                </a:solidFill>
-                <a:latin typeface="Arial"/>
-                <a:ea typeface="Microsoft JhengHei"/>
-              </a:rPr>
-              <a:t>Limitation: 9 receipts, mostly printed mock receipts; the improved rules were tuned on them. AOAI still makes mistakes and has not been tested on a large unseen set.</a:t>
+              <a:t>it is how much development and ongoing maintenance we want to own.</a:t>
             </a:r>
           </a:p>
         </p:txBody>

</xml_diff>

<commit_message>
OCR benchmark deck V2: rewrite slide 9 pros and cons
- Each column now opens with its main message: rules may need manual
  updates for new formats, which can break working cases; AOAI is
  expected to need less rule maintenance, with accuracy depending on
  the model, OCR output and prompt.
- Three pros and three cons per approach; "Measured" marks benchmark
  results. Both 88.2%, AOAI with no prompt changes. No claim of zero
  maintenance or that every new layout needs a rule update.
- Archive the previous 10-slide deck (as saved in PowerPoint) in
  archive/v2_10slides/. Other slides unchanged.

Co-Authored-By: Claude Opus 5.5 <noreply@anthropic.com>
</commit_message>
<xml_diff>
--- a/ppt/ocr_benchmark/current/OCR_Benchmark_V2.pptx
+++ b/ppt/ocr_benchmark/current/OCR_Benchmark_V2.pptx
@@ -5,22 +5,22 @@
     <p:sldMasterId id="2147483648" r:id="rId1"/>
   </p:sldMasterIdLst>
   <p:notesMasterIdLst>
-    <p:notesMasterId r:id="rId12"/>
+    <p:notesMasterId r:id="rId5"/>
   </p:notesMasterIdLst>
   <p:handoutMasterIdLst>
-    <p:handoutMasterId r:id="rId13"/>
+    <p:handoutMasterId r:id="rId6"/>
   </p:handoutMasterIdLst>
   <p:sldIdLst>
-    <p:sldId id="256" r:id="rId2"/>
+    <p:sldId id="256" r:id="rId4"/>
     <p:sldId id="257" r:id="rId3"/>
-    <p:sldId id="258" r:id="rId4"/>
-    <p:sldId id="259" r:id="rId5"/>
-    <p:sldId id="260" r:id="rId6"/>
-    <p:sldId id="261" r:id="rId7"/>
-    <p:sldId id="262" r:id="rId8"/>
-    <p:sldId id="263" r:id="rId9"/>
-    <p:sldId id="264" r:id="rId10"/>
-    <p:sldId id="265" r:id="rId11"/>
+    <p:sldId id="258" r:id="rId2"/>
+    <p:sldId id="259" r:id="rId11"/>
+    <p:sldId id="260" r:id="rId12"/>
+    <p:sldId id="261" r:id="rId13"/>
+    <p:sldId id="262" r:id="rId14"/>
+    <p:sldId id="263" r:id="rId15"/>
+    <p:sldId id="264" r:id="rId16"/>
+    <p:sldId id="265" r:id="rId17"/>
   </p:sldIdLst>
   <p:sldSz cx="12192000" cy="6858000"/>
   <p:notesSz cx="6858000" cy="9144000"/>
@@ -223,7 +223,7 @@
           <a:p>
             <a:fld id="{C3218ECE-A34A-49B3-9686-CAB705FE9FAE}" type="datetimeFigureOut">
               <a:rPr lang="en-GB" smtClean="0"/>
-              <a:t>14/10/2026</a:t>
+              <a:t>23/09/2026</a:t>
             </a:fld>
             <a:endParaRPr lang="en-GB"/>
           </a:p>
@@ -389,7 +389,7 @@
           <a:p>
             <a:fld id="{BFECA36D-3A4E-49AB-8998-33E386CC9347}" type="datetimeFigureOut">
               <a:rPr lang="en-US" smtClean="0"/>
-              <a:t>10/14/2026</a:t>
+              <a:t>9/23/2026</a:t>
             </a:fld>
             <a:endParaRPr lang="en-US"/>
           </a:p>
@@ -658,7 +658,7 @@
 </file>
 
 <file path=ppt/notesSlides/notesSlide1.xml><?xml version="1.0" encoding="utf-8"?>
-<p:notes xmlns:a="http://schemas.openxmlformats.org/drawingml/2006/main" xmlns:r="http://schemas.openxmlformats.org/officeDocument/2006/relationships" xmlns:p="http://schemas.openxmlformats.org/presentationml/2006/main">
+<p:notes xmlns:a="http://schemas.openxmlformats.org/drawingml/2006/main" xmlns:p="http://schemas.openxmlformats.org/presentationml/2006/main" xmlns:r="http://schemas.openxmlformats.org/officeDocument/2006/relationships">
   <p:cSld>
     <p:spTree>
       <p:nvGrpSpPr>
@@ -678,7 +678,7 @@
         <p:nvSpPr>
           <p:cNvPr id="2" name="Slide Image Placeholder 1"/>
           <p:cNvSpPr>
-            <a:spLocks noGrp="1" noRot="1" noChangeAspect="1"/>
+            <a:spLocks noGrp="1"/>
           </p:cNvSpPr>
           <p:nvPr>
             <p:ph type="sldImg" idx="2"/>
@@ -693,7 +693,7 @@
             <a:spLocks noGrp="1"/>
           </p:cNvSpPr>
           <p:nvPr>
-            <p:ph type="body" sz="quarter" idx="3"/>
+            <p:ph type="body" idx="3" sz="quarter"/>
           </p:nvPr>
         </p:nvSpPr>
         <p:spPr/>
@@ -714,7 +714,7 @@
             <a:spLocks noGrp="1"/>
           </p:cNvSpPr>
           <p:nvPr>
-            <p:ph type="sldNum" sz="quarter" idx="5"/>
+            <p:ph type="sldNum" idx="5" sz="quarter"/>
           </p:nvPr>
         </p:nvSpPr>
         <p:spPr/>
@@ -728,7 +728,7 @@
 </file>
 
 <file path=ppt/notesSlides/notesSlide10.xml><?xml version="1.0" encoding="utf-8"?>
-<p:notes xmlns:a="http://schemas.openxmlformats.org/drawingml/2006/main" xmlns:r="http://schemas.openxmlformats.org/officeDocument/2006/relationships" xmlns:p="http://schemas.openxmlformats.org/presentationml/2006/main">
+<p:notes xmlns:a="http://schemas.openxmlformats.org/drawingml/2006/main" xmlns:p="http://schemas.openxmlformats.org/presentationml/2006/main" xmlns:r="http://schemas.openxmlformats.org/officeDocument/2006/relationships">
   <p:cSld>
     <p:spTree>
       <p:nvGrpSpPr>
@@ -748,7 +748,7 @@
         <p:nvSpPr>
           <p:cNvPr id="2" name="Slide Image Placeholder 1"/>
           <p:cNvSpPr>
-            <a:spLocks noGrp="1" noRot="1" noChangeAspect="1"/>
+            <a:spLocks noGrp="1"/>
           </p:cNvSpPr>
           <p:nvPr>
             <p:ph type="sldImg" idx="2"/>
@@ -763,7 +763,7 @@
             <a:spLocks noGrp="1"/>
           </p:cNvSpPr>
           <p:nvPr>
-            <p:ph type="body" sz="quarter" idx="3"/>
+            <p:ph type="body" idx="3" sz="quarter"/>
           </p:nvPr>
         </p:nvSpPr>
         <p:spPr/>
@@ -784,7 +784,7 @@
             <a:spLocks noGrp="1"/>
           </p:cNvSpPr>
           <p:nvPr>
-            <p:ph type="sldNum" sz="quarter" idx="5"/>
+            <p:ph type="sldNum" idx="5" sz="quarter"/>
           </p:nvPr>
         </p:nvSpPr>
         <p:spPr/>
@@ -798,7 +798,7 @@
 </file>
 
 <file path=ppt/notesSlides/notesSlide2.xml><?xml version="1.0" encoding="utf-8"?>
-<p:notes xmlns:a="http://schemas.openxmlformats.org/drawingml/2006/main" xmlns:r="http://schemas.openxmlformats.org/officeDocument/2006/relationships" xmlns:p="http://schemas.openxmlformats.org/presentationml/2006/main">
+<p:notes xmlns:a="http://schemas.openxmlformats.org/drawingml/2006/main" xmlns:p="http://schemas.openxmlformats.org/presentationml/2006/main" xmlns:r="http://schemas.openxmlformats.org/officeDocument/2006/relationships">
   <p:cSld>
     <p:spTree>
       <p:nvGrpSpPr>
@@ -818,7 +818,7 @@
         <p:nvSpPr>
           <p:cNvPr id="2" name="Slide Image Placeholder 1"/>
           <p:cNvSpPr>
-            <a:spLocks noGrp="1" noRot="1" noChangeAspect="1"/>
+            <a:spLocks noGrp="1"/>
           </p:cNvSpPr>
           <p:nvPr>
             <p:ph type="sldImg" idx="2"/>
@@ -833,7 +833,7 @@
             <a:spLocks noGrp="1"/>
           </p:cNvSpPr>
           <p:nvPr>
-            <p:ph type="body" sz="quarter" idx="3"/>
+            <p:ph type="body" idx="3" sz="quarter"/>
           </p:nvPr>
         </p:nvSpPr>
         <p:spPr/>
@@ -854,7 +854,7 @@
             <a:spLocks noGrp="1"/>
           </p:cNvSpPr>
           <p:nvPr>
-            <p:ph type="sldNum" sz="quarter" idx="5"/>
+            <p:ph type="sldNum" idx="5" sz="quarter"/>
           </p:nvPr>
         </p:nvSpPr>
         <p:spPr/>
@@ -868,7 +868,7 @@
 </file>
 
 <file path=ppt/notesSlides/notesSlide3.xml><?xml version="1.0" encoding="utf-8"?>
-<p:notes xmlns:a="http://schemas.openxmlformats.org/drawingml/2006/main" xmlns:r="http://schemas.openxmlformats.org/officeDocument/2006/relationships" xmlns:p="http://schemas.openxmlformats.org/presentationml/2006/main">
+<p:notes xmlns:a="http://schemas.openxmlformats.org/drawingml/2006/main" xmlns:p="http://schemas.openxmlformats.org/presentationml/2006/main" xmlns:r="http://schemas.openxmlformats.org/officeDocument/2006/relationships">
   <p:cSld>
     <p:spTree>
       <p:nvGrpSpPr>
@@ -888,7 +888,7 @@
         <p:nvSpPr>
           <p:cNvPr id="2" name="Slide Image Placeholder 1"/>
           <p:cNvSpPr>
-            <a:spLocks noGrp="1" noRot="1" noChangeAspect="1"/>
+            <a:spLocks noGrp="1"/>
           </p:cNvSpPr>
           <p:nvPr>
             <p:ph type="sldImg" idx="2"/>
@@ -903,7 +903,7 @@
             <a:spLocks noGrp="1"/>
           </p:cNvSpPr>
           <p:nvPr>
-            <p:ph type="body" sz="quarter" idx="3"/>
+            <p:ph type="body" idx="3" sz="quarter"/>
           </p:nvPr>
         </p:nvSpPr>
         <p:spPr/>
@@ -924,7 +924,7 @@
             <a:spLocks noGrp="1"/>
           </p:cNvSpPr>
           <p:nvPr>
-            <p:ph type="sldNum" sz="quarter" idx="5"/>
+            <p:ph type="sldNum" idx="5" sz="quarter"/>
           </p:nvPr>
         </p:nvSpPr>
         <p:spPr/>
@@ -938,7 +938,7 @@
 </file>
 
 <file path=ppt/notesSlides/notesSlide4.xml><?xml version="1.0" encoding="utf-8"?>
-<p:notes xmlns:a="http://schemas.openxmlformats.org/drawingml/2006/main" xmlns:r="http://schemas.openxmlformats.org/officeDocument/2006/relationships" xmlns:p="http://schemas.openxmlformats.org/presentationml/2006/main">
+<p:notes xmlns:a="http://schemas.openxmlformats.org/drawingml/2006/main" xmlns:p="http://schemas.openxmlformats.org/presentationml/2006/main" xmlns:r="http://schemas.openxmlformats.org/officeDocument/2006/relationships">
   <p:cSld>
     <p:spTree>
       <p:nvGrpSpPr>
@@ -958,7 +958,7 @@
         <p:nvSpPr>
           <p:cNvPr id="2" name="Slide Image Placeholder 1"/>
           <p:cNvSpPr>
-            <a:spLocks noGrp="1" noRot="1" noChangeAspect="1"/>
+            <a:spLocks noGrp="1"/>
           </p:cNvSpPr>
           <p:nvPr>
             <p:ph type="sldImg" idx="2"/>
@@ -973,7 +973,7 @@
             <a:spLocks noGrp="1"/>
           </p:cNvSpPr>
           <p:nvPr>
-            <p:ph type="body" sz="quarter" idx="3"/>
+            <p:ph type="body" idx="3" sz="quarter"/>
           </p:nvPr>
         </p:nvSpPr>
         <p:spPr/>
@@ -994,7 +994,7 @@
             <a:spLocks noGrp="1"/>
           </p:cNvSpPr>
           <p:nvPr>
-            <p:ph type="sldNum" sz="quarter" idx="5"/>
+            <p:ph type="sldNum" idx="5" sz="quarter"/>
           </p:nvPr>
         </p:nvSpPr>
         <p:spPr/>
@@ -1008,7 +1008,7 @@
 </file>
 
 <file path=ppt/notesSlides/notesSlide5.xml><?xml version="1.0" encoding="utf-8"?>
-<p:notes xmlns:a="http://schemas.openxmlformats.org/drawingml/2006/main" xmlns:r="http://schemas.openxmlformats.org/officeDocument/2006/relationships" xmlns:p="http://schemas.openxmlformats.org/presentationml/2006/main">
+<p:notes xmlns:a="http://schemas.openxmlformats.org/drawingml/2006/main" xmlns:p="http://schemas.openxmlformats.org/presentationml/2006/main" xmlns:r="http://schemas.openxmlformats.org/officeDocument/2006/relationships">
   <p:cSld>
     <p:spTree>
       <p:nvGrpSpPr>
@@ -1028,7 +1028,7 @@
         <p:nvSpPr>
           <p:cNvPr id="2" name="Slide Image Placeholder 1"/>
           <p:cNvSpPr>
-            <a:spLocks noGrp="1" noRot="1" noChangeAspect="1"/>
+            <a:spLocks noGrp="1"/>
           </p:cNvSpPr>
           <p:nvPr>
             <p:ph type="sldImg" idx="2"/>
@@ -1043,7 +1043,7 @@
             <a:spLocks noGrp="1"/>
           </p:cNvSpPr>
           <p:nvPr>
-            <p:ph type="body" sz="quarter" idx="3"/>
+            <p:ph type="body" idx="3" sz="quarter"/>
           </p:nvPr>
         </p:nvSpPr>
         <p:spPr/>
@@ -1064,7 +1064,7 @@
             <a:spLocks noGrp="1"/>
           </p:cNvSpPr>
           <p:nvPr>
-            <p:ph type="sldNum" sz="quarter" idx="5"/>
+            <p:ph type="sldNum" idx="5" sz="quarter"/>
           </p:nvPr>
         </p:nvSpPr>
         <p:spPr/>
@@ -1078,7 +1078,7 @@
 </file>
 
 <file path=ppt/notesSlides/notesSlide6.xml><?xml version="1.0" encoding="utf-8"?>
-<p:notes xmlns:a="http://schemas.openxmlformats.org/drawingml/2006/main" xmlns:r="http://schemas.openxmlformats.org/officeDocument/2006/relationships" xmlns:p="http://schemas.openxmlformats.org/presentationml/2006/main">
+<p:notes xmlns:a="http://schemas.openxmlformats.org/drawingml/2006/main" xmlns:p="http://schemas.openxmlformats.org/presentationml/2006/main" xmlns:r="http://schemas.openxmlformats.org/officeDocument/2006/relationships">
   <p:cSld>
     <p:spTree>
       <p:nvGrpSpPr>
@@ -1098,7 +1098,7 @@
         <p:nvSpPr>
           <p:cNvPr id="2" name="Slide Image Placeholder 1"/>
           <p:cNvSpPr>
-            <a:spLocks noGrp="1" noRot="1" noChangeAspect="1"/>
+            <a:spLocks noGrp="1"/>
           </p:cNvSpPr>
           <p:nvPr>
             <p:ph type="sldImg" idx="2"/>
@@ -1113,7 +1113,7 @@
             <a:spLocks noGrp="1"/>
           </p:cNvSpPr>
           <p:nvPr>
-            <p:ph type="body" sz="quarter" idx="3"/>
+            <p:ph type="body" idx="3" sz="quarter"/>
           </p:nvPr>
         </p:nvSpPr>
         <p:spPr/>
@@ -1134,7 +1134,7 @@
             <a:spLocks noGrp="1"/>
           </p:cNvSpPr>
           <p:nvPr>
-            <p:ph type="sldNum" sz="quarter" idx="5"/>
+            <p:ph type="sldNum" idx="5" sz="quarter"/>
           </p:nvPr>
         </p:nvSpPr>
         <p:spPr/>
@@ -1148,7 +1148,7 @@
 </file>
 
 <file path=ppt/notesSlides/notesSlide7.xml><?xml version="1.0" encoding="utf-8"?>
-<p:notes xmlns:a="http://schemas.openxmlformats.org/drawingml/2006/main" xmlns:r="http://schemas.openxmlformats.org/officeDocument/2006/relationships" xmlns:p="http://schemas.openxmlformats.org/presentationml/2006/main">
+<p:notes xmlns:a="http://schemas.openxmlformats.org/drawingml/2006/main" xmlns:p="http://schemas.openxmlformats.org/presentationml/2006/main" xmlns:r="http://schemas.openxmlformats.org/officeDocument/2006/relationships">
   <p:cSld>
     <p:spTree>
       <p:nvGrpSpPr>
@@ -1168,7 +1168,7 @@
         <p:nvSpPr>
           <p:cNvPr id="2" name="Slide Image Placeholder 1"/>
           <p:cNvSpPr>
-            <a:spLocks noGrp="1" noRot="1" noChangeAspect="1"/>
+            <a:spLocks noGrp="1"/>
           </p:cNvSpPr>
           <p:nvPr>
             <p:ph type="sldImg" idx="2"/>
@@ -1183,7 +1183,7 @@
             <a:spLocks noGrp="1"/>
           </p:cNvSpPr>
           <p:nvPr>
-            <p:ph type="body" sz="quarter" idx="3"/>
+            <p:ph type="body" idx="3" sz="quarter"/>
           </p:nvPr>
         </p:nvSpPr>
         <p:spPr/>
@@ -1204,7 +1204,7 @@
             <a:spLocks noGrp="1"/>
           </p:cNvSpPr>
           <p:nvPr>
-            <p:ph type="sldNum" sz="quarter" idx="5"/>
+            <p:ph type="sldNum" idx="5" sz="quarter"/>
           </p:nvPr>
         </p:nvSpPr>
         <p:spPr/>
@@ -1218,7 +1218,7 @@
 </file>
 
 <file path=ppt/notesSlides/notesSlide8.xml><?xml version="1.0" encoding="utf-8"?>
-<p:notes xmlns:a="http://schemas.openxmlformats.org/drawingml/2006/main" xmlns:r="http://schemas.openxmlformats.org/officeDocument/2006/relationships" xmlns:p="http://schemas.openxmlformats.org/presentationml/2006/main">
+<p:notes xmlns:a="http://schemas.openxmlformats.org/drawingml/2006/main" xmlns:p="http://schemas.openxmlformats.org/presentationml/2006/main" xmlns:r="http://schemas.openxmlformats.org/officeDocument/2006/relationships">
   <p:cSld>
     <p:spTree>
       <p:nvGrpSpPr>
@@ -1238,7 +1238,7 @@
         <p:nvSpPr>
           <p:cNvPr id="2" name="Slide Image Placeholder 1"/>
           <p:cNvSpPr>
-            <a:spLocks noGrp="1" noRot="1" noChangeAspect="1"/>
+            <a:spLocks noGrp="1"/>
           </p:cNvSpPr>
           <p:nvPr>
             <p:ph type="sldImg" idx="2"/>
@@ -1253,7 +1253,7 @@
             <a:spLocks noGrp="1"/>
           </p:cNvSpPr>
           <p:nvPr>
-            <p:ph type="body" sz="quarter" idx="3"/>
+            <p:ph type="body" idx="3" sz="quarter"/>
           </p:nvPr>
         </p:nvSpPr>
         <p:spPr/>
@@ -1274,7 +1274,7 @@
             <a:spLocks noGrp="1"/>
           </p:cNvSpPr>
           <p:nvPr>
-            <p:ph type="sldNum" sz="quarter" idx="5"/>
+            <p:ph type="sldNum" idx="5" sz="quarter"/>
           </p:nvPr>
         </p:nvSpPr>
         <p:spPr/>
@@ -1288,7 +1288,7 @@
 </file>
 
 <file path=ppt/notesSlides/notesSlide9.xml><?xml version="1.0" encoding="utf-8"?>
-<p:notes xmlns:a="http://schemas.openxmlformats.org/drawingml/2006/main" xmlns:r="http://schemas.openxmlformats.org/officeDocument/2006/relationships" xmlns:p="http://schemas.openxmlformats.org/presentationml/2006/main">
+<p:notes xmlns:a="http://schemas.openxmlformats.org/drawingml/2006/main" xmlns:p="http://schemas.openxmlformats.org/presentationml/2006/main" xmlns:r="http://schemas.openxmlformats.org/officeDocument/2006/relationships">
   <p:cSld>
     <p:spTree>
       <p:nvGrpSpPr>
@@ -1308,7 +1308,7 @@
         <p:nvSpPr>
           <p:cNvPr id="2" name="Slide Image Placeholder 1"/>
           <p:cNvSpPr>
-            <a:spLocks noGrp="1" noRot="1" noChangeAspect="1"/>
+            <a:spLocks noGrp="1"/>
           </p:cNvSpPr>
           <p:nvPr>
             <p:ph type="sldImg" idx="2"/>
@@ -1323,7 +1323,7 @@
             <a:spLocks noGrp="1"/>
           </p:cNvSpPr>
           <p:nvPr>
-            <p:ph type="body" sz="quarter" idx="3"/>
+            <p:ph type="body" idx="3" sz="quarter"/>
           </p:nvPr>
         </p:nvSpPr>
         <p:spPr/>
@@ -1332,7 +1332,7 @@
           <a:lstStyle/>
           <a:p>
             <a:r>
-              <a:t>Measured (summary.csv, detail.csv): PaddleOCR Light + rules 37.3% with the original rules and 88.2% after tuning on these 9 receipts; label phrases 69 to 225; vet invoice receipt number 369303 correct before tuning, 380048 after. Azure DI + AOAI 88.2% with the prompt unchanged; bilingual receipt 6/6 and Chinese medicine receipt 6/6; 6.2 s vs 13.9 s per receipt; vet invoice total 1361.5 although the Azure DI text contains the correct 1361.00. Expected, not measured: control, predictability, API fees, run-to-run variation and behaviour on unseen receipts. Prices are not yet confirmed. Source: python/receipt_ocr_benchmark/results/v2/scores_improved (summary.csv, detail.csv) and extraction JSON.</a:t>
+              <a:t>Measured (summary.csv, detail.csv): PaddleOCR Light + rules 37.3% with the original rules and 88.2% after tuning on these 9 receipts; label phrases 69 to 225; vet invoice receipt number 369303 correct before tuning, 380048 after. Azure DI + AOAI 88.2% with the prompt unchanged; 6 of 51 fields wrong, e.g. vet invoice total 1361.5 although the Azure DI text contains the correct 1361.00; 6.2 s vs 13.9 s per receipt. Expected, not measured: that new formats may need rule updates, that AOAI needs less rule maintenance, control, API fees and the upkeep AOAI still needs (validation, monitoring, prompt). AOAI is not maintenance free, and not every new layout will necessarily need a rule update. Prices are not yet confirmed. Source: python/receipt_ocr_benchmark/results/v2/scores_improved (summary.csv, detail.csv) and extraction JSON.</a:t>
             </a:r>
           </a:p>
         </p:txBody>
@@ -1344,7 +1344,7 @@
             <a:spLocks noGrp="1"/>
           </p:cNvSpPr>
           <p:nvPr>
-            <p:ph type="sldNum" sz="quarter" idx="5"/>
+            <p:ph type="sldNum" idx="5" sz="quarter"/>
           </p:nvPr>
         </p:nvSpPr>
         <p:spPr/>
@@ -5643,7 +5643,7 @@
           </a:prstGeom>
         </p:spPr>
         <p:txBody>
-          <a:bodyPr horzOverflow="overflow" wrap="none" lIns="0" tIns="0" rIns="0" bIns="0">
+          <a:bodyPr horzOverflow="overflow" lIns="0" tIns="0" rIns="0" bIns="0" wrap="none">
             <a:spAutoFit/>
           </a:bodyPr>
           <a:lstStyle/>
@@ -5962,7 +5962,7 @@
 </file>
 
 <file path=ppt/slides/slide1.xml><?xml version="1.0" encoding="utf-8"?>
-<p:sld xmlns:a="http://schemas.openxmlformats.org/drawingml/2006/main" xmlns:r="http://schemas.openxmlformats.org/officeDocument/2006/relationships" xmlns:p="http://schemas.openxmlformats.org/presentationml/2006/main">
+<p:sld xmlns:a="http://schemas.openxmlformats.org/drawingml/2006/main" xmlns:p="http://schemas.openxmlformats.org/presentationml/2006/main" xmlns:r="http://schemas.openxmlformats.org/officeDocument/2006/relationships">
   <p:cSld>
     <p:spTree>
       <p:nvGrpSpPr>
@@ -5970,14 +5970,7 @@
         <p:cNvGrpSpPr/>
         <p:nvPr/>
       </p:nvGrpSpPr>
-      <p:grpSpPr>
-        <a:xfrm>
-          <a:off x="0" y="0"/>
-          <a:ext cx="0" cy="0"/>
-          <a:chOff x="0" y="0"/>
-          <a:chExt cx="0" cy="0"/>
-        </a:xfrm>
-      </p:grpSpPr>
+      <p:grpSpPr/>
       <p:sp>
         <p:nvSpPr>
           <p:cNvPr id="2" name="Subtitle 1"/>
@@ -6024,7 +6017,7 @@
             <a:spLocks noGrp="1"/>
           </p:cNvSpPr>
           <p:nvPr>
-            <p:ph type="body" sz="quarter" idx="10"/>
+            <p:ph type="body" idx="10" sz="quarter"/>
           </p:nvPr>
         </p:nvSpPr>
         <p:spPr/>
@@ -6051,7 +6044,7 @@
 </file>
 
 <file path=ppt/slides/slide10.xml><?xml version="1.0" encoding="utf-8"?>
-<p:sld xmlns:a="http://schemas.openxmlformats.org/drawingml/2006/main" xmlns:r="http://schemas.openxmlformats.org/officeDocument/2006/relationships" xmlns:p="http://schemas.openxmlformats.org/presentationml/2006/main">
+<p:sld xmlns:a="http://schemas.openxmlformats.org/drawingml/2006/main" xmlns:p="http://schemas.openxmlformats.org/presentationml/2006/main" xmlns:r="http://schemas.openxmlformats.org/officeDocument/2006/relationships">
   <p:cSld>
     <p:spTree>
       <p:nvGrpSpPr>
@@ -6059,14 +6052,7 @@
         <p:cNvGrpSpPr/>
         <p:nvPr/>
       </p:nvGrpSpPr>
-      <p:grpSpPr>
-        <a:xfrm>
-          <a:off x="0" y="0"/>
-          <a:ext cx="0" cy="0"/>
-          <a:chOff x="0" y="0"/>
-          <a:chExt cx="0" cy="0"/>
-        </a:xfrm>
-      </p:grpSpPr>
+      <p:grpSpPr/>
       <p:sp>
         <p:nvSpPr>
           <p:cNvPr id="4" name="Text Placeholder 3"/>
@@ -6074,7 +6060,7 @@
             <a:spLocks noGrp="1"/>
           </p:cNvSpPr>
           <p:nvPr>
-            <p:ph type="body" sz="quarter" idx="10"/>
+            <p:ph type="body" idx="10" sz="quarter"/>
           </p:nvPr>
         </p:nvSpPr>
         <p:spPr>
@@ -6142,7 +6128,7 @@
             <a:fld id="{18A41853-EF22-D446-BDBC-A7CF3FE93503}" type="slidenum">
               <a:rPr lang="en-US" smtClean="0"/>
               <a:pPr/>
-              <a:t>10</a:t>
+              <a:t>‹#›</a:t>
             </a:fld>
             <a:endParaRPr lang="en-US" dirty="0"/>
           </a:p>
@@ -6165,7 +6151,7 @@
           <a:noFill/>
         </p:spPr>
         <p:txBody>
-          <a:bodyPr wrap="square" lIns="0" tIns="0" rIns="0" bIns="0" anchor="t"/>
+          <a:bodyPr wrap="square" lIns="0" rIns="0" tIns="0" bIns="0" anchor="t"/>
           <a:lstStyle/>
           <a:p>
             <a:pPr marL="0" indent="0" algn="l">
@@ -6209,10 +6195,10 @@
           </a:ln>
         </p:spPr>
         <p:txBody>
-          <a:bodyPr wrap="square" lIns="274320" tIns="109728" rIns="274320" bIns="109728" rtlCol="0" anchor="t"/>
+          <a:bodyPr rtlCol="0" anchor="t" wrap="square" lIns="274320" rIns="274320" tIns="109728" bIns="109728"/>
           <a:lstStyle/>
           <a:p>
-            <a:pPr marL="182880" indent="-182880" algn="l">
+            <a:pPr algn="l" marL="182880" indent="-182880">
               <a:spcAft>
                 <a:spcPts val="600"/>
               </a:spcAft>
@@ -6292,10 +6278,10 @@
           </a:ln>
         </p:spPr>
         <p:txBody>
-          <a:bodyPr wrap="square" lIns="201168" tIns="109728" rIns="201168" bIns="109728" rtlCol="0" anchor="t"/>
+          <a:bodyPr rtlCol="0" anchor="t" wrap="square" lIns="201168" rIns="201168" tIns="109728" bIns="109728"/>
           <a:lstStyle/>
           <a:p>
-            <a:pPr marL="0" indent="0" algn="l">
+            <a:pPr algn="l" marL="0" indent="0">
               <a:spcAft>
                 <a:spcPts val="600"/>
               </a:spcAft>
@@ -6354,10 +6340,10 @@
           </a:ln>
         </p:spPr>
         <p:txBody>
-          <a:bodyPr wrap="square" lIns="201168" tIns="109728" rIns="201168" bIns="109728" rtlCol="0" anchor="t"/>
+          <a:bodyPr rtlCol="0" anchor="t" wrap="square" lIns="201168" rIns="201168" tIns="109728" bIns="109728"/>
           <a:lstStyle/>
           <a:p>
-            <a:pPr marL="0" indent="0" algn="l">
+            <a:pPr algn="l" marL="0" indent="0">
               <a:spcAft>
                 <a:spcPts val="600"/>
               </a:spcAft>
@@ -6416,10 +6402,10 @@
           </a:ln>
         </p:spPr>
         <p:txBody>
-          <a:bodyPr wrap="square" lIns="201168" tIns="109728" rIns="201168" bIns="109728" rtlCol="0" anchor="t"/>
+          <a:bodyPr rtlCol="0" anchor="t" wrap="square" lIns="201168" rIns="201168" tIns="109728" bIns="109728"/>
           <a:lstStyle/>
           <a:p>
-            <a:pPr marL="0" indent="0" algn="l">
+            <a:pPr algn="l" marL="0" indent="0">
               <a:spcAft>
                 <a:spcPts val="600"/>
               </a:spcAft>
@@ -6473,7 +6459,7 @@
           <a:noFill/>
         </p:spPr>
         <p:txBody>
-          <a:bodyPr wrap="square" lIns="0" tIns="0" rIns="0" bIns="0" anchor="t"/>
+          <a:bodyPr wrap="square" lIns="0" rIns="0" tIns="0" bIns="0" anchor="t"/>
           <a:lstStyle/>
           <a:p>
             <a:pPr marL="0" indent="0" algn="l">
@@ -6504,7 +6490,7 @@
 </file>
 
 <file path=ppt/slides/slide2.xml><?xml version="1.0" encoding="utf-8"?>
-<p:sld xmlns:a="http://schemas.openxmlformats.org/drawingml/2006/main" xmlns:r="http://schemas.openxmlformats.org/officeDocument/2006/relationships" xmlns:p="http://schemas.openxmlformats.org/presentationml/2006/main">
+<p:sld xmlns:a="http://schemas.openxmlformats.org/drawingml/2006/main" xmlns:p="http://schemas.openxmlformats.org/presentationml/2006/main" xmlns:r="http://schemas.openxmlformats.org/officeDocument/2006/relationships">
   <p:cSld>
     <p:spTree>
       <p:nvGrpSpPr>
@@ -6512,14 +6498,7 @@
         <p:cNvGrpSpPr/>
         <p:nvPr/>
       </p:nvGrpSpPr>
-      <p:grpSpPr>
-        <a:xfrm>
-          <a:off x="0" y="0"/>
-          <a:ext cx="0" cy="0"/>
-          <a:chOff x="0" y="0"/>
-          <a:chExt cx="0" cy="0"/>
-        </a:xfrm>
-      </p:grpSpPr>
+      <p:grpSpPr/>
       <p:sp>
         <p:nvSpPr>
           <p:cNvPr id="4" name="Text Placeholder 3"/>
@@ -6527,7 +6506,7 @@
             <a:spLocks noGrp="1"/>
           </p:cNvSpPr>
           <p:nvPr>
-            <p:ph type="body" sz="quarter" idx="10"/>
+            <p:ph type="body" idx="10" sz="quarter"/>
           </p:nvPr>
         </p:nvSpPr>
         <p:spPr>
@@ -6595,7 +6574,7 @@
             <a:fld id="{18A41853-EF22-D446-BDBC-A7CF3FE93503}" type="slidenum">
               <a:rPr lang="en-US" smtClean="0"/>
               <a:pPr/>
-              <a:t>2</a:t>
+              <a:t>‹#›</a:t>
             </a:fld>
             <a:endParaRPr lang="en-US" dirty="0"/>
           </a:p>
@@ -6618,7 +6597,7 @@
           <a:noFill/>
         </p:spPr>
         <p:txBody>
-          <a:bodyPr wrap="square" lIns="0" tIns="0" rIns="0" bIns="0" anchor="t"/>
+          <a:bodyPr wrap="square" lIns="0" rIns="0" tIns="0" bIns="0" anchor="t"/>
           <a:lstStyle/>
           <a:p>
             <a:pPr marL="0" indent="0" algn="l">
@@ -6686,7 +6665,7 @@
           <a:noFill/>
         </p:spPr>
         <p:txBody>
-          <a:bodyPr wrap="square" lIns="0" tIns="0" rIns="0" bIns="0" anchor="t"/>
+          <a:bodyPr wrap="square" lIns="0" rIns="0" tIns="0" bIns="0" anchor="t"/>
           <a:lstStyle/>
           <a:p>
             <a:pPr marL="0" indent="0" algn="l">
@@ -6754,7 +6733,7 @@
           <a:noFill/>
         </p:spPr>
         <p:txBody>
-          <a:bodyPr wrap="square" lIns="0" tIns="0" rIns="0" bIns="0" anchor="t"/>
+          <a:bodyPr wrap="square" lIns="0" rIns="0" tIns="0" bIns="0" anchor="t"/>
           <a:lstStyle/>
           <a:p>
             <a:pPr marL="0" indent="0" algn="l">
@@ -6822,7 +6801,7 @@
           <a:noFill/>
         </p:spPr>
         <p:txBody>
-          <a:bodyPr wrap="square" lIns="0" tIns="0" rIns="0" bIns="0" anchor="t"/>
+          <a:bodyPr wrap="square" lIns="0" rIns="0" tIns="0" bIns="0" anchor="t"/>
           <a:lstStyle/>
           <a:p>
             <a:pPr marL="0" indent="0" algn="l">
@@ -6859,36 +6838,18 @@
         <a:graphic>
           <a:graphicData uri="http://schemas.openxmlformats.org/drawingml/2006/table">
             <a:tbl>
-              <a:tblPr>
+              <a:tblPr firstRow="0" bandRow="0">
                 <a:tableStyleId>{2D5ABB26-0587-4C30-8999-92F81FD0307C}</a:tableStyleId>
               </a:tblPr>
               <a:tblGrid>
-                <a:gridCol w="1965960">
-                  <a:extLst>
-                    <a:ext uri="{9D8B030D-6E8A-4147-A177-3AD203B41FA5}">
-                      <a16:colId xmlns:a16="http://schemas.microsoft.com/office/drawing/2014/main" val="20000"/>
-                    </a:ext>
-                  </a:extLst>
-                </a:gridCol>
-                <a:gridCol w="1691640">
-                  <a:extLst>
-                    <a:ext uri="{9D8B030D-6E8A-4147-A177-3AD203B41FA5}">
-                      <a16:colId xmlns:a16="http://schemas.microsoft.com/office/drawing/2014/main" val="20001"/>
-                    </a:ext>
-                  </a:extLst>
-                </a:gridCol>
-                <a:gridCol w="1545336">
-                  <a:extLst>
-                    <a:ext uri="{9D8B030D-6E8A-4147-A177-3AD203B41FA5}">
-                      <a16:colId xmlns:a16="http://schemas.microsoft.com/office/drawing/2014/main" val="20002"/>
-                    </a:ext>
-                  </a:extLst>
-                </a:gridCol>
+                <a:gridCol w="1965960"/>
+                <a:gridCol w="1691640"/>
+                <a:gridCol w="1545336"/>
               </a:tblGrid>
               <a:tr h="566928">
                 <a:tc>
                   <a:txBody>
-                    <a:bodyPr/>
+                    <a:bodyPr wrap="square"/>
                     <a:lstStyle/>
                     <a:p>
                       <a:pPr algn="l"/>
@@ -6904,7 +6865,7 @@
                       </a:r>
                     </a:p>
                   </a:txBody>
-                  <a:tcPr anchor="ctr">
+                  <a:tcPr marL="91440" marR="91440" marT="45720" marB="45720" anchor="ctr">
                     <a:lnL w="0">
                       <a:noFill/>
                     </a:lnL>
@@ -6924,7 +6885,7 @@
                 </a:tc>
                 <a:tc>
                   <a:txBody>
-                    <a:bodyPr/>
+                    <a:bodyPr wrap="square"/>
                     <a:lstStyle/>
                     <a:p>
                       <a:pPr algn="l"/>
@@ -6940,7 +6901,7 @@
                       </a:r>
                     </a:p>
                   </a:txBody>
-                  <a:tcPr anchor="ctr">
+                  <a:tcPr marL="91440" marR="91440" marT="45720" marB="45720" anchor="ctr">
                     <a:lnL w="0">
                       <a:noFill/>
                     </a:lnL>
@@ -6960,7 +6921,7 @@
                 </a:tc>
                 <a:tc>
                   <a:txBody>
-                    <a:bodyPr/>
+                    <a:bodyPr wrap="square"/>
                     <a:lstStyle/>
                     <a:p>
                       <a:pPr algn="l"/>
@@ -6976,7 +6937,7 @@
                       </a:r>
                     </a:p>
                   </a:txBody>
-                  <a:tcPr anchor="ctr">
+                  <a:tcPr marL="91440" marR="91440" marT="45720" marB="45720" anchor="ctr">
                     <a:lnL w="0">
                       <a:noFill/>
                     </a:lnL>
@@ -6994,16 +6955,11 @@
                     </a:solidFill>
                   </a:tcPr>
                 </a:tc>
-                <a:extLst>
-                  <a:ext uri="{0D108BD9-81ED-4DB2-BD59-A6C34878D82A}">
-                    <a16:rowId xmlns:a16="http://schemas.microsoft.com/office/drawing/2014/main" val="10000"/>
-                  </a:ext>
-                </a:extLst>
               </a:tr>
               <a:tr h="621792">
                 <a:tc>
                   <a:txBody>
-                    <a:bodyPr/>
+                    <a:bodyPr wrap="square"/>
                     <a:lstStyle/>
                     <a:p>
                       <a:pPr algn="l"/>
@@ -7019,7 +6975,7 @@
                       </a:r>
                     </a:p>
                   </a:txBody>
-                  <a:tcPr anchor="ctr">
+                  <a:tcPr marL="91440" marR="91440" marT="45720" marB="45720" anchor="ctr">
                     <a:lnL w="0">
                       <a:noFill/>
                     </a:lnL>
@@ -7039,7 +6995,7 @@
                 </a:tc>
                 <a:tc>
                   <a:txBody>
-                    <a:bodyPr/>
+                    <a:bodyPr wrap="square"/>
                     <a:lstStyle/>
                     <a:p>
                       <a:pPr algn="l"/>
@@ -7055,7 +7011,7 @@
                       </a:r>
                     </a:p>
                   </a:txBody>
-                  <a:tcPr anchor="ctr">
+                  <a:tcPr marL="91440" marR="91440" marT="45720" marB="45720" anchor="ctr">
                     <a:lnL w="0">
                       <a:noFill/>
                     </a:lnL>
@@ -7075,7 +7031,7 @@
                 </a:tc>
                 <a:tc>
                   <a:txBody>
-                    <a:bodyPr/>
+                    <a:bodyPr wrap="square"/>
                     <a:lstStyle/>
                     <a:p>
                       <a:pPr algn="l"/>
@@ -7091,7 +7047,7 @@
                       </a:r>
                     </a:p>
                   </a:txBody>
-                  <a:tcPr anchor="ctr">
+                  <a:tcPr marL="91440" marR="91440" marT="45720" marB="45720" anchor="ctr">
                     <a:lnL w="0">
                       <a:noFill/>
                     </a:lnL>
@@ -7109,16 +7065,11 @@
                     <a:noFill/>
                   </a:tcPr>
                 </a:tc>
-                <a:extLst>
-                  <a:ext uri="{0D108BD9-81ED-4DB2-BD59-A6C34878D82A}">
-                    <a16:rowId xmlns:a16="http://schemas.microsoft.com/office/drawing/2014/main" val="10001"/>
-                  </a:ext>
-                </a:extLst>
               </a:tr>
               <a:tr h="621792">
                 <a:tc>
                   <a:txBody>
-                    <a:bodyPr/>
+                    <a:bodyPr wrap="square"/>
                     <a:lstStyle/>
                     <a:p>
                       <a:pPr algn="l"/>
@@ -7134,21 +7085,15 @@
                       </a:r>
                     </a:p>
                   </a:txBody>
-                  <a:tcPr anchor="ctr">
+                  <a:tcPr marL="91440" marR="91440" marT="45720" marB="45720" anchor="ctr">
                     <a:lnL w="0">
                       <a:noFill/>
                     </a:lnL>
                     <a:lnR w="0">
                       <a:noFill/>
                     </a:lnR>
-                    <a:lnT w="9525" cap="flat" cmpd="sng" algn="ctr">
-                      <a:solidFill>
-                        <a:srgbClr val="BFBFBF"/>
-                      </a:solidFill>
-                      <a:prstDash val="solid"/>
-                      <a:round/>
-                      <a:headEnd type="none" w="med" len="med"/>
-                      <a:tailEnd type="none" w="med" len="med"/>
+                    <a:lnT w="0">
+                      <a:noFill/>
                     </a:lnT>
                     <a:lnB w="9525" cmpd="sng">
                       <a:solidFill>
@@ -7160,7 +7105,7 @@
                 </a:tc>
                 <a:tc>
                   <a:txBody>
-                    <a:bodyPr/>
+                    <a:bodyPr wrap="square"/>
                     <a:lstStyle/>
                     <a:p>
                       <a:pPr algn="l"/>
@@ -7176,21 +7121,15 @@
                       </a:r>
                     </a:p>
                   </a:txBody>
-                  <a:tcPr anchor="ctr">
+                  <a:tcPr marL="91440" marR="91440" marT="45720" marB="45720" anchor="ctr">
                     <a:lnL w="0">
                       <a:noFill/>
                     </a:lnL>
                     <a:lnR w="0">
                       <a:noFill/>
                     </a:lnR>
-                    <a:lnT w="9525" cap="flat" cmpd="sng" algn="ctr">
-                      <a:solidFill>
-                        <a:srgbClr val="BFBFBF"/>
-                      </a:solidFill>
-                      <a:prstDash val="solid"/>
-                      <a:round/>
-                      <a:headEnd type="none" w="med" len="med"/>
-                      <a:tailEnd type="none" w="med" len="med"/>
+                    <a:lnT w="0">
+                      <a:noFill/>
                     </a:lnT>
                     <a:lnB w="9525" cmpd="sng">
                       <a:solidFill>
@@ -7202,7 +7141,7 @@
                 </a:tc>
                 <a:tc>
                   <a:txBody>
-                    <a:bodyPr/>
+                    <a:bodyPr wrap="square"/>
                     <a:lstStyle/>
                     <a:p>
                       <a:pPr algn="l"/>
@@ -7218,21 +7157,15 @@
                       </a:r>
                     </a:p>
                   </a:txBody>
-                  <a:tcPr anchor="ctr">
+                  <a:tcPr marL="91440" marR="91440" marT="45720" marB="45720" anchor="ctr">
                     <a:lnL w="0">
                       <a:noFill/>
                     </a:lnL>
                     <a:lnR w="0">
                       <a:noFill/>
                     </a:lnR>
-                    <a:lnT w="9525" cap="flat" cmpd="sng" algn="ctr">
-                      <a:solidFill>
-                        <a:srgbClr val="BFBFBF"/>
-                      </a:solidFill>
-                      <a:prstDash val="solid"/>
-                      <a:round/>
-                      <a:headEnd type="none" w="med" len="med"/>
-                      <a:tailEnd type="none" w="med" len="med"/>
+                    <a:lnT w="0">
+                      <a:noFill/>
                     </a:lnT>
                     <a:lnB w="9525" cmpd="sng">
                       <a:solidFill>
@@ -7242,16 +7175,11 @@
                     <a:noFill/>
                   </a:tcPr>
                 </a:tc>
-                <a:extLst>
-                  <a:ext uri="{0D108BD9-81ED-4DB2-BD59-A6C34878D82A}">
-                    <a16:rowId xmlns:a16="http://schemas.microsoft.com/office/drawing/2014/main" val="10002"/>
-                  </a:ext>
-                </a:extLst>
               </a:tr>
               <a:tr h="621792">
                 <a:tc>
                   <a:txBody>
-                    <a:bodyPr/>
+                    <a:bodyPr wrap="square"/>
                     <a:lstStyle/>
                     <a:p>
                       <a:pPr algn="l"/>
@@ -7267,21 +7195,15 @@
                       </a:r>
                     </a:p>
                   </a:txBody>
-                  <a:tcPr anchor="ctr">
+                  <a:tcPr marL="91440" marR="91440" marT="45720" marB="45720" anchor="ctr">
                     <a:lnL w="0">
                       <a:noFill/>
                     </a:lnL>
                     <a:lnR w="0">
                       <a:noFill/>
                     </a:lnR>
-                    <a:lnT w="9525" cap="flat" cmpd="sng" algn="ctr">
-                      <a:solidFill>
-                        <a:srgbClr val="BFBFBF"/>
-                      </a:solidFill>
-                      <a:prstDash val="solid"/>
-                      <a:round/>
-                      <a:headEnd type="none" w="med" len="med"/>
-                      <a:tailEnd type="none" w="med" len="med"/>
+                    <a:lnT w="0">
+                      <a:noFill/>
                     </a:lnT>
                     <a:lnB w="9525" cmpd="sng">
                       <a:solidFill>
@@ -7293,7 +7215,7 @@
                 </a:tc>
                 <a:tc>
                   <a:txBody>
-                    <a:bodyPr/>
+                    <a:bodyPr wrap="square"/>
                     <a:lstStyle/>
                     <a:p>
                       <a:pPr algn="l"/>
@@ -7309,21 +7231,15 @@
                       </a:r>
                     </a:p>
                   </a:txBody>
-                  <a:tcPr anchor="ctr">
+                  <a:tcPr marL="91440" marR="91440" marT="45720" marB="45720" anchor="ctr">
                     <a:lnL w="0">
                       <a:noFill/>
                     </a:lnL>
                     <a:lnR w="0">
                       <a:noFill/>
                     </a:lnR>
-                    <a:lnT w="9525" cap="flat" cmpd="sng" algn="ctr">
-                      <a:solidFill>
-                        <a:srgbClr val="BFBFBF"/>
-                      </a:solidFill>
-                      <a:prstDash val="solid"/>
-                      <a:round/>
-                      <a:headEnd type="none" w="med" len="med"/>
-                      <a:tailEnd type="none" w="med" len="med"/>
+                    <a:lnT w="0">
+                      <a:noFill/>
                     </a:lnT>
                     <a:lnB w="9525" cmpd="sng">
                       <a:solidFill>
@@ -7335,7 +7251,7 @@
                 </a:tc>
                 <a:tc>
                   <a:txBody>
-                    <a:bodyPr/>
+                    <a:bodyPr wrap="square"/>
                     <a:lstStyle/>
                     <a:p>
                       <a:pPr algn="l"/>
@@ -7351,21 +7267,15 @@
                       </a:r>
                     </a:p>
                   </a:txBody>
-                  <a:tcPr anchor="ctr">
+                  <a:tcPr marL="91440" marR="91440" marT="45720" marB="45720" anchor="ctr">
                     <a:lnL w="0">
                       <a:noFill/>
                     </a:lnL>
                     <a:lnR w="0">
                       <a:noFill/>
                     </a:lnR>
-                    <a:lnT w="9525" cap="flat" cmpd="sng" algn="ctr">
-                      <a:solidFill>
-                        <a:srgbClr val="BFBFBF"/>
-                      </a:solidFill>
-                      <a:prstDash val="solid"/>
-                      <a:round/>
-                      <a:headEnd type="none" w="med" len="med"/>
-                      <a:tailEnd type="none" w="med" len="med"/>
+                    <a:lnT w="0">
+                      <a:noFill/>
                     </a:lnT>
                     <a:lnB w="9525" cmpd="sng">
                       <a:solidFill>
@@ -7375,16 +7285,11 @@
                     <a:noFill/>
                   </a:tcPr>
                 </a:tc>
-                <a:extLst>
-                  <a:ext uri="{0D108BD9-81ED-4DB2-BD59-A6C34878D82A}">
-                    <a16:rowId xmlns:a16="http://schemas.microsoft.com/office/drawing/2014/main" val="10003"/>
-                  </a:ext>
-                </a:extLst>
               </a:tr>
               <a:tr h="621792">
                 <a:tc>
                   <a:txBody>
-                    <a:bodyPr/>
+                    <a:bodyPr wrap="square"/>
                     <a:lstStyle/>
                     <a:p>
                       <a:pPr algn="l"/>
@@ -7400,21 +7305,15 @@
                       </a:r>
                     </a:p>
                   </a:txBody>
-                  <a:tcPr anchor="ctr">
+                  <a:tcPr marL="91440" marR="91440" marT="45720" marB="45720" anchor="ctr">
                     <a:lnL w="0">
                       <a:noFill/>
                     </a:lnL>
                     <a:lnR w="0">
                       <a:noFill/>
                     </a:lnR>
-                    <a:lnT w="9525" cap="flat" cmpd="sng" algn="ctr">
-                      <a:solidFill>
-                        <a:srgbClr val="BFBFBF"/>
-                      </a:solidFill>
-                      <a:prstDash val="solid"/>
-                      <a:round/>
-                      <a:headEnd type="none" w="med" len="med"/>
-                      <a:tailEnd type="none" w="med" len="med"/>
+                    <a:lnT w="0">
+                      <a:noFill/>
                     </a:lnT>
                     <a:lnB w="9525" cmpd="sng">
                       <a:solidFill>
@@ -7426,7 +7325,7 @@
                 </a:tc>
                 <a:tc>
                   <a:txBody>
-                    <a:bodyPr/>
+                    <a:bodyPr wrap="square"/>
                     <a:lstStyle/>
                     <a:p>
                       <a:pPr algn="l"/>
@@ -7442,21 +7341,15 @@
                       </a:r>
                     </a:p>
                   </a:txBody>
-                  <a:tcPr anchor="ctr">
+                  <a:tcPr marL="91440" marR="91440" marT="45720" marB="45720" anchor="ctr">
                     <a:lnL w="0">
                       <a:noFill/>
                     </a:lnL>
                     <a:lnR w="0">
                       <a:noFill/>
                     </a:lnR>
-                    <a:lnT w="9525" cap="flat" cmpd="sng" algn="ctr">
-                      <a:solidFill>
-                        <a:srgbClr val="BFBFBF"/>
-                      </a:solidFill>
-                      <a:prstDash val="solid"/>
-                      <a:round/>
-                      <a:headEnd type="none" w="med" len="med"/>
-                      <a:tailEnd type="none" w="med" len="med"/>
+                    <a:lnT w="0">
+                      <a:noFill/>
                     </a:lnT>
                     <a:lnB w="9525" cmpd="sng">
                       <a:solidFill>
@@ -7468,7 +7361,7 @@
                 </a:tc>
                 <a:tc>
                   <a:txBody>
-                    <a:bodyPr/>
+                    <a:bodyPr wrap="square"/>
                     <a:lstStyle/>
                     <a:p>
                       <a:pPr algn="l"/>
@@ -7484,21 +7377,15 @@
                       </a:r>
                     </a:p>
                   </a:txBody>
-                  <a:tcPr anchor="ctr">
+                  <a:tcPr marL="91440" marR="91440" marT="45720" marB="45720" anchor="ctr">
                     <a:lnL w="0">
                       <a:noFill/>
                     </a:lnL>
                     <a:lnR w="0">
                       <a:noFill/>
                     </a:lnR>
-                    <a:lnT w="9525" cap="flat" cmpd="sng" algn="ctr">
-                      <a:solidFill>
-                        <a:srgbClr val="BFBFBF"/>
-                      </a:solidFill>
-                      <a:prstDash val="solid"/>
-                      <a:round/>
-                      <a:headEnd type="none" w="med" len="med"/>
-                      <a:tailEnd type="none" w="med" len="med"/>
+                    <a:lnT w="0">
+                      <a:noFill/>
                     </a:lnT>
                     <a:lnB w="9525" cmpd="sng">
                       <a:solidFill>
@@ -7508,11 +7395,6 @@
                     <a:noFill/>
                   </a:tcPr>
                 </a:tc>
-                <a:extLst>
-                  <a:ext uri="{0D108BD9-81ED-4DB2-BD59-A6C34878D82A}">
-                    <a16:rowId xmlns:a16="http://schemas.microsoft.com/office/drawing/2014/main" val="10004"/>
-                  </a:ext>
-                </a:extLst>
               </a:tr>
             </a:tbl>
           </a:graphicData>
@@ -7535,7 +7417,7 @@
           <a:noFill/>
         </p:spPr>
         <p:txBody>
-          <a:bodyPr wrap="square" lIns="0" tIns="0" rIns="0" bIns="0" anchor="t"/>
+          <a:bodyPr wrap="square" lIns="0" rIns="0" tIns="0" bIns="0" anchor="t"/>
           <a:lstStyle/>
           <a:p>
             <a:pPr marL="0" indent="0" algn="l">
@@ -7566,7 +7448,7 @@
 </file>
 
 <file path=ppt/slides/slide3.xml><?xml version="1.0" encoding="utf-8"?>
-<p:sld xmlns:a="http://schemas.openxmlformats.org/drawingml/2006/main" xmlns:r="http://schemas.openxmlformats.org/officeDocument/2006/relationships" xmlns:p="http://schemas.openxmlformats.org/presentationml/2006/main">
+<p:sld xmlns:a="http://schemas.openxmlformats.org/drawingml/2006/main" xmlns:p="http://schemas.openxmlformats.org/presentationml/2006/main" xmlns:r="http://schemas.openxmlformats.org/officeDocument/2006/relationships">
   <p:cSld>
     <p:spTree>
       <p:nvGrpSpPr>
@@ -7574,14 +7456,7 @@
         <p:cNvGrpSpPr/>
         <p:nvPr/>
       </p:nvGrpSpPr>
-      <p:grpSpPr>
-        <a:xfrm>
-          <a:off x="0" y="0"/>
-          <a:ext cx="0" cy="0"/>
-          <a:chOff x="0" y="0"/>
-          <a:chExt cx="0" cy="0"/>
-        </a:xfrm>
-      </p:grpSpPr>
+      <p:grpSpPr/>
       <p:sp>
         <p:nvSpPr>
           <p:cNvPr id="4" name="Text Placeholder 3"/>
@@ -7589,7 +7464,7 @@
             <a:spLocks noGrp="1"/>
           </p:cNvSpPr>
           <p:nvPr>
-            <p:ph type="body" sz="quarter" idx="10"/>
+            <p:ph type="body" idx="10" sz="quarter"/>
           </p:nvPr>
         </p:nvSpPr>
         <p:spPr>
@@ -7657,7 +7532,7 @@
             <a:fld id="{18A41853-EF22-D446-BDBC-A7CF3FE93503}" type="slidenum">
               <a:rPr lang="en-US" smtClean="0"/>
               <a:pPr/>
-              <a:t>3</a:t>
+              <a:t>‹#›</a:t>
             </a:fld>
             <a:endParaRPr lang="en-US" dirty="0"/>
           </a:p>
@@ -7680,7 +7555,7 @@
           <a:noFill/>
         </p:spPr>
         <p:txBody>
-          <a:bodyPr wrap="square" lIns="0" tIns="0" rIns="0" bIns="0" anchor="t"/>
+          <a:bodyPr wrap="square" lIns="0" rIns="0" tIns="0" bIns="0" anchor="t"/>
           <a:lstStyle/>
           <a:p>
             <a:pPr marL="0" indent="0" algn="l">
@@ -7717,43 +7592,19 @@
         <a:graphic>
           <a:graphicData uri="http://schemas.openxmlformats.org/drawingml/2006/table">
             <a:tbl>
-              <a:tblPr>
+              <a:tblPr firstRow="0" bandRow="0">
                 <a:tableStyleId>{2D5ABB26-0587-4C30-8999-92F81FD0307C}</a:tableStyleId>
               </a:tblPr>
               <a:tblGrid>
-                <a:gridCol w="3291840">
-                  <a:extLst>
-                    <a:ext uri="{9D8B030D-6E8A-4147-A177-3AD203B41FA5}">
-                      <a16:colId xmlns:a16="http://schemas.microsoft.com/office/drawing/2014/main" val="20000"/>
-                    </a:ext>
-                  </a:extLst>
-                </a:gridCol>
-                <a:gridCol w="2606040">
-                  <a:extLst>
-                    <a:ext uri="{9D8B030D-6E8A-4147-A177-3AD203B41FA5}">
-                      <a16:colId xmlns:a16="http://schemas.microsoft.com/office/drawing/2014/main" val="20001"/>
-                    </a:ext>
-                  </a:extLst>
-                </a:gridCol>
-                <a:gridCol w="2971800">
-                  <a:extLst>
-                    <a:ext uri="{9D8B030D-6E8A-4147-A177-3AD203B41FA5}">
-                      <a16:colId xmlns:a16="http://schemas.microsoft.com/office/drawing/2014/main" val="20002"/>
-                    </a:ext>
-                  </a:extLst>
-                </a:gridCol>
-                <a:gridCol w="2606040">
-                  <a:extLst>
-                    <a:ext uri="{9D8B030D-6E8A-4147-A177-3AD203B41FA5}">
-                      <a16:colId xmlns:a16="http://schemas.microsoft.com/office/drawing/2014/main" val="20003"/>
-                    </a:ext>
-                  </a:extLst>
-                </a:gridCol>
+                <a:gridCol w="3291840"/>
+                <a:gridCol w="2606040"/>
+                <a:gridCol w="2971800"/>
+                <a:gridCol w="2606040"/>
               </a:tblGrid>
               <a:tr h="658368">
                 <a:tc>
                   <a:txBody>
-                    <a:bodyPr/>
+                    <a:bodyPr wrap="square"/>
                     <a:lstStyle/>
                     <a:p>
                       <a:pPr algn="l"/>
@@ -7769,7 +7620,7 @@
                       </a:r>
                     </a:p>
                   </a:txBody>
-                  <a:tcPr anchor="ctr">
+                  <a:tcPr marL="91440" marR="91440" marT="45720" marB="45720" anchor="ctr">
                     <a:lnL w="0">
                       <a:noFill/>
                     </a:lnL>
@@ -7789,7 +7640,7 @@
                 </a:tc>
                 <a:tc>
                   <a:txBody>
-                    <a:bodyPr/>
+                    <a:bodyPr wrap="square"/>
                     <a:lstStyle/>
                     <a:p>
                       <a:pPr algn="ctr"/>
@@ -7805,7 +7656,7 @@
                       </a:r>
                     </a:p>
                   </a:txBody>
-                  <a:tcPr anchor="ctr">
+                  <a:tcPr marL="91440" marR="91440" marT="45720" marB="45720" anchor="ctr">
                     <a:lnL w="0">
                       <a:noFill/>
                     </a:lnL>
@@ -7825,7 +7676,7 @@
                 </a:tc>
                 <a:tc>
                   <a:txBody>
-                    <a:bodyPr/>
+                    <a:bodyPr wrap="square"/>
                     <a:lstStyle/>
                     <a:p>
                       <a:pPr algn="ctr"/>
@@ -7841,7 +7692,7 @@
                       </a:r>
                     </a:p>
                   </a:txBody>
-                  <a:tcPr anchor="ctr">
+                  <a:tcPr marL="91440" marR="91440" marT="45720" marB="45720" anchor="ctr">
                     <a:lnL w="0">
                       <a:noFill/>
                     </a:lnL>
@@ -7861,7 +7712,7 @@
                 </a:tc>
                 <a:tc>
                   <a:txBody>
-                    <a:bodyPr/>
+                    <a:bodyPr wrap="square"/>
                     <a:lstStyle/>
                     <a:p>
                       <a:pPr algn="ctr"/>
@@ -7877,7 +7728,7 @@
                       </a:r>
                     </a:p>
                   </a:txBody>
-                  <a:tcPr anchor="ctr">
+                  <a:tcPr marL="91440" marR="91440" marT="45720" marB="45720" anchor="ctr">
                     <a:lnL w="0">
                       <a:noFill/>
                     </a:lnL>
@@ -7895,16 +7746,11 @@
                     </a:solidFill>
                   </a:tcPr>
                 </a:tc>
-                <a:extLst>
-                  <a:ext uri="{0D108BD9-81ED-4DB2-BD59-A6C34878D82A}">
-                    <a16:rowId xmlns:a16="http://schemas.microsoft.com/office/drawing/2014/main" val="10000"/>
-                  </a:ext>
-                </a:extLst>
               </a:tr>
               <a:tr h="749808">
                 <a:tc>
                   <a:txBody>
-                    <a:bodyPr/>
+                    <a:bodyPr wrap="square"/>
                     <a:lstStyle/>
                     <a:p>
                       <a:pPr algn="l"/>
@@ -7920,7 +7766,7 @@
                       </a:r>
                     </a:p>
                   </a:txBody>
-                  <a:tcPr anchor="ctr">
+                  <a:tcPr marL="91440" marR="91440" marT="45720" marB="45720" anchor="ctr">
                     <a:lnL w="0">
                       <a:noFill/>
                     </a:lnL>
@@ -7940,7 +7786,7 @@
                 </a:tc>
                 <a:tc>
                   <a:txBody>
-                    <a:bodyPr/>
+                    <a:bodyPr wrap="square"/>
                     <a:lstStyle/>
                     <a:p>
                       <a:pPr algn="ctr"/>
@@ -7966,7 +7812,7 @@
                       </a:r>
                     </a:p>
                   </a:txBody>
-                  <a:tcPr anchor="ctr">
+                  <a:tcPr marL="91440" marR="91440" marT="45720" marB="45720" anchor="ctr">
                     <a:lnL w="0">
                       <a:noFill/>
                     </a:lnL>
@@ -7986,7 +7832,7 @@
                 </a:tc>
                 <a:tc>
                   <a:txBody>
-                    <a:bodyPr/>
+                    <a:bodyPr wrap="square"/>
                     <a:lstStyle/>
                     <a:p>
                       <a:pPr algn="ctr"/>
@@ -8012,7 +7858,7 @@
                       </a:r>
                     </a:p>
                   </a:txBody>
-                  <a:tcPr anchor="ctr">
+                  <a:tcPr marL="91440" marR="91440" marT="45720" marB="45720" anchor="ctr">
                     <a:lnL w="0">
                       <a:noFill/>
                     </a:lnL>
@@ -8032,7 +7878,7 @@
                 </a:tc>
                 <a:tc>
                   <a:txBody>
-                    <a:bodyPr/>
+                    <a:bodyPr wrap="square"/>
                     <a:lstStyle/>
                     <a:p>
                       <a:pPr algn="ctr"/>
@@ -8048,7 +7894,7 @@
                       </a:r>
                     </a:p>
                   </a:txBody>
-                  <a:tcPr anchor="ctr">
+                  <a:tcPr marL="91440" marR="91440" marT="45720" marB="45720" anchor="ctr">
                     <a:lnL w="0">
                       <a:noFill/>
                     </a:lnL>
@@ -8066,16 +7912,11 @@
                     <a:noFill/>
                   </a:tcPr>
                 </a:tc>
-                <a:extLst>
-                  <a:ext uri="{0D108BD9-81ED-4DB2-BD59-A6C34878D82A}">
-                    <a16:rowId xmlns:a16="http://schemas.microsoft.com/office/drawing/2014/main" val="10001"/>
-                  </a:ext>
-                </a:extLst>
               </a:tr>
               <a:tr h="749808">
                 <a:tc>
                   <a:txBody>
-                    <a:bodyPr/>
+                    <a:bodyPr wrap="square"/>
                     <a:lstStyle/>
                     <a:p>
                       <a:pPr algn="l"/>
@@ -8091,21 +7932,15 @@
                       </a:r>
                     </a:p>
                   </a:txBody>
-                  <a:tcPr anchor="ctr">
+                  <a:tcPr marL="91440" marR="91440" marT="45720" marB="45720" anchor="ctr">
                     <a:lnL w="0">
                       <a:noFill/>
                     </a:lnL>
                     <a:lnR w="0">
                       <a:noFill/>
                     </a:lnR>
-                    <a:lnT w="9525" cap="flat" cmpd="sng" algn="ctr">
-                      <a:solidFill>
-                        <a:srgbClr val="BFBFBF"/>
-                      </a:solidFill>
-                      <a:prstDash val="solid"/>
-                      <a:round/>
-                      <a:headEnd type="none" w="med" len="med"/>
-                      <a:tailEnd type="none" w="med" len="med"/>
+                    <a:lnT w="0">
+                      <a:noFill/>
                     </a:lnT>
                     <a:lnB w="9525" cmpd="sng">
                       <a:solidFill>
@@ -8117,7 +7952,7 @@
                 </a:tc>
                 <a:tc>
                   <a:txBody>
-                    <a:bodyPr/>
+                    <a:bodyPr wrap="square"/>
                     <a:lstStyle/>
                     <a:p>
                       <a:pPr algn="ctr"/>
@@ -8143,21 +7978,15 @@
                       </a:r>
                     </a:p>
                   </a:txBody>
-                  <a:tcPr anchor="ctr">
+                  <a:tcPr marL="91440" marR="91440" marT="45720" marB="45720" anchor="ctr">
                     <a:lnL w="0">
                       <a:noFill/>
                     </a:lnL>
                     <a:lnR w="0">
                       <a:noFill/>
                     </a:lnR>
-                    <a:lnT w="9525" cap="flat" cmpd="sng" algn="ctr">
-                      <a:solidFill>
-                        <a:srgbClr val="BFBFBF"/>
-                      </a:solidFill>
-                      <a:prstDash val="solid"/>
-                      <a:round/>
-                      <a:headEnd type="none" w="med" len="med"/>
-                      <a:tailEnd type="none" w="med" len="med"/>
+                    <a:lnT w="0">
+                      <a:noFill/>
                     </a:lnT>
                     <a:lnB w="9525" cmpd="sng">
                       <a:solidFill>
@@ -8169,7 +7998,7 @@
                 </a:tc>
                 <a:tc>
                   <a:txBody>
-                    <a:bodyPr/>
+                    <a:bodyPr wrap="square"/>
                     <a:lstStyle/>
                     <a:p>
                       <a:pPr algn="ctr"/>
@@ -8195,21 +8024,15 @@
                       </a:r>
                     </a:p>
                   </a:txBody>
-                  <a:tcPr anchor="ctr">
+                  <a:tcPr marL="91440" marR="91440" marT="45720" marB="45720" anchor="ctr">
                     <a:lnL w="0">
                       <a:noFill/>
                     </a:lnL>
                     <a:lnR w="0">
                       <a:noFill/>
                     </a:lnR>
-                    <a:lnT w="9525" cap="flat" cmpd="sng" algn="ctr">
-                      <a:solidFill>
-                        <a:srgbClr val="BFBFBF"/>
-                      </a:solidFill>
-                      <a:prstDash val="solid"/>
-                      <a:round/>
-                      <a:headEnd type="none" w="med" len="med"/>
-                      <a:tailEnd type="none" w="med" len="med"/>
+                    <a:lnT w="0">
+                      <a:noFill/>
                     </a:lnT>
                     <a:lnB w="9525" cmpd="sng">
                       <a:solidFill>
@@ -8221,7 +8044,7 @@
                 </a:tc>
                 <a:tc>
                   <a:txBody>
-                    <a:bodyPr/>
+                    <a:bodyPr wrap="square"/>
                     <a:lstStyle/>
                     <a:p>
                       <a:pPr algn="ctr"/>
@@ -8237,21 +8060,15 @@
                       </a:r>
                     </a:p>
                   </a:txBody>
-                  <a:tcPr anchor="ctr">
+                  <a:tcPr marL="91440" marR="91440" marT="45720" marB="45720" anchor="ctr">
                     <a:lnL w="0">
                       <a:noFill/>
                     </a:lnL>
                     <a:lnR w="0">
                       <a:noFill/>
                     </a:lnR>
-                    <a:lnT w="9525" cap="flat" cmpd="sng" algn="ctr">
-                      <a:solidFill>
-                        <a:srgbClr val="BFBFBF"/>
-                      </a:solidFill>
-                      <a:prstDash val="solid"/>
-                      <a:round/>
-                      <a:headEnd type="none" w="med" len="med"/>
-                      <a:tailEnd type="none" w="med" len="med"/>
+                    <a:lnT w="0">
+                      <a:noFill/>
                     </a:lnT>
                     <a:lnB w="9525" cmpd="sng">
                       <a:solidFill>
@@ -8261,16 +8078,11 @@
                     <a:noFill/>
                   </a:tcPr>
                 </a:tc>
-                <a:extLst>
-                  <a:ext uri="{0D108BD9-81ED-4DB2-BD59-A6C34878D82A}">
-                    <a16:rowId xmlns:a16="http://schemas.microsoft.com/office/drawing/2014/main" val="10002"/>
-                  </a:ext>
-                </a:extLst>
               </a:tr>
               <a:tr h="749808">
                 <a:tc>
                   <a:txBody>
-                    <a:bodyPr/>
+                    <a:bodyPr wrap="square"/>
                     <a:lstStyle/>
                     <a:p>
                       <a:pPr algn="l"/>
@@ -8286,21 +8098,15 @@
                       </a:r>
                     </a:p>
                   </a:txBody>
-                  <a:tcPr anchor="ctr">
+                  <a:tcPr marL="91440" marR="91440" marT="45720" marB="45720" anchor="ctr">
                     <a:lnL w="0">
                       <a:noFill/>
                     </a:lnL>
                     <a:lnR w="0">
                       <a:noFill/>
                     </a:lnR>
-                    <a:lnT w="9525" cap="flat" cmpd="sng" algn="ctr">
-                      <a:solidFill>
-                        <a:srgbClr val="BFBFBF"/>
-                      </a:solidFill>
-                      <a:prstDash val="solid"/>
-                      <a:round/>
-                      <a:headEnd type="none" w="med" len="med"/>
-                      <a:tailEnd type="none" w="med" len="med"/>
+                    <a:lnT w="0">
+                      <a:noFill/>
                     </a:lnT>
                     <a:lnB w="9525" cmpd="sng">
                       <a:solidFill>
@@ -8312,7 +8118,7 @@
                 </a:tc>
                 <a:tc>
                   <a:txBody>
-                    <a:bodyPr/>
+                    <a:bodyPr wrap="square"/>
                     <a:lstStyle/>
                     <a:p>
                       <a:pPr algn="ctr"/>
@@ -8338,21 +8144,15 @@
                       </a:r>
                     </a:p>
                   </a:txBody>
-                  <a:tcPr anchor="ctr">
+                  <a:tcPr marL="91440" marR="91440" marT="45720" marB="45720" anchor="ctr">
                     <a:lnL w="0">
                       <a:noFill/>
                     </a:lnL>
                     <a:lnR w="0">
                       <a:noFill/>
                     </a:lnR>
-                    <a:lnT w="9525" cap="flat" cmpd="sng" algn="ctr">
-                      <a:solidFill>
-                        <a:srgbClr val="BFBFBF"/>
-                      </a:solidFill>
-                      <a:prstDash val="solid"/>
-                      <a:round/>
-                      <a:headEnd type="none" w="med" len="med"/>
-                      <a:tailEnd type="none" w="med" len="med"/>
+                    <a:lnT w="0">
+                      <a:noFill/>
                     </a:lnT>
                     <a:lnB w="9525" cmpd="sng">
                       <a:solidFill>
@@ -8364,7 +8164,7 @@
                 </a:tc>
                 <a:tc>
                   <a:txBody>
-                    <a:bodyPr/>
+                    <a:bodyPr wrap="square"/>
                     <a:lstStyle/>
                     <a:p>
                       <a:pPr algn="ctr"/>
@@ -8390,21 +8190,15 @@
                       </a:r>
                     </a:p>
                   </a:txBody>
-                  <a:tcPr anchor="ctr">
+                  <a:tcPr marL="91440" marR="91440" marT="45720" marB="45720" anchor="ctr">
                     <a:lnL w="0">
                       <a:noFill/>
                     </a:lnL>
                     <a:lnR w="0">
                       <a:noFill/>
                     </a:lnR>
-                    <a:lnT w="9525" cap="flat" cmpd="sng" algn="ctr">
-                      <a:solidFill>
-                        <a:srgbClr val="BFBFBF"/>
-                      </a:solidFill>
-                      <a:prstDash val="solid"/>
-                      <a:round/>
-                      <a:headEnd type="none" w="med" len="med"/>
-                      <a:tailEnd type="none" w="med" len="med"/>
+                    <a:lnT w="0">
+                      <a:noFill/>
                     </a:lnT>
                     <a:lnB w="9525" cmpd="sng">
                       <a:solidFill>
@@ -8416,7 +8210,7 @@
                 </a:tc>
                 <a:tc>
                   <a:txBody>
-                    <a:bodyPr/>
+                    <a:bodyPr wrap="square"/>
                     <a:lstStyle/>
                     <a:p>
                       <a:pPr algn="ctr"/>
@@ -8432,21 +8226,15 @@
                       </a:r>
                     </a:p>
                   </a:txBody>
-                  <a:tcPr anchor="ctr">
+                  <a:tcPr marL="91440" marR="91440" marT="45720" marB="45720" anchor="ctr">
                     <a:lnL w="0">
                       <a:noFill/>
                     </a:lnL>
                     <a:lnR w="0">
                       <a:noFill/>
                     </a:lnR>
-                    <a:lnT w="9525" cap="flat" cmpd="sng" algn="ctr">
-                      <a:solidFill>
-                        <a:srgbClr val="BFBFBF"/>
-                      </a:solidFill>
-                      <a:prstDash val="solid"/>
-                      <a:round/>
-                      <a:headEnd type="none" w="med" len="med"/>
-                      <a:tailEnd type="none" w="med" len="med"/>
+                    <a:lnT w="0">
+                      <a:noFill/>
                     </a:lnT>
                     <a:lnB w="9525" cmpd="sng">
                       <a:solidFill>
@@ -8456,16 +8244,11 @@
                     <a:noFill/>
                   </a:tcPr>
                 </a:tc>
-                <a:extLst>
-                  <a:ext uri="{0D108BD9-81ED-4DB2-BD59-A6C34878D82A}">
-                    <a16:rowId xmlns:a16="http://schemas.microsoft.com/office/drawing/2014/main" val="10003"/>
-                  </a:ext>
-                </a:extLst>
               </a:tr>
               <a:tr h="749808">
                 <a:tc>
                   <a:txBody>
-                    <a:bodyPr/>
+                    <a:bodyPr wrap="square"/>
                     <a:lstStyle/>
                     <a:p>
                       <a:pPr algn="l"/>
@@ -8481,21 +8264,15 @@
                       </a:r>
                     </a:p>
                   </a:txBody>
-                  <a:tcPr anchor="ctr">
+                  <a:tcPr marL="91440" marR="91440" marT="45720" marB="45720" anchor="ctr">
                     <a:lnL w="0">
                       <a:noFill/>
                     </a:lnL>
                     <a:lnR w="0">
                       <a:noFill/>
                     </a:lnR>
-                    <a:lnT w="9525" cap="flat" cmpd="sng" algn="ctr">
-                      <a:solidFill>
-                        <a:srgbClr val="BFBFBF"/>
-                      </a:solidFill>
-                      <a:prstDash val="solid"/>
-                      <a:round/>
-                      <a:headEnd type="none" w="med" len="med"/>
-                      <a:tailEnd type="none" w="med" len="med"/>
+                    <a:lnT w="0">
+                      <a:noFill/>
                     </a:lnT>
                     <a:lnB w="9525" cmpd="sng">
                       <a:solidFill>
@@ -8509,7 +8286,7 @@
                 </a:tc>
                 <a:tc>
                   <a:txBody>
-                    <a:bodyPr/>
+                    <a:bodyPr wrap="square"/>
                     <a:lstStyle/>
                     <a:p>
                       <a:pPr algn="ctr"/>
@@ -8535,21 +8312,15 @@
                       </a:r>
                     </a:p>
                   </a:txBody>
-                  <a:tcPr anchor="ctr">
+                  <a:tcPr marL="91440" marR="91440" marT="45720" marB="45720" anchor="ctr">
                     <a:lnL w="0">
                       <a:noFill/>
                     </a:lnL>
                     <a:lnR w="0">
                       <a:noFill/>
                     </a:lnR>
-                    <a:lnT w="9525" cap="flat" cmpd="sng" algn="ctr">
-                      <a:solidFill>
-                        <a:srgbClr val="BFBFBF"/>
-                      </a:solidFill>
-                      <a:prstDash val="solid"/>
-                      <a:round/>
-                      <a:headEnd type="none" w="med" len="med"/>
-                      <a:tailEnd type="none" w="med" len="med"/>
+                    <a:lnT w="0">
+                      <a:noFill/>
                     </a:lnT>
                     <a:lnB w="9525" cmpd="sng">
                       <a:solidFill>
@@ -8563,7 +8334,7 @@
                 </a:tc>
                 <a:tc>
                   <a:txBody>
-                    <a:bodyPr/>
+                    <a:bodyPr wrap="square"/>
                     <a:lstStyle/>
                     <a:p>
                       <a:pPr algn="ctr"/>
@@ -8579,21 +8350,15 @@
                       </a:r>
                     </a:p>
                   </a:txBody>
-                  <a:tcPr anchor="ctr">
+                  <a:tcPr marL="91440" marR="91440" marT="45720" marB="45720" anchor="ctr">
                     <a:lnL w="0">
                       <a:noFill/>
                     </a:lnL>
                     <a:lnR w="0">
                       <a:noFill/>
                     </a:lnR>
-                    <a:lnT w="9525" cap="flat" cmpd="sng" algn="ctr">
-                      <a:solidFill>
-                        <a:srgbClr val="BFBFBF"/>
-                      </a:solidFill>
-                      <a:prstDash val="solid"/>
-                      <a:round/>
-                      <a:headEnd type="none" w="med" len="med"/>
-                      <a:tailEnd type="none" w="med" len="med"/>
+                    <a:lnT w="0">
+                      <a:noFill/>
                     </a:lnT>
                     <a:lnB w="9525" cmpd="sng">
                       <a:solidFill>
@@ -8607,7 +8372,7 @@
                 </a:tc>
                 <a:tc>
                   <a:txBody>
-                    <a:bodyPr/>
+                    <a:bodyPr wrap="square"/>
                     <a:lstStyle/>
                     <a:p>
                       <a:pPr algn="ctr"/>
@@ -8623,21 +8388,15 @@
                       </a:r>
                     </a:p>
                   </a:txBody>
-                  <a:tcPr anchor="ctr">
+                  <a:tcPr marL="91440" marR="91440" marT="45720" marB="45720" anchor="ctr">
                     <a:lnL w="0">
                       <a:noFill/>
                     </a:lnL>
                     <a:lnR w="0">
                       <a:noFill/>
                     </a:lnR>
-                    <a:lnT w="9525" cap="flat" cmpd="sng" algn="ctr">
-                      <a:solidFill>
-                        <a:srgbClr val="BFBFBF"/>
-                      </a:solidFill>
-                      <a:prstDash val="solid"/>
-                      <a:round/>
-                      <a:headEnd type="none" w="med" len="med"/>
-                      <a:tailEnd type="none" w="med" len="med"/>
+                    <a:lnT w="0">
+                      <a:noFill/>
                     </a:lnT>
                     <a:lnB w="9525" cmpd="sng">
                       <a:solidFill>
@@ -8649,11 +8408,6 @@
                     </a:solidFill>
                   </a:tcPr>
                 </a:tc>
-                <a:extLst>
-                  <a:ext uri="{0D108BD9-81ED-4DB2-BD59-A6C34878D82A}">
-                    <a16:rowId xmlns:a16="http://schemas.microsoft.com/office/drawing/2014/main" val="10004"/>
-                  </a:ext>
-                </a:extLst>
               </a:tr>
             </a:tbl>
           </a:graphicData>
@@ -8676,7 +8430,7 @@
           <a:noFill/>
         </p:spPr>
         <p:txBody>
-          <a:bodyPr wrap="square" lIns="0" tIns="0" rIns="0" bIns="0" anchor="t"/>
+          <a:bodyPr wrap="square" lIns="0" rIns="0" tIns="0" bIns="0" anchor="t"/>
           <a:lstStyle/>
           <a:p>
             <a:pPr marL="0" indent="0" algn="l">
@@ -8707,7 +8461,7 @@
 </file>
 
 <file path=ppt/slides/slide4.xml><?xml version="1.0" encoding="utf-8"?>
-<p:sld xmlns:a="http://schemas.openxmlformats.org/drawingml/2006/main" xmlns:r="http://schemas.openxmlformats.org/officeDocument/2006/relationships" xmlns:p="http://schemas.openxmlformats.org/presentationml/2006/main">
+<p:sld xmlns:a="http://schemas.openxmlformats.org/drawingml/2006/main" xmlns:p="http://schemas.openxmlformats.org/presentationml/2006/main" xmlns:r="http://schemas.openxmlformats.org/officeDocument/2006/relationships">
   <p:cSld>
     <p:spTree>
       <p:nvGrpSpPr>
@@ -8715,14 +8469,7 @@
         <p:cNvGrpSpPr/>
         <p:nvPr/>
       </p:nvGrpSpPr>
-      <p:grpSpPr>
-        <a:xfrm>
-          <a:off x="0" y="0"/>
-          <a:ext cx="0" cy="0"/>
-          <a:chOff x="0" y="0"/>
-          <a:chExt cx="0" cy="0"/>
-        </a:xfrm>
-      </p:grpSpPr>
+      <p:grpSpPr/>
       <p:sp>
         <p:nvSpPr>
           <p:cNvPr id="4" name="Text Placeholder 3"/>
@@ -8730,7 +8477,7 @@
             <a:spLocks noGrp="1"/>
           </p:cNvSpPr>
           <p:nvPr>
-            <p:ph type="body" sz="quarter" idx="10"/>
+            <p:ph type="body" idx="10" sz="quarter"/>
           </p:nvPr>
         </p:nvSpPr>
         <p:spPr>
@@ -8798,7 +8545,7 @@
             <a:fld id="{18A41853-EF22-D446-BDBC-A7CF3FE93503}" type="slidenum">
               <a:rPr lang="en-US" smtClean="0"/>
               <a:pPr/>
-              <a:t>4</a:t>
+              <a:t>‹#›</a:t>
             </a:fld>
             <a:endParaRPr lang="en-US" dirty="0"/>
           </a:p>
@@ -8821,7 +8568,7 @@
           <a:noFill/>
         </p:spPr>
         <p:txBody>
-          <a:bodyPr wrap="square" lIns="0" tIns="0" rIns="0" bIns="0" anchor="t"/>
+          <a:bodyPr wrap="square" lIns="0" rIns="0" tIns="0" bIns="0" anchor="t"/>
           <a:lstStyle/>
           <a:p>
             <a:pPr marL="0" indent="0" algn="l">
@@ -8860,7 +8607,7 @@
           <a:noFill/>
         </p:spPr>
         <p:txBody>
-          <a:bodyPr wrap="square" lIns="0" tIns="0" rIns="0" bIns="0" anchor="ctr"/>
+          <a:bodyPr wrap="square" lIns="0" rIns="0" tIns="0" bIns="0" anchor="ctr"/>
           <a:lstStyle/>
           <a:p>
             <a:pPr marL="0" indent="0" algn="l">
@@ -8940,10 +8687,10 @@
           </a:ln>
         </p:spPr>
         <p:txBody>
-          <a:bodyPr wrap="square" lIns="146304" tIns="109728" rIns="146304" bIns="109728" rtlCol="0" anchor="ctr"/>
+          <a:bodyPr rtlCol="0" anchor="ctr" wrap="square" lIns="146304" rIns="146304" tIns="109728" bIns="109728"/>
           <a:lstStyle/>
           <a:p>
-            <a:pPr marL="0" indent="0" algn="l">
+            <a:pPr algn="l" marL="0" indent="0">
               <a:spcAft>
                 <a:spcPts val="400"/>
               </a:spcAft>
@@ -9004,10 +8751,10 @@
           </a:ln>
         </p:spPr>
         <p:txBody>
-          <a:bodyPr wrap="square" lIns="146304" tIns="109728" rIns="146304" bIns="109728" rtlCol="0" anchor="ctr"/>
+          <a:bodyPr rtlCol="0" anchor="ctr" wrap="square" lIns="146304" rIns="146304" tIns="109728" bIns="109728"/>
           <a:lstStyle/>
           <a:p>
-            <a:pPr marL="0" indent="0" algn="l">
+            <a:pPr algn="l" marL="0" indent="0">
               <a:spcAft>
                 <a:spcPts val="400"/>
               </a:spcAft>
@@ -9070,7 +8817,6 @@
           <a:lstStyle/>
           <a:p>
             <a:pPr algn="ctr"/>
-            <a:endParaRPr/>
           </a:p>
         </p:txBody>
       </p:sp>
@@ -9096,10 +8842,10 @@
           </a:ln>
         </p:spPr>
         <p:txBody>
-          <a:bodyPr wrap="square" lIns="146304" tIns="109728" rIns="146304" bIns="109728" rtlCol="0" anchor="ctr"/>
+          <a:bodyPr rtlCol="0" anchor="ctr" wrap="square" lIns="146304" rIns="146304" tIns="109728" bIns="109728"/>
           <a:lstStyle/>
           <a:p>
-            <a:pPr marL="0" indent="0" algn="l">
+            <a:pPr algn="l" marL="0" indent="0">
               <a:spcAft>
                 <a:spcPts val="400"/>
               </a:spcAft>
@@ -9162,7 +8908,6 @@
           <a:lstStyle/>
           <a:p>
             <a:pPr algn="ctr"/>
-            <a:endParaRPr/>
           </a:p>
         </p:txBody>
       </p:sp>
@@ -9183,7 +8928,7 @@
           <a:noFill/>
         </p:spPr>
         <p:txBody>
-          <a:bodyPr wrap="square" lIns="0" tIns="0" rIns="0" bIns="0" anchor="ctr"/>
+          <a:bodyPr wrap="square" lIns="0" rIns="0" tIns="0" bIns="0" anchor="ctr"/>
           <a:lstStyle/>
           <a:p>
             <a:pPr marL="0" indent="0" algn="l">
@@ -9263,10 +9008,10 @@
           </a:ln>
         </p:spPr>
         <p:txBody>
-          <a:bodyPr wrap="square" lIns="146304" tIns="109728" rIns="146304" bIns="109728" rtlCol="0" anchor="ctr"/>
+          <a:bodyPr rtlCol="0" anchor="ctr" wrap="square" lIns="146304" rIns="146304" tIns="109728" bIns="109728"/>
           <a:lstStyle/>
           <a:p>
-            <a:pPr marL="0" indent="0" algn="l">
+            <a:pPr algn="l" marL="0" indent="0">
               <a:spcAft>
                 <a:spcPts val="400"/>
               </a:spcAft>
@@ -9327,10 +9072,10 @@
           </a:ln>
         </p:spPr>
         <p:txBody>
-          <a:bodyPr wrap="square" lIns="146304" tIns="109728" rIns="146304" bIns="109728" rtlCol="0" anchor="ctr"/>
+          <a:bodyPr rtlCol="0" anchor="ctr" wrap="square" lIns="146304" rIns="146304" tIns="109728" bIns="109728"/>
           <a:lstStyle/>
           <a:p>
-            <a:pPr marL="0" indent="0" algn="l">
+            <a:pPr algn="l" marL="0" indent="0">
               <a:spcAft>
                 <a:spcPts val="400"/>
               </a:spcAft>
@@ -9393,7 +9138,6 @@
           <a:lstStyle/>
           <a:p>
             <a:pPr algn="ctr"/>
-            <a:endParaRPr/>
           </a:p>
         </p:txBody>
       </p:sp>
@@ -9419,10 +9163,10 @@
           </a:ln>
         </p:spPr>
         <p:txBody>
-          <a:bodyPr wrap="square" lIns="146304" tIns="109728" rIns="146304" bIns="109728" rtlCol="0" anchor="ctr"/>
+          <a:bodyPr rtlCol="0" anchor="ctr" wrap="square" lIns="146304" rIns="146304" tIns="109728" bIns="109728"/>
           <a:lstStyle/>
           <a:p>
-            <a:pPr marL="0" indent="0" algn="l">
+            <a:pPr algn="l" marL="0" indent="0">
               <a:spcAft>
                 <a:spcPts val="400"/>
               </a:spcAft>
@@ -9485,7 +9229,6 @@
           <a:lstStyle/>
           <a:p>
             <a:pPr algn="ctr"/>
-            <a:endParaRPr/>
           </a:p>
         </p:txBody>
       </p:sp>
@@ -9515,7 +9258,6 @@
           <a:lstStyle/>
           <a:p>
             <a:pPr algn="ctr"/>
-            <a:endParaRPr/>
           </a:p>
         </p:txBody>
       </p:sp>
@@ -9536,7 +9278,7 @@
           <a:noFill/>
         </p:spPr>
         <p:txBody>
-          <a:bodyPr wrap="square" lIns="0" tIns="0" rIns="0" bIns="0" anchor="t"/>
+          <a:bodyPr wrap="square" lIns="0" rIns="0" tIns="0" bIns="0" anchor="t"/>
           <a:lstStyle/>
           <a:p>
             <a:pPr marL="0" indent="0" algn="l">
@@ -9580,10 +9322,10 @@
           </a:ln>
         </p:spPr>
         <p:txBody>
-          <a:bodyPr wrap="square" lIns="228600" tIns="109728" rIns="228600" bIns="109728" rtlCol="0" anchor="ctr"/>
+          <a:bodyPr rtlCol="0" anchor="ctr" wrap="square" lIns="228600" rIns="228600" tIns="109728" bIns="109728"/>
           <a:lstStyle/>
           <a:p>
-            <a:pPr marL="0" indent="0" algn="l">
+            <a:pPr algn="l" marL="0" indent="0">
               <a:spcAft>
                 <a:spcPts val="0"/>
               </a:spcAft>
@@ -9621,7 +9363,7 @@
 </file>
 
 <file path=ppt/slides/slide5.xml><?xml version="1.0" encoding="utf-8"?>
-<p:sld xmlns:a="http://schemas.openxmlformats.org/drawingml/2006/main" xmlns:r="http://schemas.openxmlformats.org/officeDocument/2006/relationships" xmlns:p="http://schemas.openxmlformats.org/presentationml/2006/main">
+<p:sld xmlns:a="http://schemas.openxmlformats.org/drawingml/2006/main" xmlns:p="http://schemas.openxmlformats.org/presentationml/2006/main" xmlns:r="http://schemas.openxmlformats.org/officeDocument/2006/relationships">
   <p:cSld>
     <p:spTree>
       <p:nvGrpSpPr>
@@ -9629,14 +9371,7 @@
         <p:cNvGrpSpPr/>
         <p:nvPr/>
       </p:nvGrpSpPr>
-      <p:grpSpPr>
-        <a:xfrm>
-          <a:off x="0" y="0"/>
-          <a:ext cx="0" cy="0"/>
-          <a:chOff x="0" y="0"/>
-          <a:chExt cx="0" cy="0"/>
-        </a:xfrm>
-      </p:grpSpPr>
+      <p:grpSpPr/>
       <p:sp>
         <p:nvSpPr>
           <p:cNvPr id="4" name="Text Placeholder 3"/>
@@ -9644,7 +9379,7 @@
             <a:spLocks noGrp="1"/>
           </p:cNvSpPr>
           <p:nvPr>
-            <p:ph type="body" sz="quarter" idx="10"/>
+            <p:ph type="body" idx="10" sz="quarter"/>
           </p:nvPr>
         </p:nvSpPr>
         <p:spPr>
@@ -9712,7 +9447,7 @@
             <a:fld id="{18A41853-EF22-D446-BDBC-A7CF3FE93503}" type="slidenum">
               <a:rPr lang="en-US" smtClean="0"/>
               <a:pPr/>
-              <a:t>5</a:t>
+              <a:t>‹#›</a:t>
             </a:fld>
             <a:endParaRPr lang="en-US" dirty="0"/>
           </a:p>
@@ -9735,7 +9470,7 @@
           <a:noFill/>
         </p:spPr>
         <p:txBody>
-          <a:bodyPr wrap="square" lIns="0" tIns="0" rIns="0" bIns="0" anchor="t"/>
+          <a:bodyPr wrap="square" lIns="0" rIns="0" tIns="0" bIns="0" anchor="t"/>
           <a:lstStyle/>
           <a:p>
             <a:pPr marL="0" indent="0" algn="l">
@@ -9801,50 +9536,20 @@
         <a:graphic>
           <a:graphicData uri="http://schemas.openxmlformats.org/drawingml/2006/table">
             <a:tbl>
-              <a:tblPr>
+              <a:tblPr firstRow="0" bandRow="0">
                 <a:tableStyleId>{2D5ABB26-0587-4C30-8999-92F81FD0307C}</a:tableStyleId>
               </a:tblPr>
               <a:tblGrid>
-                <a:gridCol w="1051560">
-                  <a:extLst>
-                    <a:ext uri="{9D8B030D-6E8A-4147-A177-3AD203B41FA5}">
-                      <a16:colId xmlns:a16="http://schemas.microsoft.com/office/drawing/2014/main" val="20000"/>
-                    </a:ext>
-                  </a:extLst>
-                </a:gridCol>
-                <a:gridCol w="1280160">
-                  <a:extLst>
-                    <a:ext uri="{9D8B030D-6E8A-4147-A177-3AD203B41FA5}">
-                      <a16:colId xmlns:a16="http://schemas.microsoft.com/office/drawing/2014/main" val="20001"/>
-                    </a:ext>
-                  </a:extLst>
-                </a:gridCol>
-                <a:gridCol w="1234440">
-                  <a:extLst>
-                    <a:ext uri="{9D8B030D-6E8A-4147-A177-3AD203B41FA5}">
-                      <a16:colId xmlns:a16="http://schemas.microsoft.com/office/drawing/2014/main" val="20002"/>
-                    </a:ext>
-                  </a:extLst>
-                </a:gridCol>
-                <a:gridCol w="1234440">
-                  <a:extLst>
-                    <a:ext uri="{9D8B030D-6E8A-4147-A177-3AD203B41FA5}">
-                      <a16:colId xmlns:a16="http://schemas.microsoft.com/office/drawing/2014/main" val="20003"/>
-                    </a:ext>
-                  </a:extLst>
-                </a:gridCol>
-                <a:gridCol w="1271016">
-                  <a:extLst>
-                    <a:ext uri="{9D8B030D-6E8A-4147-A177-3AD203B41FA5}">
-                      <a16:colId xmlns:a16="http://schemas.microsoft.com/office/drawing/2014/main" val="20004"/>
-                    </a:ext>
-                  </a:extLst>
-                </a:gridCol>
+                <a:gridCol w="1051560"/>
+                <a:gridCol w="1280160"/>
+                <a:gridCol w="1234440"/>
+                <a:gridCol w="1234440"/>
+                <a:gridCol w="1271016"/>
               </a:tblGrid>
               <a:tr h="566928">
                 <a:tc>
                   <a:txBody>
-                    <a:bodyPr/>
+                    <a:bodyPr wrap="square"/>
                     <a:lstStyle/>
                     <a:p>
                       <a:pPr algn="l"/>
@@ -9860,7 +9565,7 @@
                       </a:r>
                     </a:p>
                   </a:txBody>
-                  <a:tcPr anchor="ctr">
+                  <a:tcPr marL="91440" marR="91440" marT="45720" marB="45720" anchor="ctr">
                     <a:lnL w="0">
                       <a:noFill/>
                     </a:lnL>
@@ -9880,7 +9585,7 @@
                 </a:tc>
                 <a:tc>
                   <a:txBody>
-                    <a:bodyPr/>
+                    <a:bodyPr wrap="square"/>
                     <a:lstStyle/>
                     <a:p>
                       <a:pPr algn="l"/>
@@ -9896,7 +9601,7 @@
                       </a:r>
                     </a:p>
                   </a:txBody>
-                  <a:tcPr anchor="ctr">
+                  <a:tcPr marL="91440" marR="91440" marT="45720" marB="45720" anchor="ctr">
                     <a:lnL w="0">
                       <a:noFill/>
                     </a:lnL>
@@ -9916,7 +9621,7 @@
                 </a:tc>
                 <a:tc>
                   <a:txBody>
-                    <a:bodyPr/>
+                    <a:bodyPr wrap="square"/>
                     <a:lstStyle/>
                     <a:p>
                       <a:pPr algn="l"/>
@@ -9932,7 +9637,7 @@
                       </a:r>
                     </a:p>
                   </a:txBody>
-                  <a:tcPr anchor="ctr">
+                  <a:tcPr marL="91440" marR="91440" marT="45720" marB="45720" anchor="ctr">
                     <a:lnL w="0">
                       <a:noFill/>
                     </a:lnL>
@@ -9952,7 +9657,7 @@
                 </a:tc>
                 <a:tc>
                   <a:txBody>
-                    <a:bodyPr/>
+                    <a:bodyPr wrap="square"/>
                     <a:lstStyle/>
                     <a:p>
                       <a:pPr algn="l"/>
@@ -9968,7 +9673,7 @@
                       </a:r>
                     </a:p>
                   </a:txBody>
-                  <a:tcPr anchor="ctr">
+                  <a:tcPr marL="91440" marR="91440" marT="45720" marB="45720" anchor="ctr">
                     <a:lnL w="0">
                       <a:noFill/>
                     </a:lnL>
@@ -9988,7 +9693,7 @@
                 </a:tc>
                 <a:tc>
                   <a:txBody>
-                    <a:bodyPr/>
+                    <a:bodyPr wrap="square"/>
                     <a:lstStyle/>
                     <a:p>
                       <a:pPr algn="l"/>
@@ -10004,7 +9709,7 @@
                       </a:r>
                     </a:p>
                   </a:txBody>
-                  <a:tcPr anchor="ctr">
+                  <a:tcPr marL="91440" marR="91440" marT="45720" marB="45720" anchor="ctr">
                     <a:lnL w="0">
                       <a:noFill/>
                     </a:lnL>
@@ -10022,16 +9727,11 @@
                     </a:solidFill>
                   </a:tcPr>
                 </a:tc>
-                <a:extLst>
-                  <a:ext uri="{0D108BD9-81ED-4DB2-BD59-A6C34878D82A}">
-                    <a16:rowId xmlns:a16="http://schemas.microsoft.com/office/drawing/2014/main" val="10000"/>
-                  </a:ext>
-                </a:extLst>
               </a:tr>
               <a:tr h="658368">
                 <a:tc>
                   <a:txBody>
-                    <a:bodyPr/>
+                    <a:bodyPr wrap="square"/>
                     <a:lstStyle/>
                     <a:p>
                       <a:pPr algn="l"/>
@@ -10047,7 +9747,7 @@
                       </a:r>
                     </a:p>
                   </a:txBody>
-                  <a:tcPr anchor="ctr">
+                  <a:tcPr marL="91440" marR="91440" marT="45720" marB="45720" anchor="ctr">
                     <a:lnL w="0">
                       <a:noFill/>
                     </a:lnL>
@@ -10067,7 +9767,7 @@
                 </a:tc>
                 <a:tc>
                   <a:txBody>
-                    <a:bodyPr/>
+                    <a:bodyPr wrap="square"/>
                     <a:lstStyle/>
                     <a:p>
                       <a:pPr algn="l"/>
@@ -10083,7 +9783,7 @@
                       </a:r>
                     </a:p>
                   </a:txBody>
-                  <a:tcPr anchor="ctr">
+                  <a:tcPr marL="91440" marR="91440" marT="45720" marB="45720" anchor="ctr">
                     <a:lnL w="0">
                       <a:noFill/>
                     </a:lnL>
@@ -10103,7 +9803,7 @@
                 </a:tc>
                 <a:tc>
                   <a:txBody>
-                    <a:bodyPr/>
+                    <a:bodyPr wrap="square"/>
                     <a:lstStyle/>
                     <a:p>
                       <a:pPr algn="l"/>
@@ -10129,7 +9829,7 @@
                       </a:r>
                     </a:p>
                   </a:txBody>
-                  <a:tcPr anchor="ctr">
+                  <a:tcPr marL="91440" marR="91440" marT="45720" marB="45720" anchor="ctr">
                     <a:lnL w="0">
                       <a:noFill/>
                     </a:lnL>
@@ -10151,7 +9851,7 @@
                 </a:tc>
                 <a:tc>
                   <a:txBody>
-                    <a:bodyPr/>
+                    <a:bodyPr wrap="square"/>
                     <a:lstStyle/>
                     <a:p>
                       <a:pPr algn="l"/>
@@ -10177,7 +9877,7 @@
                       </a:r>
                     </a:p>
                   </a:txBody>
-                  <a:tcPr anchor="ctr">
+                  <a:tcPr marL="91440" marR="91440" marT="45720" marB="45720" anchor="ctr">
                     <a:lnL w="0">
                       <a:noFill/>
                     </a:lnL>
@@ -10199,7 +9899,7 @@
                 </a:tc>
                 <a:tc>
                   <a:txBody>
-                    <a:bodyPr/>
+                    <a:bodyPr wrap="square"/>
                     <a:lstStyle/>
                     <a:p>
                       <a:pPr algn="l"/>
@@ -10225,7 +9925,7 @@
                       </a:r>
                     </a:p>
                   </a:txBody>
-                  <a:tcPr anchor="ctr">
+                  <a:tcPr marL="91440" marR="91440" marT="45720" marB="45720" anchor="ctr">
                     <a:lnL w="0">
                       <a:noFill/>
                     </a:lnL>
@@ -10245,16 +9945,11 @@
                     </a:solidFill>
                   </a:tcPr>
                 </a:tc>
-                <a:extLst>
-                  <a:ext uri="{0D108BD9-81ED-4DB2-BD59-A6C34878D82A}">
-                    <a16:rowId xmlns:a16="http://schemas.microsoft.com/office/drawing/2014/main" val="10001"/>
-                  </a:ext>
-                </a:extLst>
               </a:tr>
               <a:tr h="658368">
                 <a:tc>
                   <a:txBody>
-                    <a:bodyPr/>
+                    <a:bodyPr wrap="square"/>
                     <a:lstStyle/>
                     <a:p>
                       <a:pPr algn="l"/>
@@ -10270,21 +9965,15 @@
                       </a:r>
                     </a:p>
                   </a:txBody>
-                  <a:tcPr anchor="ctr">
+                  <a:tcPr marL="91440" marR="91440" marT="45720" marB="45720" anchor="ctr">
                     <a:lnL w="0">
                       <a:noFill/>
                     </a:lnL>
                     <a:lnR w="0">
                       <a:noFill/>
                     </a:lnR>
-                    <a:lnT w="19050" cap="flat" cmpd="sng" algn="ctr">
-                      <a:solidFill>
-                        <a:srgbClr val="FFFFFF"/>
-                      </a:solidFill>
-                      <a:prstDash val="solid"/>
-                      <a:round/>
-                      <a:headEnd type="none" w="med" len="med"/>
-                      <a:tailEnd type="none" w="med" len="med"/>
+                    <a:lnT w="0">
+                      <a:noFill/>
                     </a:lnT>
                     <a:lnB w="19050" cmpd="sng">
                       <a:solidFill>
@@ -10296,7 +9985,7 @@
                 </a:tc>
                 <a:tc>
                   <a:txBody>
-                    <a:bodyPr/>
+                    <a:bodyPr wrap="square"/>
                     <a:lstStyle/>
                     <a:p>
                       <a:pPr algn="l"/>
@@ -10312,21 +10001,15 @@
                       </a:r>
                     </a:p>
                   </a:txBody>
-                  <a:tcPr anchor="ctr">
+                  <a:tcPr marL="91440" marR="91440" marT="45720" marB="45720" anchor="ctr">
                     <a:lnL w="0">
                       <a:noFill/>
                     </a:lnL>
                     <a:lnR w="0">
                       <a:noFill/>
                     </a:lnR>
-                    <a:lnT w="19050" cap="flat" cmpd="sng" algn="ctr">
-                      <a:solidFill>
-                        <a:srgbClr val="FFFFFF"/>
-                      </a:solidFill>
-                      <a:prstDash val="solid"/>
-                      <a:round/>
-                      <a:headEnd type="none" w="med" len="med"/>
-                      <a:tailEnd type="none" w="med" len="med"/>
+                    <a:lnT w="0">
+                      <a:noFill/>
                     </a:lnT>
                     <a:lnB w="19050" cmpd="sng">
                       <a:solidFill>
@@ -10338,7 +10021,7 @@
                 </a:tc>
                 <a:tc>
                   <a:txBody>
-                    <a:bodyPr/>
+                    <a:bodyPr wrap="square"/>
                     <a:lstStyle/>
                     <a:p>
                       <a:pPr algn="l"/>
@@ -10364,21 +10047,15 @@
                       </a:r>
                     </a:p>
                   </a:txBody>
-                  <a:tcPr anchor="ctr">
+                  <a:tcPr marL="91440" marR="91440" marT="45720" marB="45720" anchor="ctr">
                     <a:lnL w="0">
                       <a:noFill/>
                     </a:lnL>
                     <a:lnR w="0">
                       <a:noFill/>
                     </a:lnR>
-                    <a:lnT w="19050" cap="flat" cmpd="sng" algn="ctr">
-                      <a:solidFill>
-                        <a:srgbClr val="FFFFFF"/>
-                      </a:solidFill>
-                      <a:prstDash val="solid"/>
-                      <a:round/>
-                      <a:headEnd type="none" w="med" len="med"/>
-                      <a:tailEnd type="none" w="med" len="med"/>
+                    <a:lnT w="0">
+                      <a:noFill/>
                     </a:lnT>
                     <a:lnB w="19050" cmpd="sng">
                       <a:solidFill>
@@ -10392,7 +10069,7 @@
                 </a:tc>
                 <a:tc>
                   <a:txBody>
-                    <a:bodyPr/>
+                    <a:bodyPr wrap="square"/>
                     <a:lstStyle/>
                     <a:p>
                       <a:pPr algn="l"/>
@@ -10418,21 +10095,15 @@
                       </a:r>
                     </a:p>
                   </a:txBody>
-                  <a:tcPr anchor="ctr">
+                  <a:tcPr marL="91440" marR="91440" marT="45720" marB="45720" anchor="ctr">
                     <a:lnL w="0">
                       <a:noFill/>
                     </a:lnL>
                     <a:lnR w="0">
                       <a:noFill/>
                     </a:lnR>
-                    <a:lnT w="19050" cap="flat" cmpd="sng" algn="ctr">
-                      <a:solidFill>
-                        <a:srgbClr val="FFFFFF"/>
-                      </a:solidFill>
-                      <a:prstDash val="solid"/>
-                      <a:round/>
-                      <a:headEnd type="none" w="med" len="med"/>
-                      <a:tailEnd type="none" w="med" len="med"/>
+                    <a:lnT w="0">
+                      <a:noFill/>
                     </a:lnT>
                     <a:lnB w="19050" cmpd="sng">
                       <a:solidFill>
@@ -10446,7 +10117,7 @@
                 </a:tc>
                 <a:tc>
                   <a:txBody>
-                    <a:bodyPr/>
+                    <a:bodyPr wrap="square"/>
                     <a:lstStyle/>
                     <a:p>
                       <a:pPr algn="l"/>
@@ -10472,21 +10143,15 @@
                       </a:r>
                     </a:p>
                   </a:txBody>
-                  <a:tcPr anchor="ctr">
+                  <a:tcPr marL="91440" marR="91440" marT="45720" marB="45720" anchor="ctr">
                     <a:lnL w="0">
                       <a:noFill/>
                     </a:lnL>
                     <a:lnR w="0">
                       <a:noFill/>
                     </a:lnR>
-                    <a:lnT w="19050" cap="flat" cmpd="sng" algn="ctr">
-                      <a:solidFill>
-                        <a:srgbClr val="FFFFFF"/>
-                      </a:solidFill>
-                      <a:prstDash val="solid"/>
-                      <a:round/>
-                      <a:headEnd type="none" w="med" len="med"/>
-                      <a:tailEnd type="none" w="med" len="med"/>
+                    <a:lnT w="0">
+                      <a:noFill/>
                     </a:lnT>
                     <a:lnB w="19050" cmpd="sng">
                       <a:solidFill>
@@ -10498,11 +10163,6 @@
                     </a:solidFill>
                   </a:tcPr>
                 </a:tc>
-                <a:extLst>
-                  <a:ext uri="{0D108BD9-81ED-4DB2-BD59-A6C34878D82A}">
-                    <a16:rowId xmlns:a16="http://schemas.microsoft.com/office/drawing/2014/main" val="10002"/>
-                  </a:ext>
-                </a:extLst>
               </a:tr>
             </a:tbl>
           </a:graphicData>
@@ -10525,7 +10185,7 @@
           <a:noFill/>
         </p:spPr>
         <p:txBody>
-          <a:bodyPr wrap="square" lIns="0" tIns="0" rIns="0" bIns="0" anchor="t"/>
+          <a:bodyPr wrap="square" lIns="0" rIns="0" tIns="0" bIns="0" anchor="t"/>
           <a:lstStyle/>
           <a:p>
             <a:pPr marL="182880" indent="-182880" algn="l">
@@ -10603,7 +10263,7 @@
           <a:noFill/>
         </p:spPr>
         <p:txBody>
-          <a:bodyPr wrap="square" lIns="0" tIns="0" rIns="0" bIns="0" anchor="t"/>
+          <a:bodyPr wrap="square" lIns="0" rIns="0" tIns="0" bIns="0" anchor="t"/>
           <a:lstStyle/>
           <a:p>
             <a:pPr marL="0" indent="0" algn="l">
@@ -10634,7 +10294,7 @@
 </file>
 
 <file path=ppt/slides/slide6.xml><?xml version="1.0" encoding="utf-8"?>
-<p:sld xmlns:a="http://schemas.openxmlformats.org/drawingml/2006/main" xmlns:r="http://schemas.openxmlformats.org/officeDocument/2006/relationships" xmlns:p="http://schemas.openxmlformats.org/presentationml/2006/main">
+<p:sld xmlns:a="http://schemas.openxmlformats.org/drawingml/2006/main" xmlns:p="http://schemas.openxmlformats.org/presentationml/2006/main" xmlns:r="http://schemas.openxmlformats.org/officeDocument/2006/relationships">
   <p:cSld>
     <p:spTree>
       <p:nvGrpSpPr>
@@ -10642,14 +10302,7 @@
         <p:cNvGrpSpPr/>
         <p:nvPr/>
       </p:nvGrpSpPr>
-      <p:grpSpPr>
-        <a:xfrm>
-          <a:off x="0" y="0"/>
-          <a:ext cx="0" cy="0"/>
-          <a:chOff x="0" y="0"/>
-          <a:chExt cx="0" cy="0"/>
-        </a:xfrm>
-      </p:grpSpPr>
+      <p:grpSpPr/>
       <p:sp>
         <p:nvSpPr>
           <p:cNvPr id="4" name="Text Placeholder 3"/>
@@ -10657,7 +10310,7 @@
             <a:spLocks noGrp="1"/>
           </p:cNvSpPr>
           <p:nvPr>
-            <p:ph type="body" sz="quarter" idx="10"/>
+            <p:ph type="body" idx="10" sz="quarter"/>
           </p:nvPr>
         </p:nvSpPr>
         <p:spPr>
@@ -10725,7 +10378,7 @@
             <a:fld id="{18A41853-EF22-D446-BDBC-A7CF3FE93503}" type="slidenum">
               <a:rPr lang="en-US" smtClean="0"/>
               <a:pPr/>
-              <a:t>6</a:t>
+              <a:t>‹#›</a:t>
             </a:fld>
             <a:endParaRPr lang="en-US" dirty="0"/>
           </a:p>
@@ -10748,7 +10401,7 @@
           <a:noFill/>
         </p:spPr>
         <p:txBody>
-          <a:bodyPr wrap="square" lIns="0" tIns="0" rIns="0" bIns="0" anchor="t"/>
+          <a:bodyPr wrap="square" lIns="0" rIns="0" tIns="0" bIns="0" anchor="t"/>
           <a:lstStyle/>
           <a:p>
             <a:pPr marL="0" indent="0" algn="l">
@@ -10816,7 +10469,7 @@
           <a:noFill/>
         </p:spPr>
         <p:txBody>
-          <a:bodyPr wrap="square" lIns="0" tIns="0" rIns="0" bIns="0" anchor="t"/>
+          <a:bodyPr wrap="square" lIns="0" rIns="0" tIns="0" bIns="0" anchor="t"/>
           <a:lstStyle/>
           <a:p>
             <a:pPr marL="0" indent="0" algn="l">
@@ -10860,10 +10513,10 @@
           </a:ln>
         </p:spPr>
         <p:txBody>
-          <a:bodyPr wrap="square" lIns="182880" tIns="109728" rIns="182880" bIns="109728" rtlCol="0" anchor="t"/>
+          <a:bodyPr rtlCol="0" anchor="t" wrap="square" lIns="182880" rIns="182880" tIns="109728" bIns="109728"/>
           <a:lstStyle/>
           <a:p>
-            <a:pPr marL="0" indent="0" algn="l">
+            <a:pPr algn="l" marL="0" indent="0">
               <a:spcAft>
                 <a:spcPts val="800"/>
               </a:spcAft>
@@ -10922,10 +10575,10 @@
           </a:ln>
         </p:spPr>
         <p:txBody>
-          <a:bodyPr wrap="square" lIns="182880" tIns="109728" rIns="182880" bIns="109728" rtlCol="0" anchor="t"/>
+          <a:bodyPr rtlCol="0" anchor="t" wrap="square" lIns="182880" rIns="182880" tIns="109728" bIns="109728"/>
           <a:lstStyle/>
           <a:p>
-            <a:pPr marL="0" indent="0" algn="l">
+            <a:pPr algn="l" marL="0" indent="0">
               <a:spcAft>
                 <a:spcPts val="800"/>
               </a:spcAft>
@@ -10984,10 +10637,10 @@
           </a:ln>
         </p:spPr>
         <p:txBody>
-          <a:bodyPr wrap="square" lIns="182880" tIns="109728" rIns="182880" bIns="109728" rtlCol="0" anchor="t"/>
+          <a:bodyPr rtlCol="0" anchor="t" wrap="square" lIns="182880" rIns="182880" tIns="109728" bIns="109728"/>
           <a:lstStyle/>
           <a:p>
-            <a:pPr marL="0" indent="0" algn="l">
+            <a:pPr algn="l" marL="0" indent="0">
               <a:spcAft>
                 <a:spcPts val="800"/>
               </a:spcAft>
@@ -11041,7 +10694,7 @@
           <a:noFill/>
         </p:spPr>
         <p:txBody>
-          <a:bodyPr wrap="square" lIns="0" tIns="0" rIns="0" bIns="0" anchor="t"/>
+          <a:bodyPr wrap="square" lIns="0" rIns="0" tIns="0" bIns="0" anchor="t"/>
           <a:lstStyle/>
           <a:p>
             <a:pPr marL="0" indent="0" algn="l">
@@ -11072,7 +10725,7 @@
 </file>
 
 <file path=ppt/slides/slide7.xml><?xml version="1.0" encoding="utf-8"?>
-<p:sld xmlns:a="http://schemas.openxmlformats.org/drawingml/2006/main" xmlns:r="http://schemas.openxmlformats.org/officeDocument/2006/relationships" xmlns:p="http://schemas.openxmlformats.org/presentationml/2006/main">
+<p:sld xmlns:a="http://schemas.openxmlformats.org/drawingml/2006/main" xmlns:p="http://schemas.openxmlformats.org/presentationml/2006/main" xmlns:r="http://schemas.openxmlformats.org/officeDocument/2006/relationships">
   <p:cSld>
     <p:spTree>
       <p:nvGrpSpPr>
@@ -11080,14 +10733,7 @@
         <p:cNvGrpSpPr/>
         <p:nvPr/>
       </p:nvGrpSpPr>
-      <p:grpSpPr>
-        <a:xfrm>
-          <a:off x="0" y="0"/>
-          <a:ext cx="0" cy="0"/>
-          <a:chOff x="0" y="0"/>
-          <a:chExt cx="0" cy="0"/>
-        </a:xfrm>
-      </p:grpSpPr>
+      <p:grpSpPr/>
       <p:sp>
         <p:nvSpPr>
           <p:cNvPr id="4" name="Text Placeholder 3"/>
@@ -11095,7 +10741,7 @@
             <a:spLocks noGrp="1"/>
           </p:cNvSpPr>
           <p:nvPr>
-            <p:ph type="body" sz="quarter" idx="10"/>
+            <p:ph type="body" idx="10" sz="quarter"/>
           </p:nvPr>
         </p:nvSpPr>
         <p:spPr>
@@ -11163,7 +10809,7 @@
             <a:fld id="{18A41853-EF22-D446-BDBC-A7CF3FE93503}" type="slidenum">
               <a:rPr lang="en-US" smtClean="0"/>
               <a:pPr/>
-              <a:t>7</a:t>
+              <a:t>‹#›</a:t>
             </a:fld>
             <a:endParaRPr lang="en-US" dirty="0"/>
           </a:p>
@@ -11186,7 +10832,7 @@
           <a:noFill/>
         </p:spPr>
         <p:txBody>
-          <a:bodyPr wrap="square" lIns="0" tIns="0" rIns="0" bIns="0" anchor="t"/>
+          <a:bodyPr wrap="square" lIns="0" rIns="0" tIns="0" bIns="0" anchor="t"/>
           <a:lstStyle/>
           <a:p>
             <a:pPr marL="0" indent="0" algn="l">
@@ -11281,50 +10927,20 @@
         <a:graphic>
           <a:graphicData uri="http://schemas.openxmlformats.org/drawingml/2006/table">
             <a:tbl>
-              <a:tblPr>
+              <a:tblPr firstRow="0" bandRow="0">
                 <a:tableStyleId>{2D5ABB26-0587-4C30-8999-92F81FD0307C}</a:tableStyleId>
               </a:tblPr>
               <a:tblGrid>
-                <a:gridCol w="1051560">
-                  <a:extLst>
-                    <a:ext uri="{9D8B030D-6E8A-4147-A177-3AD203B41FA5}">
-                      <a16:colId xmlns:a16="http://schemas.microsoft.com/office/drawing/2014/main" val="20000"/>
-                    </a:ext>
-                  </a:extLst>
-                </a:gridCol>
-                <a:gridCol w="1280160">
-                  <a:extLst>
-                    <a:ext uri="{9D8B030D-6E8A-4147-A177-3AD203B41FA5}">
-                      <a16:colId xmlns:a16="http://schemas.microsoft.com/office/drawing/2014/main" val="20001"/>
-                    </a:ext>
-                  </a:extLst>
-                </a:gridCol>
-                <a:gridCol w="1234440">
-                  <a:extLst>
-                    <a:ext uri="{9D8B030D-6E8A-4147-A177-3AD203B41FA5}">
-                      <a16:colId xmlns:a16="http://schemas.microsoft.com/office/drawing/2014/main" val="20002"/>
-                    </a:ext>
-                  </a:extLst>
-                </a:gridCol>
-                <a:gridCol w="1234440">
-                  <a:extLst>
-                    <a:ext uri="{9D8B030D-6E8A-4147-A177-3AD203B41FA5}">
-                      <a16:colId xmlns:a16="http://schemas.microsoft.com/office/drawing/2014/main" val="20003"/>
-                    </a:ext>
-                  </a:extLst>
-                </a:gridCol>
-                <a:gridCol w="1271016">
-                  <a:extLst>
-                    <a:ext uri="{9D8B030D-6E8A-4147-A177-3AD203B41FA5}">
-                      <a16:colId xmlns:a16="http://schemas.microsoft.com/office/drawing/2014/main" val="20004"/>
-                    </a:ext>
-                  </a:extLst>
-                </a:gridCol>
+                <a:gridCol w="1051560"/>
+                <a:gridCol w="1280160"/>
+                <a:gridCol w="1234440"/>
+                <a:gridCol w="1234440"/>
+                <a:gridCol w="1271016"/>
               </a:tblGrid>
               <a:tr h="566928">
                 <a:tc>
                   <a:txBody>
-                    <a:bodyPr/>
+                    <a:bodyPr wrap="square"/>
                     <a:lstStyle/>
                     <a:p>
                       <a:pPr algn="l"/>
@@ -11340,7 +10956,7 @@
                       </a:r>
                     </a:p>
                   </a:txBody>
-                  <a:tcPr anchor="ctr">
+                  <a:tcPr marL="91440" marR="91440" marT="45720" marB="45720" anchor="ctr">
                     <a:lnL w="0">
                       <a:noFill/>
                     </a:lnL>
@@ -11360,7 +10976,7 @@
                 </a:tc>
                 <a:tc>
                   <a:txBody>
-                    <a:bodyPr/>
+                    <a:bodyPr wrap="square"/>
                     <a:lstStyle/>
                     <a:p>
                       <a:pPr algn="l"/>
@@ -11376,7 +10992,7 @@
                       </a:r>
                     </a:p>
                   </a:txBody>
-                  <a:tcPr anchor="ctr">
+                  <a:tcPr marL="91440" marR="91440" marT="45720" marB="45720" anchor="ctr">
                     <a:lnL w="0">
                       <a:noFill/>
                     </a:lnL>
@@ -11396,7 +11012,7 @@
                 </a:tc>
                 <a:tc>
                   <a:txBody>
-                    <a:bodyPr/>
+                    <a:bodyPr wrap="square"/>
                     <a:lstStyle/>
                     <a:p>
                       <a:pPr algn="l"/>
@@ -11412,7 +11028,7 @@
                       </a:r>
                     </a:p>
                   </a:txBody>
-                  <a:tcPr anchor="ctr">
+                  <a:tcPr marL="91440" marR="91440" marT="45720" marB="45720" anchor="ctr">
                     <a:lnL w="0">
                       <a:noFill/>
                     </a:lnL>
@@ -11432,7 +11048,7 @@
                 </a:tc>
                 <a:tc>
                   <a:txBody>
-                    <a:bodyPr/>
+                    <a:bodyPr wrap="square"/>
                     <a:lstStyle/>
                     <a:p>
                       <a:pPr algn="l"/>
@@ -11448,7 +11064,7 @@
                       </a:r>
                     </a:p>
                   </a:txBody>
-                  <a:tcPr anchor="ctr">
+                  <a:tcPr marL="91440" marR="91440" marT="45720" marB="45720" anchor="ctr">
                     <a:lnL w="0">
                       <a:noFill/>
                     </a:lnL>
@@ -11468,7 +11084,7 @@
                 </a:tc>
                 <a:tc>
                   <a:txBody>
-                    <a:bodyPr/>
+                    <a:bodyPr wrap="square"/>
                     <a:lstStyle/>
                     <a:p>
                       <a:pPr algn="l"/>
@@ -11484,7 +11100,7 @@
                       </a:r>
                     </a:p>
                   </a:txBody>
-                  <a:tcPr anchor="ctr">
+                  <a:tcPr marL="91440" marR="91440" marT="45720" marB="45720" anchor="ctr">
                     <a:lnL w="0">
                       <a:noFill/>
                     </a:lnL>
@@ -11502,16 +11118,11 @@
                     </a:solidFill>
                   </a:tcPr>
                 </a:tc>
-                <a:extLst>
-                  <a:ext uri="{0D108BD9-81ED-4DB2-BD59-A6C34878D82A}">
-                    <a16:rowId xmlns:a16="http://schemas.microsoft.com/office/drawing/2014/main" val="10000"/>
-                  </a:ext>
-                </a:extLst>
               </a:tr>
               <a:tr h="621792">
                 <a:tc>
                   <a:txBody>
-                    <a:bodyPr/>
+                    <a:bodyPr wrap="square"/>
                     <a:lstStyle/>
                     <a:p>
                       <a:pPr algn="l"/>
@@ -11527,7 +11138,7 @@
                       </a:r>
                     </a:p>
                   </a:txBody>
-                  <a:tcPr anchor="ctr">
+                  <a:tcPr marL="91440" marR="91440" marT="45720" marB="45720" anchor="ctr">
                     <a:lnL w="0">
                       <a:noFill/>
                     </a:lnL>
@@ -11547,7 +11158,7 @@
                 </a:tc>
                 <a:tc>
                   <a:txBody>
-                    <a:bodyPr/>
+                    <a:bodyPr wrap="square"/>
                     <a:lstStyle/>
                     <a:p>
                       <a:pPr algn="l"/>
@@ -11563,7 +11174,7 @@
                       </a:r>
                     </a:p>
                   </a:txBody>
-                  <a:tcPr anchor="ctr">
+                  <a:tcPr marL="91440" marR="91440" marT="45720" marB="45720" anchor="ctr">
                     <a:lnL w="0">
                       <a:noFill/>
                     </a:lnL>
@@ -11583,7 +11194,7 @@
                 </a:tc>
                 <a:tc>
                   <a:txBody>
-                    <a:bodyPr/>
+                    <a:bodyPr wrap="square"/>
                     <a:lstStyle/>
                     <a:p>
                       <a:pPr algn="l"/>
@@ -11609,7 +11220,7 @@
                       </a:r>
                     </a:p>
                   </a:txBody>
-                  <a:tcPr anchor="ctr">
+                  <a:tcPr marL="91440" marR="91440" marT="45720" marB="45720" anchor="ctr">
                     <a:lnL w="0">
                       <a:noFill/>
                     </a:lnL>
@@ -11631,7 +11242,7 @@
                 </a:tc>
                 <a:tc>
                   <a:txBody>
-                    <a:bodyPr/>
+                    <a:bodyPr wrap="square"/>
                     <a:lstStyle/>
                     <a:p>
                       <a:pPr algn="l"/>
@@ -11657,7 +11268,7 @@
                       </a:r>
                     </a:p>
                   </a:txBody>
-                  <a:tcPr anchor="ctr">
+                  <a:tcPr marL="91440" marR="91440" marT="45720" marB="45720" anchor="ctr">
                     <a:lnL w="0">
                       <a:noFill/>
                     </a:lnL>
@@ -11679,7 +11290,7 @@
                 </a:tc>
                 <a:tc>
                   <a:txBody>
-                    <a:bodyPr/>
+                    <a:bodyPr wrap="square"/>
                     <a:lstStyle/>
                     <a:p>
                       <a:pPr algn="l"/>
@@ -11705,7 +11316,7 @@
                       </a:r>
                     </a:p>
                   </a:txBody>
-                  <a:tcPr anchor="ctr">
+                  <a:tcPr marL="91440" marR="91440" marT="45720" marB="45720" anchor="ctr">
                     <a:lnL w="0">
                       <a:noFill/>
                     </a:lnL>
@@ -11725,16 +11336,11 @@
                     </a:solidFill>
                   </a:tcPr>
                 </a:tc>
-                <a:extLst>
-                  <a:ext uri="{0D108BD9-81ED-4DB2-BD59-A6C34878D82A}">
-                    <a16:rowId xmlns:a16="http://schemas.microsoft.com/office/drawing/2014/main" val="10001"/>
-                  </a:ext>
-                </a:extLst>
               </a:tr>
               <a:tr h="621792">
                 <a:tc>
                   <a:txBody>
-                    <a:bodyPr/>
+                    <a:bodyPr wrap="square"/>
                     <a:lstStyle/>
                     <a:p>
                       <a:pPr algn="l"/>
@@ -11750,21 +11356,15 @@
                       </a:r>
                     </a:p>
                   </a:txBody>
-                  <a:tcPr anchor="ctr">
+                  <a:tcPr marL="91440" marR="91440" marT="45720" marB="45720" anchor="ctr">
                     <a:lnL w="0">
                       <a:noFill/>
                     </a:lnL>
                     <a:lnR w="0">
                       <a:noFill/>
                     </a:lnR>
-                    <a:lnT w="19050" cap="flat" cmpd="sng" algn="ctr">
-                      <a:solidFill>
-                        <a:srgbClr val="FFFFFF"/>
-                      </a:solidFill>
-                      <a:prstDash val="solid"/>
-                      <a:round/>
-                      <a:headEnd type="none" w="med" len="med"/>
-                      <a:tailEnd type="none" w="med" len="med"/>
+                    <a:lnT w="0">
+                      <a:noFill/>
                     </a:lnT>
                     <a:lnB w="19050" cmpd="sng">
                       <a:solidFill>
@@ -11776,7 +11376,7 @@
                 </a:tc>
                 <a:tc>
                   <a:txBody>
-                    <a:bodyPr/>
+                    <a:bodyPr wrap="square"/>
                     <a:lstStyle/>
                     <a:p>
                       <a:pPr algn="l"/>
@@ -11792,21 +11392,15 @@
                       </a:r>
                     </a:p>
                   </a:txBody>
-                  <a:tcPr anchor="ctr">
+                  <a:tcPr marL="91440" marR="91440" marT="45720" marB="45720" anchor="ctr">
                     <a:lnL w="0">
                       <a:noFill/>
                     </a:lnL>
                     <a:lnR w="0">
                       <a:noFill/>
                     </a:lnR>
-                    <a:lnT w="19050" cap="flat" cmpd="sng" algn="ctr">
-                      <a:solidFill>
-                        <a:srgbClr val="FFFFFF"/>
-                      </a:solidFill>
-                      <a:prstDash val="solid"/>
-                      <a:round/>
-                      <a:headEnd type="none" w="med" len="med"/>
-                      <a:tailEnd type="none" w="med" len="med"/>
+                    <a:lnT w="0">
+                      <a:noFill/>
                     </a:lnT>
                     <a:lnB w="19050" cmpd="sng">
                       <a:solidFill>
@@ -11818,7 +11412,7 @@
                 </a:tc>
                 <a:tc>
                   <a:txBody>
-                    <a:bodyPr/>
+                    <a:bodyPr wrap="square"/>
                     <a:lstStyle/>
                     <a:p>
                       <a:pPr algn="l"/>
@@ -11844,21 +11438,15 @@
                       </a:r>
                     </a:p>
                   </a:txBody>
-                  <a:tcPr anchor="ctr">
+                  <a:tcPr marL="91440" marR="91440" marT="45720" marB="45720" anchor="ctr">
                     <a:lnL w="0">
                       <a:noFill/>
                     </a:lnL>
                     <a:lnR w="0">
                       <a:noFill/>
                     </a:lnR>
-                    <a:lnT w="19050" cap="flat" cmpd="sng" algn="ctr">
-                      <a:solidFill>
-                        <a:srgbClr val="FFFFFF"/>
-                      </a:solidFill>
-                      <a:prstDash val="solid"/>
-                      <a:round/>
-                      <a:headEnd type="none" w="med" len="med"/>
-                      <a:tailEnd type="none" w="med" len="med"/>
+                    <a:lnT w="0">
+                      <a:noFill/>
                     </a:lnT>
                     <a:lnB w="19050" cmpd="sng">
                       <a:solidFill>
@@ -11872,7 +11460,7 @@
                 </a:tc>
                 <a:tc>
                   <a:txBody>
-                    <a:bodyPr/>
+                    <a:bodyPr wrap="square"/>
                     <a:lstStyle/>
                     <a:p>
                       <a:pPr algn="l"/>
@@ -11898,21 +11486,15 @@
                       </a:r>
                     </a:p>
                   </a:txBody>
-                  <a:tcPr anchor="ctr">
+                  <a:tcPr marL="91440" marR="91440" marT="45720" marB="45720" anchor="ctr">
                     <a:lnL w="0">
                       <a:noFill/>
                     </a:lnL>
                     <a:lnR w="0">
                       <a:noFill/>
                     </a:lnR>
-                    <a:lnT w="19050" cap="flat" cmpd="sng" algn="ctr">
-                      <a:solidFill>
-                        <a:srgbClr val="FFFFFF"/>
-                      </a:solidFill>
-                      <a:prstDash val="solid"/>
-                      <a:round/>
-                      <a:headEnd type="none" w="med" len="med"/>
-                      <a:tailEnd type="none" w="med" len="med"/>
+                    <a:lnT w="0">
+                      <a:noFill/>
                     </a:lnT>
                     <a:lnB w="19050" cmpd="sng">
                       <a:solidFill>
@@ -11926,7 +11508,7 @@
                 </a:tc>
                 <a:tc>
                   <a:txBody>
-                    <a:bodyPr/>
+                    <a:bodyPr wrap="square"/>
                     <a:lstStyle/>
                     <a:p>
                       <a:pPr algn="l"/>
@@ -11952,21 +11534,15 @@
                       </a:r>
                     </a:p>
                   </a:txBody>
-                  <a:tcPr anchor="ctr">
+                  <a:tcPr marL="91440" marR="91440" marT="45720" marB="45720" anchor="ctr">
                     <a:lnL w="0">
                       <a:noFill/>
                     </a:lnL>
                     <a:lnR w="0">
                       <a:noFill/>
                     </a:lnR>
-                    <a:lnT w="19050" cap="flat" cmpd="sng" algn="ctr">
-                      <a:solidFill>
-                        <a:srgbClr val="FFFFFF"/>
-                      </a:solidFill>
-                      <a:prstDash val="solid"/>
-                      <a:round/>
-                      <a:headEnd type="none" w="med" len="med"/>
-                      <a:tailEnd type="none" w="med" len="med"/>
+                    <a:lnT w="0">
+                      <a:noFill/>
                     </a:lnT>
                     <a:lnB w="19050" cmpd="sng">
                       <a:solidFill>
@@ -11978,16 +11554,11 @@
                     </a:solidFill>
                   </a:tcPr>
                 </a:tc>
-                <a:extLst>
-                  <a:ext uri="{0D108BD9-81ED-4DB2-BD59-A6C34878D82A}">
-                    <a16:rowId xmlns:a16="http://schemas.microsoft.com/office/drawing/2014/main" val="10002"/>
-                  </a:ext>
-                </a:extLst>
               </a:tr>
               <a:tr h="621792">
                 <a:tc>
                   <a:txBody>
-                    <a:bodyPr/>
+                    <a:bodyPr wrap="square"/>
                     <a:lstStyle/>
                     <a:p>
                       <a:pPr algn="l"/>
@@ -12003,21 +11574,15 @@
                       </a:r>
                     </a:p>
                   </a:txBody>
-                  <a:tcPr anchor="ctr">
+                  <a:tcPr marL="91440" marR="91440" marT="45720" marB="45720" anchor="ctr">
                     <a:lnL w="0">
                       <a:noFill/>
                     </a:lnL>
                     <a:lnR w="0">
                       <a:noFill/>
                     </a:lnR>
-                    <a:lnT w="19050" cap="flat" cmpd="sng" algn="ctr">
-                      <a:solidFill>
-                        <a:srgbClr val="FFFFFF"/>
-                      </a:solidFill>
-                      <a:prstDash val="solid"/>
-                      <a:round/>
-                      <a:headEnd type="none" w="med" len="med"/>
-                      <a:tailEnd type="none" w="med" len="med"/>
+                    <a:lnT w="0">
+                      <a:noFill/>
                     </a:lnT>
                     <a:lnB w="19050" cmpd="sng">
                       <a:solidFill>
@@ -12029,7 +11594,7 @@
                 </a:tc>
                 <a:tc>
                   <a:txBody>
-                    <a:bodyPr/>
+                    <a:bodyPr wrap="square"/>
                     <a:lstStyle/>
                     <a:p>
                       <a:pPr algn="l"/>
@@ -12045,21 +11610,15 @@
                       </a:r>
                     </a:p>
                   </a:txBody>
-                  <a:tcPr anchor="ctr">
+                  <a:tcPr marL="91440" marR="91440" marT="45720" marB="45720" anchor="ctr">
                     <a:lnL w="0">
                       <a:noFill/>
                     </a:lnL>
                     <a:lnR w="0">
                       <a:noFill/>
                     </a:lnR>
-                    <a:lnT w="19050" cap="flat" cmpd="sng" algn="ctr">
-                      <a:solidFill>
-                        <a:srgbClr val="FFFFFF"/>
-                      </a:solidFill>
-                      <a:prstDash val="solid"/>
-                      <a:round/>
-                      <a:headEnd type="none" w="med" len="med"/>
-                      <a:tailEnd type="none" w="med" len="med"/>
+                    <a:lnT w="0">
+                      <a:noFill/>
                     </a:lnT>
                     <a:lnB w="19050" cmpd="sng">
                       <a:solidFill>
@@ -12071,7 +11630,7 @@
                 </a:tc>
                 <a:tc>
                   <a:txBody>
-                    <a:bodyPr/>
+                    <a:bodyPr wrap="square"/>
                     <a:lstStyle/>
                     <a:p>
                       <a:pPr algn="l"/>
@@ -12097,21 +11656,15 @@
                       </a:r>
                     </a:p>
                   </a:txBody>
-                  <a:tcPr anchor="ctr">
+                  <a:tcPr marL="91440" marR="91440" marT="45720" marB="45720" anchor="ctr">
                     <a:lnL w="0">
                       <a:noFill/>
                     </a:lnL>
                     <a:lnR w="0">
                       <a:noFill/>
                     </a:lnR>
-                    <a:lnT w="19050" cap="flat" cmpd="sng" algn="ctr">
-                      <a:solidFill>
-                        <a:srgbClr val="FFFFFF"/>
-                      </a:solidFill>
-                      <a:prstDash val="solid"/>
-                      <a:round/>
-                      <a:headEnd type="none" w="med" len="med"/>
-                      <a:tailEnd type="none" w="med" len="med"/>
+                    <a:lnT w="0">
+                      <a:noFill/>
                     </a:lnT>
                     <a:lnB w="19050" cmpd="sng">
                       <a:solidFill>
@@ -12125,7 +11678,7 @@
                 </a:tc>
                 <a:tc>
                   <a:txBody>
-                    <a:bodyPr/>
+                    <a:bodyPr wrap="square"/>
                     <a:lstStyle/>
                     <a:p>
                       <a:pPr algn="l"/>
@@ -12151,21 +11704,15 @@
                       </a:r>
                     </a:p>
                   </a:txBody>
-                  <a:tcPr anchor="ctr">
+                  <a:tcPr marL="91440" marR="91440" marT="45720" marB="45720" anchor="ctr">
                     <a:lnL w="0">
                       <a:noFill/>
                     </a:lnL>
                     <a:lnR w="0">
                       <a:noFill/>
                     </a:lnR>
-                    <a:lnT w="19050" cap="flat" cmpd="sng" algn="ctr">
-                      <a:solidFill>
-                        <a:srgbClr val="FFFFFF"/>
-                      </a:solidFill>
-                      <a:prstDash val="solid"/>
-                      <a:round/>
-                      <a:headEnd type="none" w="med" len="med"/>
-                      <a:tailEnd type="none" w="med" len="med"/>
+                    <a:lnT w="0">
+                      <a:noFill/>
                     </a:lnT>
                     <a:lnB w="19050" cmpd="sng">
                       <a:solidFill>
@@ -12179,7 +11726,7 @@
                 </a:tc>
                 <a:tc>
                   <a:txBody>
-                    <a:bodyPr/>
+                    <a:bodyPr wrap="square"/>
                     <a:lstStyle/>
                     <a:p>
                       <a:pPr algn="l"/>
@@ -12205,21 +11752,15 @@
                       </a:r>
                     </a:p>
                   </a:txBody>
-                  <a:tcPr anchor="ctr">
+                  <a:tcPr marL="91440" marR="91440" marT="45720" marB="45720" anchor="ctr">
                     <a:lnL w="0">
                       <a:noFill/>
                     </a:lnL>
                     <a:lnR w="0">
                       <a:noFill/>
                     </a:lnR>
-                    <a:lnT w="19050" cap="flat" cmpd="sng" algn="ctr">
-                      <a:solidFill>
-                        <a:srgbClr val="FFFFFF"/>
-                      </a:solidFill>
-                      <a:prstDash val="solid"/>
-                      <a:round/>
-                      <a:headEnd type="none" w="med" len="med"/>
-                      <a:tailEnd type="none" w="med" len="med"/>
+                    <a:lnT w="0">
+                      <a:noFill/>
                     </a:lnT>
                     <a:lnB w="19050" cmpd="sng">
                       <a:solidFill>
@@ -12231,11 +11772,6 @@
                     </a:solidFill>
                   </a:tcPr>
                 </a:tc>
-                <a:extLst>
-                  <a:ext uri="{0D108BD9-81ED-4DB2-BD59-A6C34878D82A}">
-                    <a16:rowId xmlns:a16="http://schemas.microsoft.com/office/drawing/2014/main" val="10003"/>
-                  </a:ext>
-                </a:extLst>
               </a:tr>
             </a:tbl>
           </a:graphicData>
@@ -12258,7 +11794,7 @@
           <a:noFill/>
         </p:spPr>
         <p:txBody>
-          <a:bodyPr wrap="square" lIns="0" tIns="0" rIns="0" bIns="0" anchor="t"/>
+          <a:bodyPr wrap="square" lIns="0" rIns="0" tIns="0" bIns="0" anchor="t"/>
           <a:lstStyle/>
           <a:p>
             <a:pPr marL="182880" indent="-182880" algn="l">
@@ -12328,7 +11864,7 @@
 </file>
 
 <file path=ppt/slides/slide8.xml><?xml version="1.0" encoding="utf-8"?>
-<p:sld xmlns:a="http://schemas.openxmlformats.org/drawingml/2006/main" xmlns:r="http://schemas.openxmlformats.org/officeDocument/2006/relationships" xmlns:p="http://schemas.openxmlformats.org/presentationml/2006/main">
+<p:sld xmlns:a="http://schemas.openxmlformats.org/drawingml/2006/main" xmlns:p="http://schemas.openxmlformats.org/presentationml/2006/main" xmlns:r="http://schemas.openxmlformats.org/officeDocument/2006/relationships">
   <p:cSld>
     <p:spTree>
       <p:nvGrpSpPr>
@@ -12336,14 +11872,7 @@
         <p:cNvGrpSpPr/>
         <p:nvPr/>
       </p:nvGrpSpPr>
-      <p:grpSpPr>
-        <a:xfrm>
-          <a:off x="0" y="0"/>
-          <a:ext cx="0" cy="0"/>
-          <a:chOff x="0" y="0"/>
-          <a:chExt cx="0" cy="0"/>
-        </a:xfrm>
-      </p:grpSpPr>
+      <p:grpSpPr/>
       <p:sp>
         <p:nvSpPr>
           <p:cNvPr id="4" name="Text Placeholder 3"/>
@@ -12351,7 +11880,7 @@
             <a:spLocks noGrp="1"/>
           </p:cNvSpPr>
           <p:nvPr>
-            <p:ph type="body" sz="quarter" idx="10"/>
+            <p:ph type="body" idx="10" sz="quarter"/>
           </p:nvPr>
         </p:nvSpPr>
         <p:spPr>
@@ -12419,7 +11948,7 @@
             <a:fld id="{18A41853-EF22-D446-BDBC-A7CF3FE93503}" type="slidenum">
               <a:rPr lang="en-US" smtClean="0"/>
               <a:pPr/>
-              <a:t>8</a:t>
+              <a:t>‹#›</a:t>
             </a:fld>
             <a:endParaRPr lang="en-US" dirty="0"/>
           </a:p>
@@ -12442,7 +11971,7 @@
           <a:noFill/>
         </p:spPr>
         <p:txBody>
-          <a:bodyPr wrap="square" lIns="0" tIns="0" rIns="0" bIns="0" anchor="t"/>
+          <a:bodyPr wrap="square" lIns="0" rIns="0" tIns="0" bIns="0" anchor="t"/>
           <a:lstStyle/>
           <a:p>
             <a:pPr marL="0" indent="0" algn="l">
@@ -12479,43 +12008,34 @@
         <a:graphic>
           <a:graphicData uri="http://schemas.openxmlformats.org/drawingml/2006/table">
             <a:tbl>
-              <a:tblPr>
+              <a:tblPr firstRow="0" bandRow="0">
                 <a:tableStyleId>{2D5ABB26-0587-4C30-8999-92F81FD0307C}</a:tableStyleId>
               </a:tblPr>
               <a:tblGrid>
-                <a:gridCol w="2743200">
-                  <a:extLst>
-                    <a:ext uri="{9D8B030D-6E8A-4147-A177-3AD203B41FA5}">
-                      <a16:colId xmlns:a16="http://schemas.microsoft.com/office/drawing/2014/main" val="20000"/>
-                    </a:ext>
-                  </a:extLst>
-                </a:gridCol>
-                <a:gridCol w="4343400">
-                  <a:extLst>
-                    <a:ext uri="{9D8B030D-6E8A-4147-A177-3AD203B41FA5}">
-                      <a16:colId xmlns:a16="http://schemas.microsoft.com/office/drawing/2014/main" val="20001"/>
-                    </a:ext>
-                  </a:extLst>
-                </a:gridCol>
-                <a:gridCol w="4389120">
-                  <a:extLst>
-                    <a:ext uri="{9D8B030D-6E8A-4147-A177-3AD203B41FA5}">
-                      <a16:colId xmlns:a16="http://schemas.microsoft.com/office/drawing/2014/main" val="20002"/>
-                    </a:ext>
-                  </a:extLst>
-                </a:gridCol>
+                <a:gridCol w="2743200"/>
+                <a:gridCol w="4343400"/>
+                <a:gridCol w="4389120"/>
               </a:tblGrid>
               <a:tr h="548640">
                 <a:tc>
                   <a:txBody>
-                    <a:bodyPr/>
+                    <a:bodyPr wrap="square"/>
                     <a:lstStyle/>
                     <a:p>
                       <a:pPr algn="l"/>
-                      <a:endParaRPr/>
+                      <a:r>
+                        <a:rPr sz="1500" b="1" i="0">
+                          <a:solidFill>
+                            <a:srgbClr val="FFFFFF"/>
+                          </a:solidFill>
+                          <a:latin typeface="Arial"/>
+                          <a:ea typeface="Microsoft JhengHei"/>
+                        </a:rPr>
+                        <a:t/>
+                      </a:r>
                     </a:p>
                   </a:txBody>
-                  <a:tcPr anchor="ctr">
+                  <a:tcPr marL="91440" marR="91440" marT="45720" marB="45720" anchor="ctr">
                     <a:lnL w="0">
                       <a:noFill/>
                     </a:lnL>
@@ -12535,7 +12055,7 @@
                 </a:tc>
                 <a:tc>
                   <a:txBody>
-                    <a:bodyPr/>
+                    <a:bodyPr wrap="square"/>
                     <a:lstStyle/>
                     <a:p>
                       <a:pPr algn="l"/>
@@ -12551,7 +12071,7 @@
                       </a:r>
                     </a:p>
                   </a:txBody>
-                  <a:tcPr anchor="ctr">
+                  <a:tcPr marL="91440" marR="91440" marT="45720" marB="45720" anchor="ctr">
                     <a:lnL w="0">
                       <a:noFill/>
                     </a:lnL>
@@ -12571,7 +12091,7 @@
                 </a:tc>
                 <a:tc>
                   <a:txBody>
-                    <a:bodyPr/>
+                    <a:bodyPr wrap="square"/>
                     <a:lstStyle/>
                     <a:p>
                       <a:pPr algn="l"/>
@@ -12587,7 +12107,7 @@
                       </a:r>
                     </a:p>
                   </a:txBody>
-                  <a:tcPr anchor="ctr">
+                  <a:tcPr marL="91440" marR="91440" marT="45720" marB="45720" anchor="ctr">
                     <a:lnL w="0">
                       <a:noFill/>
                     </a:lnL>
@@ -12605,16 +12125,11 @@
                     </a:solidFill>
                   </a:tcPr>
                 </a:tc>
-                <a:extLst>
-                  <a:ext uri="{0D108BD9-81ED-4DB2-BD59-A6C34878D82A}">
-                    <a16:rowId xmlns:a16="http://schemas.microsoft.com/office/drawing/2014/main" val="10000"/>
-                  </a:ext>
-                </a:extLst>
               </a:tr>
               <a:tr h="512064">
                 <a:tc>
                   <a:txBody>
-                    <a:bodyPr/>
+                    <a:bodyPr wrap="square"/>
                     <a:lstStyle/>
                     <a:p>
                       <a:pPr algn="l"/>
@@ -12630,7 +12145,7 @@
                       </a:r>
                     </a:p>
                   </a:txBody>
-                  <a:tcPr anchor="ctr">
+                  <a:tcPr marL="91440" marR="91440" marT="45720" marB="45720" anchor="ctr">
                     <a:lnL w="0">
                       <a:noFill/>
                     </a:lnL>
@@ -12650,7 +12165,7 @@
                 </a:tc>
                 <a:tc>
                   <a:txBody>
-                    <a:bodyPr/>
+                    <a:bodyPr wrap="square"/>
                     <a:lstStyle/>
                     <a:p>
                       <a:pPr algn="l"/>
@@ -12666,7 +12181,7 @@
                       </a:r>
                     </a:p>
                   </a:txBody>
-                  <a:tcPr anchor="ctr">
+                  <a:tcPr marL="91440" marR="91440" marT="45720" marB="45720" anchor="ctr">
                     <a:lnL w="0">
                       <a:noFill/>
                     </a:lnL>
@@ -12686,7 +12201,7 @@
                 </a:tc>
                 <a:tc>
                   <a:txBody>
-                    <a:bodyPr/>
+                    <a:bodyPr wrap="square"/>
                     <a:lstStyle/>
                     <a:p>
                       <a:pPr algn="l"/>
@@ -12702,7 +12217,7 @@
                       </a:r>
                     </a:p>
                   </a:txBody>
-                  <a:tcPr anchor="ctr">
+                  <a:tcPr marL="91440" marR="91440" marT="45720" marB="45720" anchor="ctr">
                     <a:lnL w="0">
                       <a:noFill/>
                     </a:lnL>
@@ -12720,16 +12235,11 @@
                     <a:noFill/>
                   </a:tcPr>
                 </a:tc>
-                <a:extLst>
-                  <a:ext uri="{0D108BD9-81ED-4DB2-BD59-A6C34878D82A}">
-                    <a16:rowId xmlns:a16="http://schemas.microsoft.com/office/drawing/2014/main" val="10001"/>
-                  </a:ext>
-                </a:extLst>
               </a:tr>
               <a:tr h="512064">
                 <a:tc>
                   <a:txBody>
-                    <a:bodyPr/>
+                    <a:bodyPr wrap="square"/>
                     <a:lstStyle/>
                     <a:p>
                       <a:pPr algn="l"/>
@@ -12745,21 +12255,15 @@
                       </a:r>
                     </a:p>
                   </a:txBody>
-                  <a:tcPr anchor="ctr">
+                  <a:tcPr marL="91440" marR="91440" marT="45720" marB="45720" anchor="ctr">
                     <a:lnL w="0">
                       <a:noFill/>
                     </a:lnL>
                     <a:lnR w="0">
                       <a:noFill/>
                     </a:lnR>
-                    <a:lnT w="9525" cap="flat" cmpd="sng" algn="ctr">
-                      <a:solidFill>
-                        <a:srgbClr val="BFBFBF"/>
-                      </a:solidFill>
-                      <a:prstDash val="solid"/>
-                      <a:round/>
-                      <a:headEnd type="none" w="med" len="med"/>
-                      <a:tailEnd type="none" w="med" len="med"/>
+                    <a:lnT w="0">
+                      <a:noFill/>
                     </a:lnT>
                     <a:lnB w="9525" cmpd="sng">
                       <a:solidFill>
@@ -12771,7 +12275,7 @@
                 </a:tc>
                 <a:tc>
                   <a:txBody>
-                    <a:bodyPr/>
+                    <a:bodyPr wrap="square"/>
                     <a:lstStyle/>
                     <a:p>
                       <a:pPr algn="l"/>
@@ -12787,21 +12291,15 @@
                       </a:r>
                     </a:p>
                   </a:txBody>
-                  <a:tcPr anchor="ctr">
+                  <a:tcPr marL="91440" marR="91440" marT="45720" marB="45720" anchor="ctr">
                     <a:lnL w="0">
                       <a:noFill/>
                     </a:lnL>
                     <a:lnR w="0">
                       <a:noFill/>
                     </a:lnR>
-                    <a:lnT w="9525" cap="flat" cmpd="sng" algn="ctr">
-                      <a:solidFill>
-                        <a:srgbClr val="BFBFBF"/>
-                      </a:solidFill>
-                      <a:prstDash val="solid"/>
-                      <a:round/>
-                      <a:headEnd type="none" w="med" len="med"/>
-                      <a:tailEnd type="none" w="med" len="med"/>
+                    <a:lnT w="0">
+                      <a:noFill/>
                     </a:lnT>
                     <a:lnB w="9525" cmpd="sng">
                       <a:solidFill>
@@ -12813,7 +12311,7 @@
                 </a:tc>
                 <a:tc>
                   <a:txBody>
-                    <a:bodyPr/>
+                    <a:bodyPr wrap="square"/>
                     <a:lstStyle/>
                     <a:p>
                       <a:pPr algn="l"/>
@@ -12829,21 +12327,15 @@
                       </a:r>
                     </a:p>
                   </a:txBody>
-                  <a:tcPr anchor="ctr">
+                  <a:tcPr marL="91440" marR="91440" marT="45720" marB="45720" anchor="ctr">
                     <a:lnL w="0">
                       <a:noFill/>
                     </a:lnL>
                     <a:lnR w="0">
                       <a:noFill/>
                     </a:lnR>
-                    <a:lnT w="9525" cap="flat" cmpd="sng" algn="ctr">
-                      <a:solidFill>
-                        <a:srgbClr val="BFBFBF"/>
-                      </a:solidFill>
-                      <a:prstDash val="solid"/>
-                      <a:round/>
-                      <a:headEnd type="none" w="med" len="med"/>
-                      <a:tailEnd type="none" w="med" len="med"/>
+                    <a:lnT w="0">
+                      <a:noFill/>
                     </a:lnT>
                     <a:lnB w="9525" cmpd="sng">
                       <a:solidFill>
@@ -12853,16 +12345,11 @@
                     <a:noFill/>
                   </a:tcPr>
                 </a:tc>
-                <a:extLst>
-                  <a:ext uri="{0D108BD9-81ED-4DB2-BD59-A6C34878D82A}">
-                    <a16:rowId xmlns:a16="http://schemas.microsoft.com/office/drawing/2014/main" val="10002"/>
-                  </a:ext>
-                </a:extLst>
               </a:tr>
               <a:tr h="512064">
                 <a:tc>
                   <a:txBody>
-                    <a:bodyPr/>
+                    <a:bodyPr wrap="square"/>
                     <a:lstStyle/>
                     <a:p>
                       <a:pPr algn="l"/>
@@ -12878,21 +12365,15 @@
                       </a:r>
                     </a:p>
                   </a:txBody>
-                  <a:tcPr anchor="ctr">
+                  <a:tcPr marL="91440" marR="91440" marT="45720" marB="45720" anchor="ctr">
                     <a:lnL w="0">
                       <a:noFill/>
                     </a:lnL>
                     <a:lnR w="0">
                       <a:noFill/>
                     </a:lnR>
-                    <a:lnT w="9525" cap="flat" cmpd="sng" algn="ctr">
-                      <a:solidFill>
-                        <a:srgbClr val="BFBFBF"/>
-                      </a:solidFill>
-                      <a:prstDash val="solid"/>
-                      <a:round/>
-                      <a:headEnd type="none" w="med" len="med"/>
-                      <a:tailEnd type="none" w="med" len="med"/>
+                    <a:lnT w="0">
+                      <a:noFill/>
                     </a:lnT>
                     <a:lnB w="9525" cmpd="sng">
                       <a:solidFill>
@@ -12904,7 +12385,7 @@
                 </a:tc>
                 <a:tc>
                   <a:txBody>
-                    <a:bodyPr/>
+                    <a:bodyPr wrap="square"/>
                     <a:lstStyle/>
                     <a:p>
                       <a:pPr algn="l"/>
@@ -12920,21 +12401,15 @@
                       </a:r>
                     </a:p>
                   </a:txBody>
-                  <a:tcPr anchor="ctr">
+                  <a:tcPr marL="91440" marR="91440" marT="45720" marB="45720" anchor="ctr">
                     <a:lnL w="0">
                       <a:noFill/>
                     </a:lnL>
                     <a:lnR w="0">
                       <a:noFill/>
                     </a:lnR>
-                    <a:lnT w="9525" cap="flat" cmpd="sng" algn="ctr">
-                      <a:solidFill>
-                        <a:srgbClr val="BFBFBF"/>
-                      </a:solidFill>
-                      <a:prstDash val="solid"/>
-                      <a:round/>
-                      <a:headEnd type="none" w="med" len="med"/>
-                      <a:tailEnd type="none" w="med" len="med"/>
+                    <a:lnT w="0">
+                      <a:noFill/>
                     </a:lnT>
                     <a:lnB w="9525" cmpd="sng">
                       <a:solidFill>
@@ -12946,7 +12421,7 @@
                 </a:tc>
                 <a:tc>
                   <a:txBody>
-                    <a:bodyPr/>
+                    <a:bodyPr wrap="square"/>
                     <a:lstStyle/>
                     <a:p>
                       <a:pPr algn="l"/>
@@ -12962,21 +12437,15 @@
                       </a:r>
                     </a:p>
                   </a:txBody>
-                  <a:tcPr anchor="ctr">
+                  <a:tcPr marL="91440" marR="91440" marT="45720" marB="45720" anchor="ctr">
                     <a:lnL w="0">
                       <a:noFill/>
                     </a:lnL>
                     <a:lnR w="0">
                       <a:noFill/>
                     </a:lnR>
-                    <a:lnT w="9525" cap="flat" cmpd="sng" algn="ctr">
-                      <a:solidFill>
-                        <a:srgbClr val="BFBFBF"/>
-                      </a:solidFill>
-                      <a:prstDash val="solid"/>
-                      <a:round/>
-                      <a:headEnd type="none" w="med" len="med"/>
-                      <a:tailEnd type="none" w="med" len="med"/>
+                    <a:lnT w="0">
+                      <a:noFill/>
                     </a:lnT>
                     <a:lnB w="9525" cmpd="sng">
                       <a:solidFill>
@@ -12986,16 +12455,11 @@
                     <a:noFill/>
                   </a:tcPr>
                 </a:tc>
-                <a:extLst>
-                  <a:ext uri="{0D108BD9-81ED-4DB2-BD59-A6C34878D82A}">
-                    <a16:rowId xmlns:a16="http://schemas.microsoft.com/office/drawing/2014/main" val="10003"/>
-                  </a:ext>
-                </a:extLst>
               </a:tr>
               <a:tr h="512064">
                 <a:tc>
                   <a:txBody>
-                    <a:bodyPr/>
+                    <a:bodyPr wrap="square"/>
                     <a:lstStyle/>
                     <a:p>
                       <a:pPr algn="l"/>
@@ -13011,21 +12475,15 @@
                       </a:r>
                     </a:p>
                   </a:txBody>
-                  <a:tcPr anchor="ctr">
+                  <a:tcPr marL="91440" marR="91440" marT="45720" marB="45720" anchor="ctr">
                     <a:lnL w="0">
                       <a:noFill/>
                     </a:lnL>
                     <a:lnR w="0">
                       <a:noFill/>
                     </a:lnR>
-                    <a:lnT w="9525" cap="flat" cmpd="sng" algn="ctr">
-                      <a:solidFill>
-                        <a:srgbClr val="BFBFBF"/>
-                      </a:solidFill>
-                      <a:prstDash val="solid"/>
-                      <a:round/>
-                      <a:headEnd type="none" w="med" len="med"/>
-                      <a:tailEnd type="none" w="med" len="med"/>
+                    <a:lnT w="0">
+                      <a:noFill/>
                     </a:lnT>
                     <a:lnB w="9525" cmpd="sng">
                       <a:solidFill>
@@ -13037,7 +12495,7 @@
                 </a:tc>
                 <a:tc>
                   <a:txBody>
-                    <a:bodyPr/>
+                    <a:bodyPr wrap="square"/>
                     <a:lstStyle/>
                     <a:p>
                       <a:pPr algn="l"/>
@@ -13053,21 +12511,15 @@
                       </a:r>
                     </a:p>
                   </a:txBody>
-                  <a:tcPr anchor="ctr">
+                  <a:tcPr marL="91440" marR="91440" marT="45720" marB="45720" anchor="ctr">
                     <a:lnL w="0">
                       <a:noFill/>
                     </a:lnL>
                     <a:lnR w="0">
                       <a:noFill/>
                     </a:lnR>
-                    <a:lnT w="9525" cap="flat" cmpd="sng" algn="ctr">
-                      <a:solidFill>
-                        <a:srgbClr val="BFBFBF"/>
-                      </a:solidFill>
-                      <a:prstDash val="solid"/>
-                      <a:round/>
-                      <a:headEnd type="none" w="med" len="med"/>
-                      <a:tailEnd type="none" w="med" len="med"/>
+                    <a:lnT w="0">
+                      <a:noFill/>
                     </a:lnT>
                     <a:lnB w="9525" cmpd="sng">
                       <a:solidFill>
@@ -13079,7 +12531,7 @@
                 </a:tc>
                 <a:tc>
                   <a:txBody>
-                    <a:bodyPr/>
+                    <a:bodyPr wrap="square"/>
                     <a:lstStyle/>
                     <a:p>
                       <a:pPr algn="l"/>
@@ -13095,21 +12547,15 @@
                       </a:r>
                     </a:p>
                   </a:txBody>
-                  <a:tcPr anchor="ctr">
+                  <a:tcPr marL="91440" marR="91440" marT="45720" marB="45720" anchor="ctr">
                     <a:lnL w="0">
                       <a:noFill/>
                     </a:lnL>
                     <a:lnR w="0">
                       <a:noFill/>
                     </a:lnR>
-                    <a:lnT w="9525" cap="flat" cmpd="sng" algn="ctr">
-                      <a:solidFill>
-                        <a:srgbClr val="BFBFBF"/>
-                      </a:solidFill>
-                      <a:prstDash val="solid"/>
-                      <a:round/>
-                      <a:headEnd type="none" w="med" len="med"/>
-                      <a:tailEnd type="none" w="med" len="med"/>
+                    <a:lnT w="0">
+                      <a:noFill/>
                     </a:lnT>
                     <a:lnB w="9525" cmpd="sng">
                       <a:solidFill>
@@ -13119,16 +12565,11 @@
                     <a:noFill/>
                   </a:tcPr>
                 </a:tc>
-                <a:extLst>
-                  <a:ext uri="{0D108BD9-81ED-4DB2-BD59-A6C34878D82A}">
-                    <a16:rowId xmlns:a16="http://schemas.microsoft.com/office/drawing/2014/main" val="10004"/>
-                  </a:ext>
-                </a:extLst>
               </a:tr>
               <a:tr h="512064">
                 <a:tc>
                   <a:txBody>
-                    <a:bodyPr/>
+                    <a:bodyPr wrap="square"/>
                     <a:lstStyle/>
                     <a:p>
                       <a:pPr algn="l"/>
@@ -13144,21 +12585,15 @@
                       </a:r>
                     </a:p>
                   </a:txBody>
-                  <a:tcPr anchor="ctr">
+                  <a:tcPr marL="91440" marR="91440" marT="45720" marB="45720" anchor="ctr">
                     <a:lnL w="0">
                       <a:noFill/>
                     </a:lnL>
                     <a:lnR w="0">
                       <a:noFill/>
                     </a:lnR>
-                    <a:lnT w="9525" cap="flat" cmpd="sng" algn="ctr">
-                      <a:solidFill>
-                        <a:srgbClr val="BFBFBF"/>
-                      </a:solidFill>
-                      <a:prstDash val="solid"/>
-                      <a:round/>
-                      <a:headEnd type="none" w="med" len="med"/>
-                      <a:tailEnd type="none" w="med" len="med"/>
+                    <a:lnT w="0">
+                      <a:noFill/>
                     </a:lnT>
                     <a:lnB w="9525" cmpd="sng">
                       <a:solidFill>
@@ -13170,7 +12605,7 @@
                 </a:tc>
                 <a:tc>
                   <a:txBody>
-                    <a:bodyPr/>
+                    <a:bodyPr wrap="square"/>
                     <a:lstStyle/>
                     <a:p>
                       <a:pPr algn="l"/>
@@ -13186,21 +12621,15 @@
                       </a:r>
                     </a:p>
                   </a:txBody>
-                  <a:tcPr anchor="ctr">
+                  <a:tcPr marL="91440" marR="91440" marT="45720" marB="45720" anchor="ctr">
                     <a:lnL w="0">
                       <a:noFill/>
                     </a:lnL>
                     <a:lnR w="0">
                       <a:noFill/>
                     </a:lnR>
-                    <a:lnT w="9525" cap="flat" cmpd="sng" algn="ctr">
-                      <a:solidFill>
-                        <a:srgbClr val="BFBFBF"/>
-                      </a:solidFill>
-                      <a:prstDash val="solid"/>
-                      <a:round/>
-                      <a:headEnd type="none" w="med" len="med"/>
-                      <a:tailEnd type="none" w="med" len="med"/>
+                    <a:lnT w="0">
+                      <a:noFill/>
                     </a:lnT>
                     <a:lnB w="9525" cmpd="sng">
                       <a:solidFill>
@@ -13212,7 +12641,7 @@
                 </a:tc>
                 <a:tc>
                   <a:txBody>
-                    <a:bodyPr/>
+                    <a:bodyPr wrap="square"/>
                     <a:lstStyle/>
                     <a:p>
                       <a:pPr algn="l"/>
@@ -13228,21 +12657,15 @@
                       </a:r>
                     </a:p>
                   </a:txBody>
-                  <a:tcPr anchor="ctr">
+                  <a:tcPr marL="91440" marR="91440" marT="45720" marB="45720" anchor="ctr">
                     <a:lnL w="0">
                       <a:noFill/>
                     </a:lnL>
                     <a:lnR w="0">
                       <a:noFill/>
                     </a:lnR>
-                    <a:lnT w="9525" cap="flat" cmpd="sng" algn="ctr">
-                      <a:solidFill>
-                        <a:srgbClr val="BFBFBF"/>
-                      </a:solidFill>
-                      <a:prstDash val="solid"/>
-                      <a:round/>
-                      <a:headEnd type="none" w="med" len="med"/>
-                      <a:tailEnd type="none" w="med" len="med"/>
+                    <a:lnT w="0">
+                      <a:noFill/>
                     </a:lnT>
                     <a:lnB w="9525" cmpd="sng">
                       <a:solidFill>
@@ -13252,16 +12675,11 @@
                     <a:noFill/>
                   </a:tcPr>
                 </a:tc>
-                <a:extLst>
-                  <a:ext uri="{0D108BD9-81ED-4DB2-BD59-A6C34878D82A}">
-                    <a16:rowId xmlns:a16="http://schemas.microsoft.com/office/drawing/2014/main" val="10005"/>
-                  </a:ext>
-                </a:extLst>
               </a:tr>
               <a:tr h="512064">
                 <a:tc>
                   <a:txBody>
-                    <a:bodyPr/>
+                    <a:bodyPr wrap="square"/>
                     <a:lstStyle/>
                     <a:p>
                       <a:pPr algn="l"/>
@@ -13277,21 +12695,15 @@
                       </a:r>
                     </a:p>
                   </a:txBody>
-                  <a:tcPr anchor="ctr">
+                  <a:tcPr marL="91440" marR="91440" marT="45720" marB="45720" anchor="ctr">
                     <a:lnL w="0">
                       <a:noFill/>
                     </a:lnL>
                     <a:lnR w="0">
                       <a:noFill/>
                     </a:lnR>
-                    <a:lnT w="9525" cap="flat" cmpd="sng" algn="ctr">
-                      <a:solidFill>
-                        <a:srgbClr val="BFBFBF"/>
-                      </a:solidFill>
-                      <a:prstDash val="solid"/>
-                      <a:round/>
-                      <a:headEnd type="none" w="med" len="med"/>
-                      <a:tailEnd type="none" w="med" len="med"/>
+                    <a:lnT w="0">
+                      <a:noFill/>
                     </a:lnT>
                     <a:lnB w="9525" cmpd="sng">
                       <a:solidFill>
@@ -13303,7 +12715,7 @@
                 </a:tc>
                 <a:tc>
                   <a:txBody>
-                    <a:bodyPr/>
+                    <a:bodyPr wrap="square"/>
                     <a:lstStyle/>
                     <a:p>
                       <a:pPr algn="l"/>
@@ -13319,21 +12731,15 @@
                       </a:r>
                     </a:p>
                   </a:txBody>
-                  <a:tcPr anchor="ctr">
+                  <a:tcPr marL="91440" marR="91440" marT="45720" marB="45720" anchor="ctr">
                     <a:lnL w="0">
                       <a:noFill/>
                     </a:lnL>
                     <a:lnR w="0">
                       <a:noFill/>
                     </a:lnR>
-                    <a:lnT w="9525" cap="flat" cmpd="sng" algn="ctr">
-                      <a:solidFill>
-                        <a:srgbClr val="BFBFBF"/>
-                      </a:solidFill>
-                      <a:prstDash val="solid"/>
-                      <a:round/>
-                      <a:headEnd type="none" w="med" len="med"/>
-                      <a:tailEnd type="none" w="med" len="med"/>
+                    <a:lnT w="0">
+                      <a:noFill/>
                     </a:lnT>
                     <a:lnB w="9525" cmpd="sng">
                       <a:solidFill>
@@ -13345,7 +12751,7 @@
                 </a:tc>
                 <a:tc>
                   <a:txBody>
-                    <a:bodyPr/>
+                    <a:bodyPr wrap="square"/>
                     <a:lstStyle/>
                     <a:p>
                       <a:pPr algn="l"/>
@@ -13361,21 +12767,15 @@
                       </a:r>
                     </a:p>
                   </a:txBody>
-                  <a:tcPr anchor="ctr">
+                  <a:tcPr marL="91440" marR="91440" marT="45720" marB="45720" anchor="ctr">
                     <a:lnL w="0">
                       <a:noFill/>
                     </a:lnL>
                     <a:lnR w="0">
                       <a:noFill/>
                     </a:lnR>
-                    <a:lnT w="9525" cap="flat" cmpd="sng" algn="ctr">
-                      <a:solidFill>
-                        <a:srgbClr val="BFBFBF"/>
-                      </a:solidFill>
-                      <a:prstDash val="solid"/>
-                      <a:round/>
-                      <a:headEnd type="none" w="med" len="med"/>
-                      <a:tailEnd type="none" w="med" len="med"/>
+                    <a:lnT w="0">
+                      <a:noFill/>
                     </a:lnT>
                     <a:lnB w="9525" cmpd="sng">
                       <a:solidFill>
@@ -13385,11 +12785,6 @@
                     <a:noFill/>
                   </a:tcPr>
                 </a:tc>
-                <a:extLst>
-                  <a:ext uri="{0D108BD9-81ED-4DB2-BD59-A6C34878D82A}">
-                    <a16:rowId xmlns:a16="http://schemas.microsoft.com/office/drawing/2014/main" val="10006"/>
-                  </a:ext>
-                </a:extLst>
               </a:tr>
             </a:tbl>
           </a:graphicData>
@@ -13412,7 +12807,7 @@
           <a:noFill/>
         </p:spPr>
         <p:txBody>
-          <a:bodyPr wrap="square" lIns="0" tIns="0" rIns="0" bIns="0" anchor="t"/>
+          <a:bodyPr wrap="square" lIns="0" rIns="0" tIns="0" bIns="0" anchor="t"/>
           <a:lstStyle/>
           <a:p>
             <a:pPr marL="0" indent="0" algn="l">
@@ -13443,7 +12838,7 @@
 </file>
 
 <file path=ppt/slides/slide9.xml><?xml version="1.0" encoding="utf-8"?>
-<p:sld xmlns:a="http://schemas.openxmlformats.org/drawingml/2006/main" xmlns:r="http://schemas.openxmlformats.org/officeDocument/2006/relationships" xmlns:p="http://schemas.openxmlformats.org/presentationml/2006/main">
+<p:sld xmlns:a="http://schemas.openxmlformats.org/drawingml/2006/main" xmlns:p="http://schemas.openxmlformats.org/presentationml/2006/main" xmlns:r="http://schemas.openxmlformats.org/officeDocument/2006/relationships">
   <p:cSld>
     <p:spTree>
       <p:nvGrpSpPr>
@@ -13451,14 +12846,7 @@
         <p:cNvGrpSpPr/>
         <p:nvPr/>
       </p:nvGrpSpPr>
-      <p:grpSpPr>
-        <a:xfrm>
-          <a:off x="0" y="0"/>
-          <a:ext cx="0" cy="0"/>
-          <a:chOff x="0" y="0"/>
-          <a:chExt cx="0" cy="0"/>
-        </a:xfrm>
-      </p:grpSpPr>
+      <p:grpSpPr/>
       <p:sp>
         <p:nvSpPr>
           <p:cNvPr id="4" name="Text Placeholder 3"/>
@@ -13466,7 +12854,7 @@
             <a:spLocks noGrp="1"/>
           </p:cNvSpPr>
           <p:nvPr>
-            <p:ph type="body" sz="quarter" idx="10"/>
+            <p:ph type="body" idx="10" sz="quarter"/>
           </p:nvPr>
         </p:nvSpPr>
         <p:spPr>
@@ -13534,7 +12922,7 @@
             <a:fld id="{18A41853-EF22-D446-BDBC-A7CF3FE93503}" type="slidenum">
               <a:rPr lang="en-US" smtClean="0"/>
               <a:pPr/>
-              <a:t>9</a:t>
+              <a:t>‹#›</a:t>
             </a:fld>
             <a:endParaRPr lang="en-US" dirty="0"/>
           </a:p>
@@ -13557,7 +12945,7 @@
           <a:noFill/>
         </p:spPr>
         <p:txBody>
-          <a:bodyPr wrap="square" lIns="0" tIns="0" rIns="0" bIns="0" anchor="t"/>
+          <a:bodyPr wrap="square" lIns="0" rIns="0" tIns="0" bIns="0" anchor="t"/>
           <a:lstStyle/>
           <a:p>
             <a:pPr marL="0" indent="0" algn="l">
@@ -13574,7 +12962,7 @@
                 <a:latin typeface="Arial"/>
                 <a:ea typeface="Microsoft JhengHei"/>
               </a:rPr>
-              <a:t>Both reached 88.2%. Points marked "Measured" come from this benchmark; the rest are expected, not yet tested.</a:t>
+              <a:t>Both reached 88.2%, AOAI with no prompt changes. "Measured" = this benchmark; the rest is expected.</a:t>
             </a:r>
           </a:p>
         </p:txBody>
@@ -13601,7 +12989,46 @@
           </a:ln>
         </p:spPr>
         <p:txBody>
-          <a:bodyPr wrap="square" lIns="164592" tIns="109728" rIns="164592" bIns="109728" rtlCol="0" anchor="ctr"/>
+          <a:bodyPr rtlCol="0" anchor="ctr" wrap="square" lIns="164592" rIns="164592" tIns="109728" bIns="109728"/>
+          <a:lstStyle/>
+          <a:p>
+            <a:pPr algn="l" marL="0" indent="0">
+              <a:spcAft>
+                <a:spcPts val="0"/>
+              </a:spcAft>
+              <a:buNone/>
+            </a:pPr>
+            <a:r>
+              <a:rPr sz="1600" b="1" i="0">
+                <a:solidFill>
+                  <a:srgbClr val="FFFFFF"/>
+                </a:solidFill>
+                <a:latin typeface="Arial"/>
+                <a:ea typeface="Microsoft JhengHei"/>
+              </a:rPr>
+              <a:t>Pure OCR + Rules (PaddleOCR Light)</a:t>
+            </a:r>
+          </a:p>
+        </p:txBody>
+      </p:sp>
+      <p:sp>
+        <p:nvSpPr>
+          <p:cNvPr id="13" name="TextBox 12"/>
+          <p:cNvSpPr txBox="1"/>
+          <p:nvPr/>
+        </p:nvSpPr>
+        <p:spPr>
+          <a:xfrm>
+            <a:off x="356616" y="2267712"/>
+            <a:ext cx="5600700" cy="566928"/>
+          </a:xfrm>
+          <a:prstGeom prst="rect">
+            <a:avLst/>
+          </a:prstGeom>
+          <a:noFill/>
+        </p:spPr>
+        <p:txBody>
+          <a:bodyPr wrap="square" lIns="0" rIns="0" tIns="0" bIns="0" anchor="ctr"/>
           <a:lstStyle/>
           <a:p>
             <a:pPr marL="0" indent="0" algn="l">
@@ -13611,28 +13038,28 @@
               <a:buNone/>
             </a:pPr>
             <a:r>
-              <a:rPr sz="1600" b="1" i="0">
-                <a:solidFill>
-                  <a:srgbClr val="FFFFFF"/>
+              <a:rPr sz="1300" b="1" i="0">
+                <a:solidFill>
+                  <a:srgbClr val="333D47"/>
                 </a:solidFill>
                 <a:latin typeface="Arial"/>
                 <a:ea typeface="Microsoft JhengHei"/>
               </a:rPr>
-              <a:t>Pure OCR + Rules (PaddleOCR Light)</a:t>
+              <a:t>New formats may need manual rule updates, which can break working cases and add maintenance and testing.</a:t>
             </a:r>
           </a:p>
         </p:txBody>
       </p:sp>
       <p:sp>
         <p:nvSpPr>
-          <p:cNvPr id="13" name="Rectangle 12"/>
+          <p:cNvPr id="14" name="Rectangle 13"/>
           <p:cNvSpPr/>
           <p:nvPr/>
         </p:nvSpPr>
         <p:spPr>
           <a:xfrm>
-            <a:off x="356616" y="2286000"/>
-            <a:ext cx="5600700" cy="1527048"/>
+            <a:off x="356616" y="2907792"/>
+            <a:ext cx="5600700" cy="1225296"/>
           </a:xfrm>
           <a:prstGeom prst="rect">
             <a:avLst/>
@@ -13645,10 +13072,10 @@
           </a:ln>
         </p:spPr>
         <p:txBody>
-          <a:bodyPr wrap="square" lIns="164592" tIns="109728" rIns="164592" bIns="109728" rtlCol="0" anchor="t"/>
+          <a:bodyPr rtlCol="0" anchor="t" wrap="square" lIns="164592" rIns="164592" tIns="109728" bIns="109728"/>
           <a:lstStyle/>
           <a:p>
-            <a:pPr marL="0" indent="0" algn="l">
+            <a:pPr algn="l" marL="0" indent="0">
               <a:spcAft>
                 <a:spcPts val="400"/>
               </a:spcAft>
@@ -13674,14 +13101,24 @@
               <a:buChar char="•"/>
             </a:pPr>
             <a:r>
-              <a:rPr sz="1300" b="0" i="0">
+              <a:rPr sz="1300" b="1" i="0">
                 <a:solidFill>
                   <a:srgbClr val="333D47"/>
                 </a:solidFill>
                 <a:latin typeface="Arial"/>
                 <a:ea typeface="Microsoft JhengHei"/>
               </a:rPr>
-              <a:t>Full control over the extraction logic.</a:t>
+              <a:t>Measured: </a:t>
+            </a:r>
+            <a:r>
+              <a:rPr sz="1300" b="0" i="0">
+                <a:solidFill>
+                  <a:srgbClr val="333D47"/>
+                </a:solidFill>
+                <a:latin typeface="Arial"/>
+                <a:ea typeface="Microsoft JhengHei"/>
+              </a:rPr>
+              <a:t>88.2% after manual rule tuning (from 37.3%).</a:t>
             </a:r>
           </a:p>
           <a:p>
@@ -13700,26 +13137,7 @@
                 <a:latin typeface="Arial"/>
                 <a:ea typeface="Microsoft JhengHei"/>
               </a:rPr>
-              <a:t>No API fees: open-source OCR on our own compute.</a:t>
-            </a:r>
-          </a:p>
-          <a:p>
-            <a:pPr marL="182880" indent="-182880" algn="l">
-              <a:spcAft>
-                <a:spcPts val="300"/>
-              </a:spcAft>
-              <a:buFont typeface="Arial"/>
-              <a:buChar char="•"/>
-            </a:pPr>
-            <a:r>
-              <a:rPr sz="1300" b="0" i="0">
-                <a:solidFill>
-                  <a:srgbClr val="333D47"/>
-                </a:solidFill>
-                <a:latin typeface="Arial"/>
-                <a:ea typeface="Microsoft JhengHei"/>
-              </a:rPr>
-              <a:t>Predictable on receipt formats the rules already know.</a:t>
+              <a:t>Full control; predictable on formats the rules know.</a:t>
             </a:r>
           </a:p>
           <a:p>
@@ -13731,38 +13149,28 @@
               <a:buChar char="•"/>
             </a:pPr>
             <a:r>
-              <a:rPr sz="1300" b="1" i="0">
+              <a:rPr sz="1300" b="0" i="0">
                 <a:solidFill>
                   <a:srgbClr val="333D47"/>
                 </a:solidFill>
                 <a:latin typeface="Arial"/>
                 <a:ea typeface="Microsoft JhengHei"/>
               </a:rPr>
-              <a:t>Measured: </a:t>
-            </a:r>
-            <a:r>
-              <a:rPr sz="1300" b="0" i="0">
-                <a:solidFill>
-                  <a:srgbClr val="333D47"/>
-                </a:solidFill>
-                <a:latin typeface="Arial"/>
-                <a:ea typeface="Microsoft JhengHei"/>
-              </a:rPr>
-              <a:t>88.2% after careful tuning (from 37.3%).</a:t>
+              <a:t>No API fees: open-source OCR on our own compute.</a:t>
             </a:r>
           </a:p>
         </p:txBody>
       </p:sp>
       <p:sp>
         <p:nvSpPr>
-          <p:cNvPr id="14" name="Rectangle 13"/>
+          <p:cNvPr id="15" name="Rectangle 14"/>
           <p:cNvSpPr/>
           <p:nvPr/>
         </p:nvSpPr>
         <p:spPr>
           <a:xfrm>
-            <a:off x="356616" y="3886200"/>
-            <a:ext cx="5600700" cy="1527048"/>
+            <a:off x="356616" y="4206240"/>
+            <a:ext cx="5600700" cy="1225296"/>
           </a:xfrm>
           <a:prstGeom prst="rect">
             <a:avLst/>
@@ -13775,10 +13183,10 @@
           </a:ln>
         </p:spPr>
         <p:txBody>
-          <a:bodyPr wrap="square" lIns="164592" tIns="109728" rIns="164592" bIns="109728" rtlCol="0" anchor="t"/>
+          <a:bodyPr rtlCol="0" anchor="t" wrap="square" lIns="164592" rIns="164592" tIns="109728" bIns="109728"/>
           <a:lstStyle/>
           <a:p>
-            <a:pPr marL="0" indent="0" algn="l">
+            <a:pPr algn="l" marL="0" indent="0">
               <a:spcAft>
                 <a:spcPts val="400"/>
               </a:spcAft>
@@ -13804,24 +13212,14 @@
               <a:buChar char="•"/>
             </a:pPr>
             <a:r>
-              <a:rPr sz="1300" b="1" i="0">
+              <a:rPr sz="1300" b="0" i="0">
                 <a:solidFill>
                   <a:srgbClr val="333D47"/>
                 </a:solidFill>
                 <a:latin typeface="Arial"/>
                 <a:ea typeface="Microsoft JhengHei"/>
               </a:rPr>
-              <a:t>Measured: </a:t>
-            </a:r>
-            <a:r>
-              <a:rPr sz="1300" b="0" i="0">
-                <a:solidFill>
-                  <a:srgbClr val="333D47"/>
-                </a:solidFill>
-                <a:latin typeface="Arial"/>
-                <a:ea typeface="Microsoft JhengHei"/>
-              </a:rPr>
-              <a:t>rules expanded by hand (69 → 225 label phrases).</a:t>
+              <a:t>New formats and layouts may need rule updates by hand.</a:t>
             </a:r>
           </a:p>
           <a:p>
@@ -13833,25 +13231,6 @@
               <a:buChar char="•"/>
             </a:pPr>
             <a:r>
-              <a:rPr sz="1300" b="0" i="0">
-                <a:solidFill>
-                  <a:srgbClr val="333D47"/>
-                </a:solidFill>
-                <a:latin typeface="Arial"/>
-                <a:ea typeface="Microsoft JhengHei"/>
-              </a:rPr>
-              <a:t>New languages, labels and layouts need more rule changes.</a:t>
-            </a:r>
-          </a:p>
-          <a:p>
-            <a:pPr marL="182880" indent="-182880" algn="l">
-              <a:spcAft>
-                <a:spcPts val="300"/>
-              </a:spcAft>
-              <a:buFont typeface="Arial"/>
-              <a:buChar char="•"/>
-            </a:pPr>
-            <a:r>
               <a:rPr sz="1300" b="1" i="0">
                 <a:solidFill>
                   <a:srgbClr val="333D47"/>
@@ -13869,7 +13248,7 @@
                 <a:latin typeface="Arial"/>
                 <a:ea typeface="Microsoft JhengHei"/>
               </a:rPr>
-              <a:t>a rule update broke a receipt that was already correct.</a:t>
+              <a:t>a rule change broke a receipt that was already correct.</a:t>
             </a:r>
           </a:p>
           <a:p>
@@ -13881,21 +13260,31 @@
               <a:buChar char="•"/>
             </a:pPr>
             <a:r>
-              <a:rPr sz="1300" b="0" i="0">
+              <a:rPr sz="1300" b="1" i="0">
                 <a:solidFill>
                   <a:srgbClr val="333D47"/>
                 </a:solidFill>
                 <a:latin typeface="Arial"/>
                 <a:ea typeface="Microsoft JhengHei"/>
               </a:rPr>
-              <a:t>Accuracy on unseen receipt formats is unknown.</a:t>
+              <a:t>Measured: </a:t>
+            </a:r>
+            <a:r>
+              <a:rPr sz="1300" b="0" i="0">
+                <a:solidFill>
+                  <a:srgbClr val="333D47"/>
+                </a:solidFill>
+                <a:latin typeface="Arial"/>
+                <a:ea typeface="Microsoft JhengHei"/>
+              </a:rPr>
+              <a:t>rules grew from 69 to 225 label phrases.</a:t>
             </a:r>
           </a:p>
         </p:txBody>
       </p:sp>
       <p:sp>
         <p:nvSpPr>
-          <p:cNvPr id="15" name="Rectangle 14"/>
+          <p:cNvPr id="16" name="Rectangle 15"/>
           <p:cNvSpPr/>
           <p:nvPr/>
         </p:nvSpPr>
@@ -13915,7 +13304,46 @@
           </a:ln>
         </p:spPr>
         <p:txBody>
-          <a:bodyPr wrap="square" lIns="164592" tIns="109728" rIns="164592" bIns="109728" rtlCol="0" anchor="ctr"/>
+          <a:bodyPr rtlCol="0" anchor="ctr" wrap="square" lIns="164592" rIns="164592" tIns="109728" bIns="109728"/>
+          <a:lstStyle/>
+          <a:p>
+            <a:pPr algn="l" marL="0" indent="0">
+              <a:spcAft>
+                <a:spcPts val="0"/>
+              </a:spcAft>
+              <a:buNone/>
+            </a:pPr>
+            <a:r>
+              <a:rPr sz="1600" b="1" i="0">
+                <a:solidFill>
+                  <a:srgbClr val="FFFFFF"/>
+                </a:solidFill>
+                <a:latin typeface="Arial"/>
+                <a:ea typeface="Microsoft JhengHei"/>
+              </a:rPr>
+              <a:t>Azure DI + AOAI</a:t>
+            </a:r>
+          </a:p>
+        </p:txBody>
+      </p:sp>
+      <p:sp>
+        <p:nvSpPr>
+          <p:cNvPr id="17" name="TextBox 16"/>
+          <p:cNvSpPr txBox="1"/>
+          <p:nvPr/>
+        </p:nvSpPr>
+        <p:spPr>
+          <a:xfrm>
+            <a:off x="6231636" y="2267712"/>
+            <a:ext cx="5600700" cy="566928"/>
+          </a:xfrm>
+          <a:prstGeom prst="rect">
+            <a:avLst/>
+          </a:prstGeom>
+          <a:noFill/>
+        </p:spPr>
+        <p:txBody>
+          <a:bodyPr wrap="square" lIns="0" rIns="0" tIns="0" bIns="0" anchor="ctr"/>
           <a:lstStyle/>
           <a:p>
             <a:pPr marL="0" indent="0" algn="l">
@@ -13925,28 +13353,28 @@
               <a:buNone/>
             </a:pPr>
             <a:r>
-              <a:rPr sz="1600" b="1" i="0">
-                <a:solidFill>
-                  <a:srgbClr val="FFFFFF"/>
+              <a:rPr sz="1300" b="1" i="0">
+                <a:solidFill>
+                  <a:srgbClr val="333D47"/>
                 </a:solidFill>
                 <a:latin typeface="Arial"/>
                 <a:ea typeface="Microsoft JhengHei"/>
               </a:rPr>
-              <a:t>Azure DI + AOAI</a:t>
+              <a:t>Less rule maintenance expected: accuracy depends mainly on the AI model, OCR output and prompt.</a:t>
             </a:r>
           </a:p>
         </p:txBody>
       </p:sp>
       <p:sp>
         <p:nvSpPr>
-          <p:cNvPr id="16" name="Rectangle 15"/>
+          <p:cNvPr id="18" name="Rectangle 17"/>
           <p:cNvSpPr/>
           <p:nvPr/>
         </p:nvSpPr>
         <p:spPr>
           <a:xfrm>
-            <a:off x="6231636" y="2286000"/>
-            <a:ext cx="5600700" cy="1527048"/>
+            <a:off x="6231636" y="2907792"/>
+            <a:ext cx="5600700" cy="1225296"/>
           </a:xfrm>
           <a:prstGeom prst="rect">
             <a:avLst/>
@@ -13959,10 +13387,10 @@
           </a:ln>
         </p:spPr>
         <p:txBody>
-          <a:bodyPr wrap="square" lIns="164592" tIns="109728" rIns="164592" bIns="109728" rtlCol="0" anchor="t"/>
+          <a:bodyPr rtlCol="0" anchor="t" wrap="square" lIns="164592" rIns="164592" tIns="109728" bIns="109728"/>
           <a:lstStyle/>
           <a:p>
-            <a:pPr marL="0" indent="0" algn="l">
+            <a:pPr algn="l" marL="0" indent="0">
               <a:spcAft>
                 <a:spcPts val="400"/>
               </a:spcAft>
@@ -14005,7 +13433,7 @@
                 <a:latin typeface="Arial"/>
                 <a:ea typeface="Microsoft JhengHei"/>
               </a:rPr>
-              <a:t>88.2% with the prompt unchanged.</a:t>
+              <a:t>88.2% with no prompt changes.</a:t>
             </a:r>
           </a:p>
           <a:p>
@@ -14024,36 +13452,7 @@
                 <a:latin typeface="Arial"/>
                 <a:ea typeface="Microsoft JhengHei"/>
               </a:rPr>
-              <a:t>Reduces the need to write detailed extraction rules.</a:t>
-            </a:r>
-          </a:p>
-          <a:p>
-            <a:pPr marL="182880" indent="-182880" algn="l">
-              <a:spcAft>
-                <a:spcPts val="300"/>
-              </a:spcAft>
-              <a:buFont typeface="Arial"/>
-              <a:buChar char="•"/>
-            </a:pPr>
-            <a:r>
-              <a:rPr sz="1300" b="1" i="0">
-                <a:solidFill>
-                  <a:srgbClr val="333D47"/>
-                </a:solidFill>
-                <a:latin typeface="Arial"/>
-                <a:ea typeface="Microsoft JhengHei"/>
-              </a:rPr>
-              <a:t>Measured: </a:t>
-            </a:r>
-            <a:r>
-              <a:rPr sz="1300" b="0" i="0">
-                <a:solidFill>
-                  <a:srgbClr val="333D47"/>
-                </a:solidFill>
-                <a:latin typeface="Arial"/>
-                <a:ea typeface="Microsoft JhengHei"/>
-              </a:rPr>
-              <a:t>6/6 fields on both the bilingual and Chinese examples.</a:t>
+              <a:t>Reads varied formats using existing model capabilities.</a:t>
             </a:r>
           </a:p>
           <a:p>
@@ -14089,14 +13488,14 @@
       </p:sp>
       <p:sp>
         <p:nvSpPr>
-          <p:cNvPr id="17" name="Rectangle 16"/>
+          <p:cNvPr id="19" name="Rectangle 18"/>
           <p:cNvSpPr/>
           <p:nvPr/>
         </p:nvSpPr>
         <p:spPr>
           <a:xfrm>
-            <a:off x="6231636" y="3886200"/>
-            <a:ext cx="5600700" cy="1527048"/>
+            <a:off x="6231636" y="4206240"/>
+            <a:ext cx="5600700" cy="1225296"/>
           </a:xfrm>
           <a:prstGeom prst="rect">
             <a:avLst/>
@@ -14109,17 +13508,17 @@
           </a:ln>
         </p:spPr>
         <p:txBody>
-          <a:bodyPr wrap="square" lIns="164592" tIns="109728" rIns="164592" bIns="109728" rtlCol="0" anchor="t"/>
+          <a:bodyPr rtlCol="0" anchor="t" wrap="square" lIns="164592" rIns="164592" tIns="109728" bIns="109728"/>
           <a:lstStyle/>
           <a:p>
-            <a:pPr marL="0" indent="0" algn="l">
+            <a:pPr algn="l" marL="0" indent="0">
               <a:spcAft>
                 <a:spcPts val="400"/>
               </a:spcAft>
               <a:buNone/>
             </a:pPr>
             <a:r>
-              <a:rPr sz="1500" b="1" i="0" dirty="0">
+              <a:rPr sz="1500" b="1" i="0">
                 <a:solidFill>
                   <a:srgbClr val="D31145"/>
                 </a:solidFill>
@@ -14138,14 +13537,24 @@
               <a:buChar char="•"/>
             </a:pPr>
             <a:r>
-              <a:rPr sz="1300" b="0" i="0" dirty="0">
+              <a:rPr sz="1300" b="1" i="0">
                 <a:solidFill>
                   <a:srgbClr val="333D47"/>
                 </a:solidFill>
                 <a:latin typeface="Arial"/>
                 <a:ea typeface="Microsoft JhengHei"/>
               </a:rPr>
-              <a:t>Needs Azure services and per-request API fees.</a:t>
+              <a:t>Measured: </a:t>
+            </a:r>
+            <a:r>
+              <a:rPr sz="1300" b="0" i="0">
+                <a:solidFill>
+                  <a:srgbClr val="333D47"/>
+                </a:solidFill>
+                <a:latin typeface="Arial"/>
+                <a:ea typeface="Microsoft JhengHei"/>
+              </a:rPr>
+              <a:t>still wrong on 6 of 51 fields, e.g. a total.</a:t>
             </a:r>
           </a:p>
           <a:p>
@@ -14157,50 +13566,40 @@
               <a:buChar char="•"/>
             </a:pPr>
             <a:r>
-              <a:rPr sz="1300" b="1" i="0" dirty="0">
+              <a:rPr sz="1300" b="0" i="0">
                 <a:solidFill>
                   <a:srgbClr val="333D47"/>
                 </a:solidFill>
                 <a:latin typeface="Arial"/>
                 <a:ea typeface="Microsoft JhengHei"/>
               </a:rPr>
-              <a:t>Measured: </a:t>
-            </a:r>
-            <a:r>
-              <a:rPr sz="1300" b="0" i="0" dirty="0">
-                <a:solidFill>
-                  <a:srgbClr val="333D47"/>
-                </a:solidFill>
-                <a:latin typeface="Arial"/>
-                <a:ea typeface="Microsoft JhengHei"/>
-              </a:rPr>
-              <a:t>wrong value even though the OCR text was correct.</a:t>
+              <a:t>Less direct control: results depend on model, OCR, prompt.</a:t>
             </a:r>
           </a:p>
           <a:p>
             <a:pPr marL="182880" indent="-182880" algn="l">
               <a:spcAft>
-                <a:spcPts val="300"/>
+                <a:spcPts val="0"/>
               </a:spcAft>
               <a:buFont typeface="Arial"/>
               <a:buChar char="•"/>
             </a:pPr>
             <a:r>
-              <a:rPr sz="1300" b="0" i="0" dirty="0">
+              <a:rPr sz="1300" b="0" i="0">
                 <a:solidFill>
                   <a:srgbClr val="333D47"/>
                 </a:solidFill>
                 <a:latin typeface="Arial"/>
                 <a:ea typeface="Microsoft JhengHei"/>
               </a:rPr>
-              <a:t>Results may vary, so validation and error handling are needed.</a:t>
+              <a:t>API fees; needs validation, monitoring and prompt upkeep.</a:t>
             </a:r>
           </a:p>
         </p:txBody>
       </p:sp>
       <p:sp>
         <p:nvSpPr>
-          <p:cNvPr id="18" name="Rectangle 17"/>
+          <p:cNvPr id="20" name="Rectangle 19"/>
           <p:cNvSpPr/>
           <p:nvPr/>
         </p:nvSpPr>
@@ -14220,10 +13619,10 @@
           </a:ln>
         </p:spPr>
         <p:txBody>
-          <a:bodyPr wrap="square" lIns="164592" tIns="109728" rIns="164592" bIns="109728" rtlCol="0" anchor="ctr"/>
+          <a:bodyPr rtlCol="0" anchor="ctr" wrap="square" lIns="164592" rIns="164592" tIns="109728" bIns="109728"/>
           <a:lstStyle/>
           <a:p>
-            <a:pPr marL="0" indent="0" algn="l">
+            <a:pPr algn="l" marL="0" indent="0">
               <a:spcAft>
                 <a:spcPts val="0"/>
               </a:spcAft>
@@ -14237,7 +13636,7 @@
                 <a:latin typeface="Arial"/>
                 <a:ea typeface="Microsoft JhengHei"/>
               </a:rPr>
-              <a:t>The decision is not only accuracy or API cost: </a:t>
+              <a:t>Both reach 88.2% here. </a:t>
             </a:r>
             <a:r>
               <a:rPr sz="1400" b="0" i="0">
@@ -14247,7 +13646,7 @@
                 <a:latin typeface="Arial"/>
                 <a:ea typeface="Microsoft JhengHei"/>
               </a:rPr>
-              <a:t>it is how much development and ongoing maintenance we want to own.</a:t>
+              <a:t>The difference is where the maintenance effort sits, and how much of it we own.</a:t>
             </a:r>
           </a:p>
         </p:txBody>

</xml_diff>